<commit_message>
fix(motion): configure presenter click sequencing as default mode for in-slide cards
</commit_message>
<xml_diff>
--- a/Du An/A Tuan Dan So/Bai 1. Nhap mon DSH - Dark.pptx
+++ b/Du An/A Tuan Dan So/Bai 1. Nhap mon DSH - Dark.pptx
@@ -142,7 +142,7 @@
           <p:cNvPr id="2" name="Title 1">
             <a:extLst>
               <a:ext uri="{FF2B5EF4-FFF2-40B4-BE49-F238E27FC236}">
-                <a16:creationId xmlns:a16="http://schemas.microsoft.com/office/drawing/2014/main" id="{EA1BA91A-0EB9-E0C2-084C-44EA3BACA74A}"/>
+                <a16:creationId xmlns:a16="http://schemas.microsoft.com/office/drawing/2014/main" id="{9FF5CBEE-8E31-EA3A-D270-C3C473C2D853}"/>
               </a:ext>
             </a:extLst>
           </p:cNvPr>
@@ -179,7 +179,7 @@
           <p:cNvPr id="3" name="Subtitle 2">
             <a:extLst>
               <a:ext uri="{FF2B5EF4-FFF2-40B4-BE49-F238E27FC236}">
-                <a16:creationId xmlns:a16="http://schemas.microsoft.com/office/drawing/2014/main" id="{C46F00E4-1D56-50DB-AA1D-7A0293AF8AB8}"/>
+                <a16:creationId xmlns:a16="http://schemas.microsoft.com/office/drawing/2014/main" id="{978F26FE-AB63-1639-1878-6E15E916C536}"/>
               </a:ext>
             </a:extLst>
           </p:cNvPr>
@@ -249,7 +249,7 @@
           <p:cNvPr id="4" name="Date Placeholder 3">
             <a:extLst>
               <a:ext uri="{FF2B5EF4-FFF2-40B4-BE49-F238E27FC236}">
-                <a16:creationId xmlns:a16="http://schemas.microsoft.com/office/drawing/2014/main" id="{B623BA84-BFCB-F9C6-1126-302DBDF0994E}"/>
+                <a16:creationId xmlns:a16="http://schemas.microsoft.com/office/drawing/2014/main" id="{807CE603-9C11-2440-25A4-934C37A3C277}"/>
               </a:ext>
             </a:extLst>
           </p:cNvPr>
@@ -265,7 +265,7 @@
           <a:bodyPr/>
           <a:lstStyle/>
           <a:p>
-            <a:fld id="{A7719A36-783A-425C-B6FC-5643BEA553F5}" type="datetimeFigureOut">
+            <a:fld id="{AE1EB108-E25E-41A5-B3DD-045838C88DEA}" type="datetimeFigureOut">
               <a:rPr lang="en-US" smtClean="0"/>
               <a:t>9/18/2026</a:t>
             </a:fld>
@@ -278,7 +278,7 @@
           <p:cNvPr id="5" name="Footer Placeholder 4">
             <a:extLst>
               <a:ext uri="{FF2B5EF4-FFF2-40B4-BE49-F238E27FC236}">
-                <a16:creationId xmlns:a16="http://schemas.microsoft.com/office/drawing/2014/main" id="{0CFCB4EA-D3B9-B1B0-DB85-20A30F39A648}"/>
+                <a16:creationId xmlns:a16="http://schemas.microsoft.com/office/drawing/2014/main" id="{F610B40C-6B80-DCB1-25FA-75AD3D240379}"/>
               </a:ext>
             </a:extLst>
           </p:cNvPr>
@@ -303,7 +303,7 @@
           <p:cNvPr id="6" name="Slide Number Placeholder 5">
             <a:extLst>
               <a:ext uri="{FF2B5EF4-FFF2-40B4-BE49-F238E27FC236}">
-                <a16:creationId xmlns:a16="http://schemas.microsoft.com/office/drawing/2014/main" id="{9C90A26A-727C-6E95-6EF9-0868BC531760}"/>
+                <a16:creationId xmlns:a16="http://schemas.microsoft.com/office/drawing/2014/main" id="{02858AF8-C462-7671-8960-979DD768D030}"/>
               </a:ext>
             </a:extLst>
           </p:cNvPr>
@@ -319,7 +319,7 @@
           <a:bodyPr/>
           <a:lstStyle/>
           <a:p>
-            <a:fld id="{11B7EAB8-895B-4396-84A9-DA5337866697}" type="slidenum">
+            <a:fld id="{3E968F7E-64B4-4319-BA52-44084D8B6E1C}" type="slidenum">
               <a:rPr lang="en-US" smtClean="0"/>
               <a:t>‹#›</a:t>
             </a:fld>
@@ -330,7 +330,7 @@
     </p:spTree>
     <p:extLst>
       <p:ext uri="{BB962C8B-B14F-4D97-AF65-F5344CB8AC3E}">
-        <p14:creationId xmlns:p14="http://schemas.microsoft.com/office/powerpoint/2010/main" val="2131480288"/>
+        <p14:creationId xmlns:p14="http://schemas.microsoft.com/office/powerpoint/2010/main" val="240782937"/>
       </p:ext>
     </p:extLst>
   </p:cSld>
@@ -362,7 +362,7 @@
           <p:cNvPr id="2" name="Title 1">
             <a:extLst>
               <a:ext uri="{FF2B5EF4-FFF2-40B4-BE49-F238E27FC236}">
-                <a16:creationId xmlns:a16="http://schemas.microsoft.com/office/drawing/2014/main" id="{30D1DAD4-11FF-F18B-D574-2740F1CF0CE9}"/>
+                <a16:creationId xmlns:a16="http://schemas.microsoft.com/office/drawing/2014/main" id="{FF491793-D32A-3BF3-6844-CD1DF2D689A2}"/>
               </a:ext>
             </a:extLst>
           </p:cNvPr>
@@ -390,7 +390,7 @@
           <p:cNvPr id="3" name="Vertical Text Placeholder 2">
             <a:extLst>
               <a:ext uri="{FF2B5EF4-FFF2-40B4-BE49-F238E27FC236}">
-                <a16:creationId xmlns:a16="http://schemas.microsoft.com/office/drawing/2014/main" id="{619788D0-A753-E17D-0D21-6BD71DAFB39C}"/>
+                <a16:creationId xmlns:a16="http://schemas.microsoft.com/office/drawing/2014/main" id="{3DA6C8E8-0D3D-10B8-2FC4-F91434752C27}"/>
               </a:ext>
             </a:extLst>
           </p:cNvPr>
@@ -447,7 +447,7 @@
           <p:cNvPr id="4" name="Date Placeholder 3">
             <a:extLst>
               <a:ext uri="{FF2B5EF4-FFF2-40B4-BE49-F238E27FC236}">
-                <a16:creationId xmlns:a16="http://schemas.microsoft.com/office/drawing/2014/main" id="{A12B0476-71E4-CD6B-4FF6-5089241D2263}"/>
+                <a16:creationId xmlns:a16="http://schemas.microsoft.com/office/drawing/2014/main" id="{BD758A7F-95B9-D592-EA4A-4357945EC962}"/>
               </a:ext>
             </a:extLst>
           </p:cNvPr>
@@ -463,7 +463,7 @@
           <a:bodyPr/>
           <a:lstStyle/>
           <a:p>
-            <a:fld id="{A7719A36-783A-425C-B6FC-5643BEA553F5}" type="datetimeFigureOut">
+            <a:fld id="{AE1EB108-E25E-41A5-B3DD-045838C88DEA}" type="datetimeFigureOut">
               <a:rPr lang="en-US" smtClean="0"/>
               <a:t>9/18/2026</a:t>
             </a:fld>
@@ -476,7 +476,7 @@
           <p:cNvPr id="5" name="Footer Placeholder 4">
             <a:extLst>
               <a:ext uri="{FF2B5EF4-FFF2-40B4-BE49-F238E27FC236}">
-                <a16:creationId xmlns:a16="http://schemas.microsoft.com/office/drawing/2014/main" id="{DAC95AFC-B6BE-9A2C-BE1E-E3DD07B29B25}"/>
+                <a16:creationId xmlns:a16="http://schemas.microsoft.com/office/drawing/2014/main" id="{14364AC3-3B22-3DE2-36D5-538012847111}"/>
               </a:ext>
             </a:extLst>
           </p:cNvPr>
@@ -501,7 +501,7 @@
           <p:cNvPr id="6" name="Slide Number Placeholder 5">
             <a:extLst>
               <a:ext uri="{FF2B5EF4-FFF2-40B4-BE49-F238E27FC236}">
-                <a16:creationId xmlns:a16="http://schemas.microsoft.com/office/drawing/2014/main" id="{D405CBBD-E3AF-E6CB-D779-79B3FFBA3256}"/>
+                <a16:creationId xmlns:a16="http://schemas.microsoft.com/office/drawing/2014/main" id="{7D57407E-96EA-1240-9F06-200BE748458A}"/>
               </a:ext>
             </a:extLst>
           </p:cNvPr>
@@ -517,7 +517,7 @@
           <a:bodyPr/>
           <a:lstStyle/>
           <a:p>
-            <a:fld id="{11B7EAB8-895B-4396-84A9-DA5337866697}" type="slidenum">
+            <a:fld id="{3E968F7E-64B4-4319-BA52-44084D8B6E1C}" type="slidenum">
               <a:rPr lang="en-US" smtClean="0"/>
               <a:t>‹#›</a:t>
             </a:fld>
@@ -528,7 +528,7 @@
     </p:spTree>
     <p:extLst>
       <p:ext uri="{BB962C8B-B14F-4D97-AF65-F5344CB8AC3E}">
-        <p14:creationId xmlns:p14="http://schemas.microsoft.com/office/powerpoint/2010/main" val="3478585353"/>
+        <p14:creationId xmlns:p14="http://schemas.microsoft.com/office/powerpoint/2010/main" val="339967967"/>
       </p:ext>
     </p:extLst>
   </p:cSld>
@@ -560,7 +560,7 @@
           <p:cNvPr id="2" name="Vertical Title 1">
             <a:extLst>
               <a:ext uri="{FF2B5EF4-FFF2-40B4-BE49-F238E27FC236}">
-                <a16:creationId xmlns:a16="http://schemas.microsoft.com/office/drawing/2014/main" id="{24443FC2-029B-9825-638C-11A8679A4D02}"/>
+                <a16:creationId xmlns:a16="http://schemas.microsoft.com/office/drawing/2014/main" id="{161EED10-A7B7-867D-905B-1FE84832FF09}"/>
               </a:ext>
             </a:extLst>
           </p:cNvPr>
@@ -593,7 +593,7 @@
           <p:cNvPr id="3" name="Vertical Text Placeholder 2">
             <a:extLst>
               <a:ext uri="{FF2B5EF4-FFF2-40B4-BE49-F238E27FC236}">
-                <a16:creationId xmlns:a16="http://schemas.microsoft.com/office/drawing/2014/main" id="{9B56CD19-5694-61B1-16F8-23157DB4F4CD}"/>
+                <a16:creationId xmlns:a16="http://schemas.microsoft.com/office/drawing/2014/main" id="{1FD9A51A-1891-A64A-CEFC-BBF64A0619B8}"/>
               </a:ext>
             </a:extLst>
           </p:cNvPr>
@@ -655,7 +655,7 @@
           <p:cNvPr id="4" name="Date Placeholder 3">
             <a:extLst>
               <a:ext uri="{FF2B5EF4-FFF2-40B4-BE49-F238E27FC236}">
-                <a16:creationId xmlns:a16="http://schemas.microsoft.com/office/drawing/2014/main" id="{D09CDB5D-8E82-F204-A380-753B567F5BB7}"/>
+                <a16:creationId xmlns:a16="http://schemas.microsoft.com/office/drawing/2014/main" id="{2670ACC2-1E62-4837-1CD1-7D870D26276E}"/>
               </a:ext>
             </a:extLst>
           </p:cNvPr>
@@ -671,7 +671,7 @@
           <a:bodyPr/>
           <a:lstStyle/>
           <a:p>
-            <a:fld id="{A7719A36-783A-425C-B6FC-5643BEA553F5}" type="datetimeFigureOut">
+            <a:fld id="{AE1EB108-E25E-41A5-B3DD-045838C88DEA}" type="datetimeFigureOut">
               <a:rPr lang="en-US" smtClean="0"/>
               <a:t>9/18/2026</a:t>
             </a:fld>
@@ -684,7 +684,7 @@
           <p:cNvPr id="5" name="Footer Placeholder 4">
             <a:extLst>
               <a:ext uri="{FF2B5EF4-FFF2-40B4-BE49-F238E27FC236}">
-                <a16:creationId xmlns:a16="http://schemas.microsoft.com/office/drawing/2014/main" id="{D430610B-6A3D-ABAC-DA86-DD8EA06468AF}"/>
+                <a16:creationId xmlns:a16="http://schemas.microsoft.com/office/drawing/2014/main" id="{E8F1B88F-F4C0-18C7-C2DB-8EF278C8C5E3}"/>
               </a:ext>
             </a:extLst>
           </p:cNvPr>
@@ -709,7 +709,7 @@
           <p:cNvPr id="6" name="Slide Number Placeholder 5">
             <a:extLst>
               <a:ext uri="{FF2B5EF4-FFF2-40B4-BE49-F238E27FC236}">
-                <a16:creationId xmlns:a16="http://schemas.microsoft.com/office/drawing/2014/main" id="{076C88BB-AD07-FFBE-46E4-3BC8FFC1422D}"/>
+                <a16:creationId xmlns:a16="http://schemas.microsoft.com/office/drawing/2014/main" id="{9D00E220-B70D-67C9-0E2D-79C09900BBA4}"/>
               </a:ext>
             </a:extLst>
           </p:cNvPr>
@@ -725,7 +725,7 @@
           <a:bodyPr/>
           <a:lstStyle/>
           <a:p>
-            <a:fld id="{11B7EAB8-895B-4396-84A9-DA5337866697}" type="slidenum">
+            <a:fld id="{3E968F7E-64B4-4319-BA52-44084D8B6E1C}" type="slidenum">
               <a:rPr lang="en-US" smtClean="0"/>
               <a:t>‹#›</a:t>
             </a:fld>
@@ -736,7 +736,7 @@
     </p:spTree>
     <p:extLst>
       <p:ext uri="{BB962C8B-B14F-4D97-AF65-F5344CB8AC3E}">
-        <p14:creationId xmlns:p14="http://schemas.microsoft.com/office/powerpoint/2010/main" val="107498109"/>
+        <p14:creationId xmlns:p14="http://schemas.microsoft.com/office/powerpoint/2010/main" val="3338971258"/>
       </p:ext>
     </p:extLst>
   </p:cSld>
@@ -768,7 +768,7 @@
           <p:cNvPr id="2" name="Title 1">
             <a:extLst>
               <a:ext uri="{FF2B5EF4-FFF2-40B4-BE49-F238E27FC236}">
-                <a16:creationId xmlns:a16="http://schemas.microsoft.com/office/drawing/2014/main" id="{20E8F8D6-C827-B68F-D260-E130C5B1A2A3}"/>
+                <a16:creationId xmlns:a16="http://schemas.microsoft.com/office/drawing/2014/main" id="{0EFA5D07-0C2F-BFB2-8496-B7BDAC64E20D}"/>
               </a:ext>
             </a:extLst>
           </p:cNvPr>
@@ -796,7 +796,7 @@
           <p:cNvPr id="3" name="Content Placeholder 2">
             <a:extLst>
               <a:ext uri="{FF2B5EF4-FFF2-40B4-BE49-F238E27FC236}">
-                <a16:creationId xmlns:a16="http://schemas.microsoft.com/office/drawing/2014/main" id="{02E26038-4758-C180-CD7D-3C8D519A80DC}"/>
+                <a16:creationId xmlns:a16="http://schemas.microsoft.com/office/drawing/2014/main" id="{B0D82316-8A14-98EC-B2FA-16CE11F9221E}"/>
               </a:ext>
             </a:extLst>
           </p:cNvPr>
@@ -853,7 +853,7 @@
           <p:cNvPr id="4" name="Date Placeholder 3">
             <a:extLst>
               <a:ext uri="{FF2B5EF4-FFF2-40B4-BE49-F238E27FC236}">
-                <a16:creationId xmlns:a16="http://schemas.microsoft.com/office/drawing/2014/main" id="{A78D03FE-5D89-0544-7AA7-144F24EB93EC}"/>
+                <a16:creationId xmlns:a16="http://schemas.microsoft.com/office/drawing/2014/main" id="{311A68E4-F625-6616-B552-0311BA1BB873}"/>
               </a:ext>
             </a:extLst>
           </p:cNvPr>
@@ -869,7 +869,7 @@
           <a:bodyPr/>
           <a:lstStyle/>
           <a:p>
-            <a:fld id="{A7719A36-783A-425C-B6FC-5643BEA553F5}" type="datetimeFigureOut">
+            <a:fld id="{AE1EB108-E25E-41A5-B3DD-045838C88DEA}" type="datetimeFigureOut">
               <a:rPr lang="en-US" smtClean="0"/>
               <a:t>9/18/2026</a:t>
             </a:fld>
@@ -882,7 +882,7 @@
           <p:cNvPr id="5" name="Footer Placeholder 4">
             <a:extLst>
               <a:ext uri="{FF2B5EF4-FFF2-40B4-BE49-F238E27FC236}">
-                <a16:creationId xmlns:a16="http://schemas.microsoft.com/office/drawing/2014/main" id="{03B0AD5A-2DAF-BB5F-925F-53DBE1D0A967}"/>
+                <a16:creationId xmlns:a16="http://schemas.microsoft.com/office/drawing/2014/main" id="{AB4F7223-6CAA-52F9-54C9-CDFB8658E6B1}"/>
               </a:ext>
             </a:extLst>
           </p:cNvPr>
@@ -907,7 +907,7 @@
           <p:cNvPr id="6" name="Slide Number Placeholder 5">
             <a:extLst>
               <a:ext uri="{FF2B5EF4-FFF2-40B4-BE49-F238E27FC236}">
-                <a16:creationId xmlns:a16="http://schemas.microsoft.com/office/drawing/2014/main" id="{7FAD920F-DC08-18E1-132B-71B84AE00FE1}"/>
+                <a16:creationId xmlns:a16="http://schemas.microsoft.com/office/drawing/2014/main" id="{B9740AF9-8646-BF60-27C2-B9762749A6F1}"/>
               </a:ext>
             </a:extLst>
           </p:cNvPr>
@@ -923,7 +923,7 @@
           <a:bodyPr/>
           <a:lstStyle/>
           <a:p>
-            <a:fld id="{11B7EAB8-895B-4396-84A9-DA5337866697}" type="slidenum">
+            <a:fld id="{3E968F7E-64B4-4319-BA52-44084D8B6E1C}" type="slidenum">
               <a:rPr lang="en-US" smtClean="0"/>
               <a:t>‹#›</a:t>
             </a:fld>
@@ -934,7 +934,7 @@
     </p:spTree>
     <p:extLst>
       <p:ext uri="{BB962C8B-B14F-4D97-AF65-F5344CB8AC3E}">
-        <p14:creationId xmlns:p14="http://schemas.microsoft.com/office/powerpoint/2010/main" val="2140164769"/>
+        <p14:creationId xmlns:p14="http://schemas.microsoft.com/office/powerpoint/2010/main" val="2288148091"/>
       </p:ext>
     </p:extLst>
   </p:cSld>
@@ -966,7 +966,7 @@
           <p:cNvPr id="2" name="Title 1">
             <a:extLst>
               <a:ext uri="{FF2B5EF4-FFF2-40B4-BE49-F238E27FC236}">
-                <a16:creationId xmlns:a16="http://schemas.microsoft.com/office/drawing/2014/main" id="{2C6F00D1-2C41-3B58-ED97-FBD65535BEB0}"/>
+                <a16:creationId xmlns:a16="http://schemas.microsoft.com/office/drawing/2014/main" id="{07C0B75D-FB91-42A6-EA6D-1058AB415E53}"/>
               </a:ext>
             </a:extLst>
           </p:cNvPr>
@@ -1003,7 +1003,7 @@
           <p:cNvPr id="3" name="Text Placeholder 2">
             <a:extLst>
               <a:ext uri="{FF2B5EF4-FFF2-40B4-BE49-F238E27FC236}">
-                <a16:creationId xmlns:a16="http://schemas.microsoft.com/office/drawing/2014/main" id="{5EA843D5-D232-EB88-ED2B-39BDFCE166D8}"/>
+                <a16:creationId xmlns:a16="http://schemas.microsoft.com/office/drawing/2014/main" id="{C594C586-8208-DCF8-4C72-5ED1DE06661A}"/>
               </a:ext>
             </a:extLst>
           </p:cNvPr>
@@ -1128,7 +1128,7 @@
           <p:cNvPr id="4" name="Date Placeholder 3">
             <a:extLst>
               <a:ext uri="{FF2B5EF4-FFF2-40B4-BE49-F238E27FC236}">
-                <a16:creationId xmlns:a16="http://schemas.microsoft.com/office/drawing/2014/main" id="{A33EC897-8098-4F75-4D50-CEA13A53E9BE}"/>
+                <a16:creationId xmlns:a16="http://schemas.microsoft.com/office/drawing/2014/main" id="{B7F55D09-5E01-EDA0-140E-E74B49095A7D}"/>
               </a:ext>
             </a:extLst>
           </p:cNvPr>
@@ -1144,7 +1144,7 @@
           <a:bodyPr/>
           <a:lstStyle/>
           <a:p>
-            <a:fld id="{A7719A36-783A-425C-B6FC-5643BEA553F5}" type="datetimeFigureOut">
+            <a:fld id="{AE1EB108-E25E-41A5-B3DD-045838C88DEA}" type="datetimeFigureOut">
               <a:rPr lang="en-US" smtClean="0"/>
               <a:t>9/18/2026</a:t>
             </a:fld>
@@ -1157,7 +1157,7 @@
           <p:cNvPr id="5" name="Footer Placeholder 4">
             <a:extLst>
               <a:ext uri="{FF2B5EF4-FFF2-40B4-BE49-F238E27FC236}">
-                <a16:creationId xmlns:a16="http://schemas.microsoft.com/office/drawing/2014/main" id="{DAE6B334-0404-B917-9474-48C7C54F6B05}"/>
+                <a16:creationId xmlns:a16="http://schemas.microsoft.com/office/drawing/2014/main" id="{EE015B9B-95F2-0441-663A-FD38E03C75F8}"/>
               </a:ext>
             </a:extLst>
           </p:cNvPr>
@@ -1182,7 +1182,7 @@
           <p:cNvPr id="6" name="Slide Number Placeholder 5">
             <a:extLst>
               <a:ext uri="{FF2B5EF4-FFF2-40B4-BE49-F238E27FC236}">
-                <a16:creationId xmlns:a16="http://schemas.microsoft.com/office/drawing/2014/main" id="{129ACA23-B20A-2732-1407-4C3BA62D58AD}"/>
+                <a16:creationId xmlns:a16="http://schemas.microsoft.com/office/drawing/2014/main" id="{1086885B-8A70-14C7-1DFC-33BCC0C6C7A5}"/>
               </a:ext>
             </a:extLst>
           </p:cNvPr>
@@ -1198,7 +1198,7 @@
           <a:bodyPr/>
           <a:lstStyle/>
           <a:p>
-            <a:fld id="{11B7EAB8-895B-4396-84A9-DA5337866697}" type="slidenum">
+            <a:fld id="{3E968F7E-64B4-4319-BA52-44084D8B6E1C}" type="slidenum">
               <a:rPr lang="en-US" smtClean="0"/>
               <a:t>‹#›</a:t>
             </a:fld>
@@ -1209,7 +1209,7 @@
     </p:spTree>
     <p:extLst>
       <p:ext uri="{BB962C8B-B14F-4D97-AF65-F5344CB8AC3E}">
-        <p14:creationId xmlns:p14="http://schemas.microsoft.com/office/powerpoint/2010/main" val="297952659"/>
+        <p14:creationId xmlns:p14="http://schemas.microsoft.com/office/powerpoint/2010/main" val="82541063"/>
       </p:ext>
     </p:extLst>
   </p:cSld>
@@ -1241,7 +1241,7 @@
           <p:cNvPr id="2" name="Title 1">
             <a:extLst>
               <a:ext uri="{FF2B5EF4-FFF2-40B4-BE49-F238E27FC236}">
-                <a16:creationId xmlns:a16="http://schemas.microsoft.com/office/drawing/2014/main" id="{87B5FB4F-1613-8998-8FAE-069608738CE3}"/>
+                <a16:creationId xmlns:a16="http://schemas.microsoft.com/office/drawing/2014/main" id="{446D5D01-A58A-4D5B-AA91-547CF8C5FD21}"/>
               </a:ext>
             </a:extLst>
           </p:cNvPr>
@@ -1269,7 +1269,7 @@
           <p:cNvPr id="3" name="Content Placeholder 2">
             <a:extLst>
               <a:ext uri="{FF2B5EF4-FFF2-40B4-BE49-F238E27FC236}">
-                <a16:creationId xmlns:a16="http://schemas.microsoft.com/office/drawing/2014/main" id="{B1079A22-98C4-702E-A1AD-5F71753280FF}"/>
+                <a16:creationId xmlns:a16="http://schemas.microsoft.com/office/drawing/2014/main" id="{3284CDBA-76B1-4700-8637-A06F11E04E4E}"/>
               </a:ext>
             </a:extLst>
           </p:cNvPr>
@@ -1331,7 +1331,7 @@
           <p:cNvPr id="4" name="Content Placeholder 3">
             <a:extLst>
               <a:ext uri="{FF2B5EF4-FFF2-40B4-BE49-F238E27FC236}">
-                <a16:creationId xmlns:a16="http://schemas.microsoft.com/office/drawing/2014/main" id="{4881C3F0-3CBE-988E-00F3-BAEEE6013501}"/>
+                <a16:creationId xmlns:a16="http://schemas.microsoft.com/office/drawing/2014/main" id="{5714F4D9-E77D-896A-771D-60CC831ADD0D}"/>
               </a:ext>
             </a:extLst>
           </p:cNvPr>
@@ -1393,7 +1393,7 @@
           <p:cNvPr id="5" name="Date Placeholder 4">
             <a:extLst>
               <a:ext uri="{FF2B5EF4-FFF2-40B4-BE49-F238E27FC236}">
-                <a16:creationId xmlns:a16="http://schemas.microsoft.com/office/drawing/2014/main" id="{10588C25-7876-2133-0152-22450261B34C}"/>
+                <a16:creationId xmlns:a16="http://schemas.microsoft.com/office/drawing/2014/main" id="{E0DDDFEC-5A19-CD46-E3CD-47562F00D5D8}"/>
               </a:ext>
             </a:extLst>
           </p:cNvPr>
@@ -1409,7 +1409,7 @@
           <a:bodyPr/>
           <a:lstStyle/>
           <a:p>
-            <a:fld id="{A7719A36-783A-425C-B6FC-5643BEA553F5}" type="datetimeFigureOut">
+            <a:fld id="{AE1EB108-E25E-41A5-B3DD-045838C88DEA}" type="datetimeFigureOut">
               <a:rPr lang="en-US" smtClean="0"/>
               <a:t>9/18/2026</a:t>
             </a:fld>
@@ -1422,7 +1422,7 @@
           <p:cNvPr id="6" name="Footer Placeholder 5">
             <a:extLst>
               <a:ext uri="{FF2B5EF4-FFF2-40B4-BE49-F238E27FC236}">
-                <a16:creationId xmlns:a16="http://schemas.microsoft.com/office/drawing/2014/main" id="{F406861F-4BD3-3444-FD31-A5B5B159568D}"/>
+                <a16:creationId xmlns:a16="http://schemas.microsoft.com/office/drawing/2014/main" id="{60B8A01D-42CA-87BF-3697-785349A4A444}"/>
               </a:ext>
             </a:extLst>
           </p:cNvPr>
@@ -1447,7 +1447,7 @@
           <p:cNvPr id="7" name="Slide Number Placeholder 6">
             <a:extLst>
               <a:ext uri="{FF2B5EF4-FFF2-40B4-BE49-F238E27FC236}">
-                <a16:creationId xmlns:a16="http://schemas.microsoft.com/office/drawing/2014/main" id="{193E83EA-BFA4-AA86-B79D-D4CC0569F7EA}"/>
+                <a16:creationId xmlns:a16="http://schemas.microsoft.com/office/drawing/2014/main" id="{1F8ACC3A-6422-347E-9FEC-D765FBFD4847}"/>
               </a:ext>
             </a:extLst>
           </p:cNvPr>
@@ -1463,7 +1463,7 @@
           <a:bodyPr/>
           <a:lstStyle/>
           <a:p>
-            <a:fld id="{11B7EAB8-895B-4396-84A9-DA5337866697}" type="slidenum">
+            <a:fld id="{3E968F7E-64B4-4319-BA52-44084D8B6E1C}" type="slidenum">
               <a:rPr lang="en-US" smtClean="0"/>
               <a:t>‹#›</a:t>
             </a:fld>
@@ -1474,7 +1474,7 @@
     </p:spTree>
     <p:extLst>
       <p:ext uri="{BB962C8B-B14F-4D97-AF65-F5344CB8AC3E}">
-        <p14:creationId xmlns:p14="http://schemas.microsoft.com/office/powerpoint/2010/main" val="4131735010"/>
+        <p14:creationId xmlns:p14="http://schemas.microsoft.com/office/powerpoint/2010/main" val="3502663897"/>
       </p:ext>
     </p:extLst>
   </p:cSld>
@@ -1506,7 +1506,7 @@
           <p:cNvPr id="2" name="Title 1">
             <a:extLst>
               <a:ext uri="{FF2B5EF4-FFF2-40B4-BE49-F238E27FC236}">
-                <a16:creationId xmlns:a16="http://schemas.microsoft.com/office/drawing/2014/main" id="{279CC117-9396-F411-361F-6F927BD26F8D}"/>
+                <a16:creationId xmlns:a16="http://schemas.microsoft.com/office/drawing/2014/main" id="{35378296-8270-3609-1394-2A4B3B730ED3}"/>
               </a:ext>
             </a:extLst>
           </p:cNvPr>
@@ -1539,7 +1539,7 @@
           <p:cNvPr id="3" name="Text Placeholder 2">
             <a:extLst>
               <a:ext uri="{FF2B5EF4-FFF2-40B4-BE49-F238E27FC236}">
-                <a16:creationId xmlns:a16="http://schemas.microsoft.com/office/drawing/2014/main" id="{CCB1ABD9-3D76-9C1E-539B-1644F6EA0D24}"/>
+                <a16:creationId xmlns:a16="http://schemas.microsoft.com/office/drawing/2014/main" id="{CDDCB054-5175-1949-3ED6-51A531E168CE}"/>
               </a:ext>
             </a:extLst>
           </p:cNvPr>
@@ -1610,7 +1610,7 @@
           <p:cNvPr id="4" name="Content Placeholder 3">
             <a:extLst>
               <a:ext uri="{FF2B5EF4-FFF2-40B4-BE49-F238E27FC236}">
-                <a16:creationId xmlns:a16="http://schemas.microsoft.com/office/drawing/2014/main" id="{8690F700-38E7-65FC-B81F-53BF517D8840}"/>
+                <a16:creationId xmlns:a16="http://schemas.microsoft.com/office/drawing/2014/main" id="{531F8890-B60C-38A7-D336-7144D304E99B}"/>
               </a:ext>
             </a:extLst>
           </p:cNvPr>
@@ -1672,7 +1672,7 @@
           <p:cNvPr id="5" name="Text Placeholder 4">
             <a:extLst>
               <a:ext uri="{FF2B5EF4-FFF2-40B4-BE49-F238E27FC236}">
-                <a16:creationId xmlns:a16="http://schemas.microsoft.com/office/drawing/2014/main" id="{CDBC0E19-D8EE-072C-E2DF-E9218464FEA7}"/>
+                <a16:creationId xmlns:a16="http://schemas.microsoft.com/office/drawing/2014/main" id="{E53F2479-74C4-4354-F959-99E7A9775873}"/>
               </a:ext>
             </a:extLst>
           </p:cNvPr>
@@ -1743,7 +1743,7 @@
           <p:cNvPr id="6" name="Content Placeholder 5">
             <a:extLst>
               <a:ext uri="{FF2B5EF4-FFF2-40B4-BE49-F238E27FC236}">
-                <a16:creationId xmlns:a16="http://schemas.microsoft.com/office/drawing/2014/main" id="{05D0BCCB-492D-6A32-F06E-94B7185E82D6}"/>
+                <a16:creationId xmlns:a16="http://schemas.microsoft.com/office/drawing/2014/main" id="{EFCD8557-348E-6958-4682-163261EF1D17}"/>
               </a:ext>
             </a:extLst>
           </p:cNvPr>
@@ -1805,7 +1805,7 @@
           <p:cNvPr id="7" name="Date Placeholder 6">
             <a:extLst>
               <a:ext uri="{FF2B5EF4-FFF2-40B4-BE49-F238E27FC236}">
-                <a16:creationId xmlns:a16="http://schemas.microsoft.com/office/drawing/2014/main" id="{C6A9B79B-1F5D-F482-A90C-76AFB97F5C40}"/>
+                <a16:creationId xmlns:a16="http://schemas.microsoft.com/office/drawing/2014/main" id="{1DA11432-039A-2B98-9930-06D98ABACF10}"/>
               </a:ext>
             </a:extLst>
           </p:cNvPr>
@@ -1821,7 +1821,7 @@
           <a:bodyPr/>
           <a:lstStyle/>
           <a:p>
-            <a:fld id="{A7719A36-783A-425C-B6FC-5643BEA553F5}" type="datetimeFigureOut">
+            <a:fld id="{AE1EB108-E25E-41A5-B3DD-045838C88DEA}" type="datetimeFigureOut">
               <a:rPr lang="en-US" smtClean="0"/>
               <a:t>9/18/2026</a:t>
             </a:fld>
@@ -1834,7 +1834,7 @@
           <p:cNvPr id="8" name="Footer Placeholder 7">
             <a:extLst>
               <a:ext uri="{FF2B5EF4-FFF2-40B4-BE49-F238E27FC236}">
-                <a16:creationId xmlns:a16="http://schemas.microsoft.com/office/drawing/2014/main" id="{7F0EE32E-47E0-1D25-A5E1-B45540D4C975}"/>
+                <a16:creationId xmlns:a16="http://schemas.microsoft.com/office/drawing/2014/main" id="{3B8E1F5E-D485-219F-DC77-24EAFDCC6F28}"/>
               </a:ext>
             </a:extLst>
           </p:cNvPr>
@@ -1859,7 +1859,7 @@
           <p:cNvPr id="9" name="Slide Number Placeholder 8">
             <a:extLst>
               <a:ext uri="{FF2B5EF4-FFF2-40B4-BE49-F238E27FC236}">
-                <a16:creationId xmlns:a16="http://schemas.microsoft.com/office/drawing/2014/main" id="{EB0F7757-4A6A-AC1A-0DF5-D3072C7B7F75}"/>
+                <a16:creationId xmlns:a16="http://schemas.microsoft.com/office/drawing/2014/main" id="{048B97A8-A2A9-D607-36D1-E44941826247}"/>
               </a:ext>
             </a:extLst>
           </p:cNvPr>
@@ -1875,7 +1875,7 @@
           <a:bodyPr/>
           <a:lstStyle/>
           <a:p>
-            <a:fld id="{11B7EAB8-895B-4396-84A9-DA5337866697}" type="slidenum">
+            <a:fld id="{3E968F7E-64B4-4319-BA52-44084D8B6E1C}" type="slidenum">
               <a:rPr lang="en-US" smtClean="0"/>
               <a:t>‹#›</a:t>
             </a:fld>
@@ -1886,7 +1886,7 @@
     </p:spTree>
     <p:extLst>
       <p:ext uri="{BB962C8B-B14F-4D97-AF65-F5344CB8AC3E}">
-        <p14:creationId xmlns:p14="http://schemas.microsoft.com/office/powerpoint/2010/main" val="77251363"/>
+        <p14:creationId xmlns:p14="http://schemas.microsoft.com/office/powerpoint/2010/main" val="243446891"/>
       </p:ext>
     </p:extLst>
   </p:cSld>
@@ -1918,7 +1918,7 @@
           <p:cNvPr id="2" name="Title 1">
             <a:extLst>
               <a:ext uri="{FF2B5EF4-FFF2-40B4-BE49-F238E27FC236}">
-                <a16:creationId xmlns:a16="http://schemas.microsoft.com/office/drawing/2014/main" id="{DCAA9717-5ABB-8DBC-31E4-44E28341E74F}"/>
+                <a16:creationId xmlns:a16="http://schemas.microsoft.com/office/drawing/2014/main" id="{7131405D-03B7-B20B-60F0-1E2372DE8971}"/>
               </a:ext>
             </a:extLst>
           </p:cNvPr>
@@ -1946,7 +1946,7 @@
           <p:cNvPr id="3" name="Date Placeholder 2">
             <a:extLst>
               <a:ext uri="{FF2B5EF4-FFF2-40B4-BE49-F238E27FC236}">
-                <a16:creationId xmlns:a16="http://schemas.microsoft.com/office/drawing/2014/main" id="{C36AAA93-9F03-4C85-1880-917662FAF122}"/>
+                <a16:creationId xmlns:a16="http://schemas.microsoft.com/office/drawing/2014/main" id="{D5FE2765-E359-FBCF-C1BC-51380A1C26A6}"/>
               </a:ext>
             </a:extLst>
           </p:cNvPr>
@@ -1962,7 +1962,7 @@
           <a:bodyPr/>
           <a:lstStyle/>
           <a:p>
-            <a:fld id="{A7719A36-783A-425C-B6FC-5643BEA553F5}" type="datetimeFigureOut">
+            <a:fld id="{AE1EB108-E25E-41A5-B3DD-045838C88DEA}" type="datetimeFigureOut">
               <a:rPr lang="en-US" smtClean="0"/>
               <a:t>9/18/2026</a:t>
             </a:fld>
@@ -1975,7 +1975,7 @@
           <p:cNvPr id="4" name="Footer Placeholder 3">
             <a:extLst>
               <a:ext uri="{FF2B5EF4-FFF2-40B4-BE49-F238E27FC236}">
-                <a16:creationId xmlns:a16="http://schemas.microsoft.com/office/drawing/2014/main" id="{1116CC33-7CC2-F856-6B69-F484C05A9CDC}"/>
+                <a16:creationId xmlns:a16="http://schemas.microsoft.com/office/drawing/2014/main" id="{FDE86A0B-F71D-8FD2-2954-4F814264AE92}"/>
               </a:ext>
             </a:extLst>
           </p:cNvPr>
@@ -2000,7 +2000,7 @@
           <p:cNvPr id="5" name="Slide Number Placeholder 4">
             <a:extLst>
               <a:ext uri="{FF2B5EF4-FFF2-40B4-BE49-F238E27FC236}">
-                <a16:creationId xmlns:a16="http://schemas.microsoft.com/office/drawing/2014/main" id="{FC660CA5-56C1-006D-71B2-9559F846B913}"/>
+                <a16:creationId xmlns:a16="http://schemas.microsoft.com/office/drawing/2014/main" id="{4B463218-1284-B03A-E185-024F5200997B}"/>
               </a:ext>
             </a:extLst>
           </p:cNvPr>
@@ -2016,7 +2016,7 @@
           <a:bodyPr/>
           <a:lstStyle/>
           <a:p>
-            <a:fld id="{11B7EAB8-895B-4396-84A9-DA5337866697}" type="slidenum">
+            <a:fld id="{3E968F7E-64B4-4319-BA52-44084D8B6E1C}" type="slidenum">
               <a:rPr lang="en-US" smtClean="0"/>
               <a:t>‹#›</a:t>
             </a:fld>
@@ -2027,7 +2027,7 @@
     </p:spTree>
     <p:extLst>
       <p:ext uri="{BB962C8B-B14F-4D97-AF65-F5344CB8AC3E}">
-        <p14:creationId xmlns:p14="http://schemas.microsoft.com/office/powerpoint/2010/main" val="3211169793"/>
+        <p14:creationId xmlns:p14="http://schemas.microsoft.com/office/powerpoint/2010/main" val="158031355"/>
       </p:ext>
     </p:extLst>
   </p:cSld>
@@ -2059,7 +2059,7 @@
           <p:cNvPr id="2" name="Date Placeholder 1">
             <a:extLst>
               <a:ext uri="{FF2B5EF4-FFF2-40B4-BE49-F238E27FC236}">
-                <a16:creationId xmlns:a16="http://schemas.microsoft.com/office/drawing/2014/main" id="{DF39B770-6FB4-FE58-905F-4844C9D7C35B}"/>
+                <a16:creationId xmlns:a16="http://schemas.microsoft.com/office/drawing/2014/main" id="{045E8E3E-F5BE-E2D8-B08E-E96344619162}"/>
               </a:ext>
             </a:extLst>
           </p:cNvPr>
@@ -2075,7 +2075,7 @@
           <a:bodyPr/>
           <a:lstStyle/>
           <a:p>
-            <a:fld id="{A7719A36-783A-425C-B6FC-5643BEA553F5}" type="datetimeFigureOut">
+            <a:fld id="{AE1EB108-E25E-41A5-B3DD-045838C88DEA}" type="datetimeFigureOut">
               <a:rPr lang="en-US" smtClean="0"/>
               <a:t>9/18/2026</a:t>
             </a:fld>
@@ -2088,7 +2088,7 @@
           <p:cNvPr id="3" name="Footer Placeholder 2">
             <a:extLst>
               <a:ext uri="{FF2B5EF4-FFF2-40B4-BE49-F238E27FC236}">
-                <a16:creationId xmlns:a16="http://schemas.microsoft.com/office/drawing/2014/main" id="{F0506CB8-56C3-F4C0-C81A-32F88CEE734A}"/>
+                <a16:creationId xmlns:a16="http://schemas.microsoft.com/office/drawing/2014/main" id="{6801D8FE-E584-219D-312B-CD35ADA94CF3}"/>
               </a:ext>
             </a:extLst>
           </p:cNvPr>
@@ -2113,7 +2113,7 @@
           <p:cNvPr id="4" name="Slide Number Placeholder 3">
             <a:extLst>
               <a:ext uri="{FF2B5EF4-FFF2-40B4-BE49-F238E27FC236}">
-                <a16:creationId xmlns:a16="http://schemas.microsoft.com/office/drawing/2014/main" id="{A4DD8A7E-4F42-9521-A14D-1FFD4102F8C2}"/>
+                <a16:creationId xmlns:a16="http://schemas.microsoft.com/office/drawing/2014/main" id="{43D47C91-F2E5-C47D-F835-7580F729D302}"/>
               </a:ext>
             </a:extLst>
           </p:cNvPr>
@@ -2129,7 +2129,7 @@
           <a:bodyPr/>
           <a:lstStyle/>
           <a:p>
-            <a:fld id="{11B7EAB8-895B-4396-84A9-DA5337866697}" type="slidenum">
+            <a:fld id="{3E968F7E-64B4-4319-BA52-44084D8B6E1C}" type="slidenum">
               <a:rPr lang="en-US" smtClean="0"/>
               <a:t>‹#›</a:t>
             </a:fld>
@@ -2140,7 +2140,7 @@
     </p:spTree>
     <p:extLst>
       <p:ext uri="{BB962C8B-B14F-4D97-AF65-F5344CB8AC3E}">
-        <p14:creationId xmlns:p14="http://schemas.microsoft.com/office/powerpoint/2010/main" val="4044873023"/>
+        <p14:creationId xmlns:p14="http://schemas.microsoft.com/office/powerpoint/2010/main" val="2177130095"/>
       </p:ext>
     </p:extLst>
   </p:cSld>
@@ -2172,7 +2172,7 @@
           <p:cNvPr id="2" name="Title 1">
             <a:extLst>
               <a:ext uri="{FF2B5EF4-FFF2-40B4-BE49-F238E27FC236}">
-                <a16:creationId xmlns:a16="http://schemas.microsoft.com/office/drawing/2014/main" id="{8FA86C7C-E34F-A469-1B4C-8B919FE4FF2C}"/>
+                <a16:creationId xmlns:a16="http://schemas.microsoft.com/office/drawing/2014/main" id="{53882157-E9C5-D667-2A6C-D3E00585D45C}"/>
               </a:ext>
             </a:extLst>
           </p:cNvPr>
@@ -2209,7 +2209,7 @@
           <p:cNvPr id="3" name="Content Placeholder 2">
             <a:extLst>
               <a:ext uri="{FF2B5EF4-FFF2-40B4-BE49-F238E27FC236}">
-                <a16:creationId xmlns:a16="http://schemas.microsoft.com/office/drawing/2014/main" id="{4AF3972E-3E02-9D65-B9FC-8FA29BB67962}"/>
+                <a16:creationId xmlns:a16="http://schemas.microsoft.com/office/drawing/2014/main" id="{DAB42539-4D56-21A5-5F3E-9EF1D1906999}"/>
               </a:ext>
             </a:extLst>
           </p:cNvPr>
@@ -2299,7 +2299,7 @@
           <p:cNvPr id="4" name="Text Placeholder 3">
             <a:extLst>
               <a:ext uri="{FF2B5EF4-FFF2-40B4-BE49-F238E27FC236}">
-                <a16:creationId xmlns:a16="http://schemas.microsoft.com/office/drawing/2014/main" id="{3AB0145C-822B-5685-188D-A94F386BCAB9}"/>
+                <a16:creationId xmlns:a16="http://schemas.microsoft.com/office/drawing/2014/main" id="{515DE32A-2924-CB34-94C7-B2E056E9B52C}"/>
               </a:ext>
             </a:extLst>
           </p:cNvPr>
@@ -2370,7 +2370,7 @@
           <p:cNvPr id="5" name="Date Placeholder 4">
             <a:extLst>
               <a:ext uri="{FF2B5EF4-FFF2-40B4-BE49-F238E27FC236}">
-                <a16:creationId xmlns:a16="http://schemas.microsoft.com/office/drawing/2014/main" id="{04636F8B-D80B-A3B7-86CE-F11B0C66CD6B}"/>
+                <a16:creationId xmlns:a16="http://schemas.microsoft.com/office/drawing/2014/main" id="{B7BA8666-1F98-438F-7D0E-3A6355688657}"/>
               </a:ext>
             </a:extLst>
           </p:cNvPr>
@@ -2386,7 +2386,7 @@
           <a:bodyPr/>
           <a:lstStyle/>
           <a:p>
-            <a:fld id="{A7719A36-783A-425C-B6FC-5643BEA553F5}" type="datetimeFigureOut">
+            <a:fld id="{AE1EB108-E25E-41A5-B3DD-045838C88DEA}" type="datetimeFigureOut">
               <a:rPr lang="en-US" smtClean="0"/>
               <a:t>9/18/2026</a:t>
             </a:fld>
@@ -2399,7 +2399,7 @@
           <p:cNvPr id="6" name="Footer Placeholder 5">
             <a:extLst>
               <a:ext uri="{FF2B5EF4-FFF2-40B4-BE49-F238E27FC236}">
-                <a16:creationId xmlns:a16="http://schemas.microsoft.com/office/drawing/2014/main" id="{3146E621-4AEF-235A-4185-E2704D4FE097}"/>
+                <a16:creationId xmlns:a16="http://schemas.microsoft.com/office/drawing/2014/main" id="{CF942209-8AD3-A176-51B1-0B90FA6618C9}"/>
               </a:ext>
             </a:extLst>
           </p:cNvPr>
@@ -2424,7 +2424,7 @@
           <p:cNvPr id="7" name="Slide Number Placeholder 6">
             <a:extLst>
               <a:ext uri="{FF2B5EF4-FFF2-40B4-BE49-F238E27FC236}">
-                <a16:creationId xmlns:a16="http://schemas.microsoft.com/office/drawing/2014/main" id="{425D6BBC-ACDE-E94E-7A82-FB742E7B4E42}"/>
+                <a16:creationId xmlns:a16="http://schemas.microsoft.com/office/drawing/2014/main" id="{DCF24C36-A7D1-252F-4F84-792151773245}"/>
               </a:ext>
             </a:extLst>
           </p:cNvPr>
@@ -2440,7 +2440,7 @@
           <a:bodyPr/>
           <a:lstStyle/>
           <a:p>
-            <a:fld id="{11B7EAB8-895B-4396-84A9-DA5337866697}" type="slidenum">
+            <a:fld id="{3E968F7E-64B4-4319-BA52-44084D8B6E1C}" type="slidenum">
               <a:rPr lang="en-US" smtClean="0"/>
               <a:t>‹#›</a:t>
             </a:fld>
@@ -2451,7 +2451,7 @@
     </p:spTree>
     <p:extLst>
       <p:ext uri="{BB962C8B-B14F-4D97-AF65-F5344CB8AC3E}">
-        <p14:creationId xmlns:p14="http://schemas.microsoft.com/office/powerpoint/2010/main" val="4272446156"/>
+        <p14:creationId xmlns:p14="http://schemas.microsoft.com/office/powerpoint/2010/main" val="1274509118"/>
       </p:ext>
     </p:extLst>
   </p:cSld>
@@ -2483,7 +2483,7 @@
           <p:cNvPr id="2" name="Title 1">
             <a:extLst>
               <a:ext uri="{FF2B5EF4-FFF2-40B4-BE49-F238E27FC236}">
-                <a16:creationId xmlns:a16="http://schemas.microsoft.com/office/drawing/2014/main" id="{530B9DD1-E73C-5FC0-7EBF-45B4E1322BC0}"/>
+                <a16:creationId xmlns:a16="http://schemas.microsoft.com/office/drawing/2014/main" id="{A1E826CE-EA07-8860-3971-E1A68F0E2C56}"/>
               </a:ext>
             </a:extLst>
           </p:cNvPr>
@@ -2520,7 +2520,7 @@
           <p:cNvPr id="3" name="Picture Placeholder 2">
             <a:extLst>
               <a:ext uri="{FF2B5EF4-FFF2-40B4-BE49-F238E27FC236}">
-                <a16:creationId xmlns:a16="http://schemas.microsoft.com/office/drawing/2014/main" id="{CEBE8692-E065-5AD4-3C81-0A3CEA8BD95D}"/>
+                <a16:creationId xmlns:a16="http://schemas.microsoft.com/office/drawing/2014/main" id="{38A78CBA-94AC-5820-9CE8-179422C02A7B}"/>
               </a:ext>
             </a:extLst>
           </p:cNvPr>
@@ -2587,7 +2587,7 @@
           <p:cNvPr id="4" name="Text Placeholder 3">
             <a:extLst>
               <a:ext uri="{FF2B5EF4-FFF2-40B4-BE49-F238E27FC236}">
-                <a16:creationId xmlns:a16="http://schemas.microsoft.com/office/drawing/2014/main" id="{FB6365D4-1846-0437-9C45-600BEB02CC33}"/>
+                <a16:creationId xmlns:a16="http://schemas.microsoft.com/office/drawing/2014/main" id="{93937EC2-F871-B648-EF1C-56D7427F6424}"/>
               </a:ext>
             </a:extLst>
           </p:cNvPr>
@@ -2658,7 +2658,7 @@
           <p:cNvPr id="5" name="Date Placeholder 4">
             <a:extLst>
               <a:ext uri="{FF2B5EF4-FFF2-40B4-BE49-F238E27FC236}">
-                <a16:creationId xmlns:a16="http://schemas.microsoft.com/office/drawing/2014/main" id="{2B2774E4-A5EE-4AFC-66FB-FE05250EDD7D}"/>
+                <a16:creationId xmlns:a16="http://schemas.microsoft.com/office/drawing/2014/main" id="{082C7F11-63CC-7DF4-84CF-F314D354A66E}"/>
               </a:ext>
             </a:extLst>
           </p:cNvPr>
@@ -2674,7 +2674,7 @@
           <a:bodyPr/>
           <a:lstStyle/>
           <a:p>
-            <a:fld id="{A7719A36-783A-425C-B6FC-5643BEA553F5}" type="datetimeFigureOut">
+            <a:fld id="{AE1EB108-E25E-41A5-B3DD-045838C88DEA}" type="datetimeFigureOut">
               <a:rPr lang="en-US" smtClean="0"/>
               <a:t>9/18/2026</a:t>
             </a:fld>
@@ -2687,7 +2687,7 @@
           <p:cNvPr id="6" name="Footer Placeholder 5">
             <a:extLst>
               <a:ext uri="{FF2B5EF4-FFF2-40B4-BE49-F238E27FC236}">
-                <a16:creationId xmlns:a16="http://schemas.microsoft.com/office/drawing/2014/main" id="{8ED186DF-75AC-CCC4-934A-234BCACF380A}"/>
+                <a16:creationId xmlns:a16="http://schemas.microsoft.com/office/drawing/2014/main" id="{32154A0E-003A-2DA1-CB2B-43D334C5B8A6}"/>
               </a:ext>
             </a:extLst>
           </p:cNvPr>
@@ -2712,7 +2712,7 @@
           <p:cNvPr id="7" name="Slide Number Placeholder 6">
             <a:extLst>
               <a:ext uri="{FF2B5EF4-FFF2-40B4-BE49-F238E27FC236}">
-                <a16:creationId xmlns:a16="http://schemas.microsoft.com/office/drawing/2014/main" id="{35668FA4-477D-0E0D-E769-D8F6A52714E7}"/>
+                <a16:creationId xmlns:a16="http://schemas.microsoft.com/office/drawing/2014/main" id="{CCFF3598-A232-704D-5D04-6A6EA169CB4E}"/>
               </a:ext>
             </a:extLst>
           </p:cNvPr>
@@ -2728,7 +2728,7 @@
           <a:bodyPr/>
           <a:lstStyle/>
           <a:p>
-            <a:fld id="{11B7EAB8-895B-4396-84A9-DA5337866697}" type="slidenum">
+            <a:fld id="{3E968F7E-64B4-4319-BA52-44084D8B6E1C}" type="slidenum">
               <a:rPr lang="en-US" smtClean="0"/>
               <a:t>‹#›</a:t>
             </a:fld>
@@ -2739,7 +2739,7 @@
     </p:spTree>
     <p:extLst>
       <p:ext uri="{BB962C8B-B14F-4D97-AF65-F5344CB8AC3E}">
-        <p14:creationId xmlns:p14="http://schemas.microsoft.com/office/powerpoint/2010/main" val="1702285088"/>
+        <p14:creationId xmlns:p14="http://schemas.microsoft.com/office/powerpoint/2010/main" val="3571925484"/>
       </p:ext>
     </p:extLst>
   </p:cSld>
@@ -2776,7 +2776,7 @@
           <p:cNvPr id="2" name="Title Placeholder 1">
             <a:extLst>
               <a:ext uri="{FF2B5EF4-FFF2-40B4-BE49-F238E27FC236}">
-                <a16:creationId xmlns:a16="http://schemas.microsoft.com/office/drawing/2014/main" id="{983DC805-6358-2BA1-B041-6D19CCEE49AD}"/>
+                <a16:creationId xmlns:a16="http://schemas.microsoft.com/office/drawing/2014/main" id="{63EFA020-1B2D-F6F1-AD68-7923FDA275D1}"/>
               </a:ext>
             </a:extLst>
           </p:cNvPr>
@@ -2814,7 +2814,7 @@
           <p:cNvPr id="3" name="Text Placeholder 2">
             <a:extLst>
               <a:ext uri="{FF2B5EF4-FFF2-40B4-BE49-F238E27FC236}">
-                <a16:creationId xmlns:a16="http://schemas.microsoft.com/office/drawing/2014/main" id="{6E013E21-2239-EF09-B286-D4F830EE9389}"/>
+                <a16:creationId xmlns:a16="http://schemas.microsoft.com/office/drawing/2014/main" id="{AE218EE7-5225-383E-A22A-EB6F82D7B5E4}"/>
               </a:ext>
             </a:extLst>
           </p:cNvPr>
@@ -2881,7 +2881,7 @@
           <p:cNvPr id="4" name="Date Placeholder 3">
             <a:extLst>
               <a:ext uri="{FF2B5EF4-FFF2-40B4-BE49-F238E27FC236}">
-                <a16:creationId xmlns:a16="http://schemas.microsoft.com/office/drawing/2014/main" id="{5C4838BB-3EE5-E706-5246-CC4BFEA2FFB4}"/>
+                <a16:creationId xmlns:a16="http://schemas.microsoft.com/office/drawing/2014/main" id="{01BE526A-58A9-E26C-4655-E9A2E5BE7C1C}"/>
               </a:ext>
             </a:extLst>
           </p:cNvPr>
@@ -2915,7 +2915,7 @@
             </a:lvl1pPr>
           </a:lstStyle>
           <a:p>
-            <a:fld id="{A7719A36-783A-425C-B6FC-5643BEA553F5}" type="datetimeFigureOut">
+            <a:fld id="{AE1EB108-E25E-41A5-B3DD-045838C88DEA}" type="datetimeFigureOut">
               <a:rPr lang="en-US" smtClean="0"/>
               <a:t>9/18/2026</a:t>
             </a:fld>
@@ -2928,7 +2928,7 @@
           <p:cNvPr id="5" name="Footer Placeholder 4">
             <a:extLst>
               <a:ext uri="{FF2B5EF4-FFF2-40B4-BE49-F238E27FC236}">
-                <a16:creationId xmlns:a16="http://schemas.microsoft.com/office/drawing/2014/main" id="{BDF97C04-7CCA-AAB2-58B4-0DE893F0F3AF}"/>
+                <a16:creationId xmlns:a16="http://schemas.microsoft.com/office/drawing/2014/main" id="{2BF1C5ED-0451-9D9D-EEB3-20C25B4F6979}"/>
               </a:ext>
             </a:extLst>
           </p:cNvPr>
@@ -2971,7 +2971,7 @@
           <p:cNvPr id="6" name="Slide Number Placeholder 5">
             <a:extLst>
               <a:ext uri="{FF2B5EF4-FFF2-40B4-BE49-F238E27FC236}">
-                <a16:creationId xmlns:a16="http://schemas.microsoft.com/office/drawing/2014/main" id="{144170A6-3405-F128-D1CE-D5498559850C}"/>
+                <a16:creationId xmlns:a16="http://schemas.microsoft.com/office/drawing/2014/main" id="{3FDBBDFC-2177-0967-9D35-55C4487BD84F}"/>
               </a:ext>
             </a:extLst>
           </p:cNvPr>
@@ -3005,7 +3005,7 @@
             </a:lvl1pPr>
           </a:lstStyle>
           <a:p>
-            <a:fld id="{11B7EAB8-895B-4396-84A9-DA5337866697}" type="slidenum">
+            <a:fld id="{3E968F7E-64B4-4319-BA52-44084D8B6E1C}" type="slidenum">
               <a:rPr lang="en-US" smtClean="0"/>
               <a:t>‹#›</a:t>
             </a:fld>
@@ -3016,7 +3016,7 @@
     </p:spTree>
     <p:extLst>
       <p:ext uri="{BB962C8B-B14F-4D97-AF65-F5344CB8AC3E}">
-        <p14:creationId xmlns:p14="http://schemas.microsoft.com/office/powerpoint/2010/main" val="3414328548"/>
+        <p14:creationId xmlns:p14="http://schemas.microsoft.com/office/powerpoint/2010/main" val="2608821881"/>
       </p:ext>
     </p:extLst>
   </p:cSld>
@@ -3347,7 +3347,7 @@
           <p:cNvPr id="2" name="Rectangle 1">
             <a:extLst>
               <a:ext uri="{FF2B5EF4-FFF2-40B4-BE49-F238E27FC236}">
-                <a16:creationId xmlns:a16="http://schemas.microsoft.com/office/drawing/2014/main" id="{76BFB723-1CF2-8D70-0706-AF02A22B97D2}"/>
+                <a16:creationId xmlns:a16="http://schemas.microsoft.com/office/drawing/2014/main" id="{5B2D31BD-1147-146C-4B94-23D5AB96C874}"/>
               </a:ext>
             </a:extLst>
           </p:cNvPr>
@@ -3415,7 +3415,7 @@
           <p:cNvPr id="3" name="TextBox 2">
             <a:extLst>
               <a:ext uri="{FF2B5EF4-FFF2-40B4-BE49-F238E27FC236}">
-                <a16:creationId xmlns:a16="http://schemas.microsoft.com/office/drawing/2014/main" id="{438C2729-35D5-ECBD-C283-919511C286F9}"/>
+                <a16:creationId xmlns:a16="http://schemas.microsoft.com/office/drawing/2014/main" id="{1018CCD3-E4A1-C69D-1A57-6E2E80C9A6AD}"/>
               </a:ext>
             </a:extLst>
           </p:cNvPr>
@@ -3461,7 +3461,7 @@
           <p:cNvPr id="4" name="TextBox 3">
             <a:extLst>
               <a:ext uri="{FF2B5EF4-FFF2-40B4-BE49-F238E27FC236}">
-                <a16:creationId xmlns:a16="http://schemas.microsoft.com/office/drawing/2014/main" id="{9C5A9841-3FB9-03C3-45A5-48F1BAA67845}"/>
+                <a16:creationId xmlns:a16="http://schemas.microsoft.com/office/drawing/2014/main" id="{261369D4-8FE1-63B8-4D27-5A0E830613FA}"/>
               </a:ext>
             </a:extLst>
           </p:cNvPr>
@@ -3501,7 +3501,7 @@
           <p:cNvPr id="5" name="TextBox 4">
             <a:extLst>
               <a:ext uri="{FF2B5EF4-FFF2-40B4-BE49-F238E27FC236}">
-                <a16:creationId xmlns:a16="http://schemas.microsoft.com/office/drawing/2014/main" id="{D6D655C7-8950-A417-3A29-E2FA512B1DD5}"/>
+                <a16:creationId xmlns:a16="http://schemas.microsoft.com/office/drawing/2014/main" id="{E5F0EA83-4CE5-C604-06DB-AC9D5C29B7D3}"/>
               </a:ext>
             </a:extLst>
           </p:cNvPr>
@@ -3547,7 +3547,7 @@
           <p:cNvPr id="7" name="!!Stage_Hero_Container!!">
             <a:extLst>
               <a:ext uri="{FF2B5EF4-FFF2-40B4-BE49-F238E27FC236}">
-                <a16:creationId xmlns:a16="http://schemas.microsoft.com/office/drawing/2014/main" id="{9E5BC98C-549F-A6E1-933F-8719ABA606F6}"/>
+                <a16:creationId xmlns:a16="http://schemas.microsoft.com/office/drawing/2014/main" id="{929D0F45-31FA-E9D1-8BB0-750A82743497}"/>
               </a:ext>
             </a:extLst>
           </p:cNvPr>
@@ -3586,7 +3586,7 @@
     </p:spTree>
     <p:extLst>
       <p:ext uri="{BB962C8B-B14F-4D97-AF65-F5344CB8AC3E}">
-        <p14:creationId xmlns:p14="http://schemas.microsoft.com/office/powerpoint/2010/main" val="740801882"/>
+        <p14:creationId xmlns:p14="http://schemas.microsoft.com/office/powerpoint/2010/main" val="3509780384"/>
       </p:ext>
     </p:extLst>
   </p:cSld>
@@ -3724,7 +3724,7 @@
           <p:cNvPr id="2" name="!!Anchor_Kicker_Rail!!">
             <a:extLst>
               <a:ext uri="{FF2B5EF4-FFF2-40B4-BE49-F238E27FC236}">
-                <a16:creationId xmlns:a16="http://schemas.microsoft.com/office/drawing/2014/main" id="{BC69D755-70E3-6478-9F9B-773195594F9D}"/>
+                <a16:creationId xmlns:a16="http://schemas.microsoft.com/office/drawing/2014/main" id="{323617E8-4A88-1DC6-C511-371AC3EE5E15}"/>
               </a:ext>
             </a:extLst>
           </p:cNvPr>
@@ -3764,7 +3764,7 @@
           <p:cNvPr id="3" name="!!Anchor_Slide_Tracker!!">
             <a:extLst>
               <a:ext uri="{FF2B5EF4-FFF2-40B4-BE49-F238E27FC236}">
-                <a16:creationId xmlns:a16="http://schemas.microsoft.com/office/drawing/2014/main" id="{0555AD0F-F2EB-2B76-5E78-B379CB832707}"/>
+                <a16:creationId xmlns:a16="http://schemas.microsoft.com/office/drawing/2014/main" id="{F94FCF3C-AA23-7284-E354-A22F500AEC5B}"/>
               </a:ext>
             </a:extLst>
           </p:cNvPr>
@@ -3805,7 +3805,7 @@
           <p:cNvPr id="4" name="!!Anchor_Assertion_Title!!">
             <a:extLst>
               <a:ext uri="{FF2B5EF4-FFF2-40B4-BE49-F238E27FC236}">
-                <a16:creationId xmlns:a16="http://schemas.microsoft.com/office/drawing/2014/main" id="{E4CCFE3D-9500-6133-7237-FBFC4F30BEAB}"/>
+                <a16:creationId xmlns:a16="http://schemas.microsoft.com/office/drawing/2014/main" id="{191A3D9F-ACD9-9699-BB61-AB2724B79D40}"/>
               </a:ext>
             </a:extLst>
           </p:cNvPr>
@@ -3851,7 +3851,7 @@
           <p:cNvPr id="12" name="!!Stage_Hero_Container!!">
             <a:extLst>
               <a:ext uri="{FF2B5EF4-FFF2-40B4-BE49-F238E27FC236}">
-                <a16:creationId xmlns:a16="http://schemas.microsoft.com/office/drawing/2014/main" id="{10B0A5B8-2592-7EA7-212A-344F41E775DA}"/>
+                <a16:creationId xmlns:a16="http://schemas.microsoft.com/office/drawing/2014/main" id="{76BC2F18-B01B-2CB4-9CA2-D7D7C5931843}"/>
               </a:ext>
             </a:extLst>
           </p:cNvPr>
@@ -3871,7 +3871,7 @@
             <p:cNvPr id="6" name="Picture 5">
               <a:extLst>
                 <a:ext uri="{FF2B5EF4-FFF2-40B4-BE49-F238E27FC236}">
-                  <a16:creationId xmlns:a16="http://schemas.microsoft.com/office/drawing/2014/main" id="{1F03FC29-199C-A0C2-6AF0-7A52C0B328F7}"/>
+                  <a16:creationId xmlns:a16="http://schemas.microsoft.com/office/drawing/2014/main" id="{5E6BE7CB-F398-7D00-DDEC-4A7E9324C7F4}"/>
                 </a:ext>
               </a:extLst>
             </p:cNvPr>
@@ -3912,7 +3912,7 @@
             <p:cNvPr id="7" name="Rectangle: Rounded Corners 6">
               <a:extLst>
                 <a:ext uri="{FF2B5EF4-FFF2-40B4-BE49-F238E27FC236}">
-                  <a16:creationId xmlns:a16="http://schemas.microsoft.com/office/drawing/2014/main" id="{92ECE6F1-4A9A-8E7A-E124-B7B9D89C1186}"/>
+                  <a16:creationId xmlns:a16="http://schemas.microsoft.com/office/drawing/2014/main" id="{8D931FD8-417E-18E8-1EB4-0B3AFB75035C}"/>
                 </a:ext>
               </a:extLst>
             </p:cNvPr>
@@ -3966,7 +3966,7 @@
             <p:cNvPr id="8" name="Oval 7">
               <a:extLst>
                 <a:ext uri="{FF2B5EF4-FFF2-40B4-BE49-F238E27FC236}">
-                  <a16:creationId xmlns:a16="http://schemas.microsoft.com/office/drawing/2014/main" id="{E564CBF2-A237-D82C-DB9A-374F2D10D20B}"/>
+                  <a16:creationId xmlns:a16="http://schemas.microsoft.com/office/drawing/2014/main" id="{7CA6D1D2-3D6F-88E9-C4ED-92F827FF6D94}"/>
                 </a:ext>
               </a:extLst>
             </p:cNvPr>
@@ -4034,7 +4034,7 @@
             <p:cNvPr id="10" name="Graphic 9">
               <a:extLst>
                 <a:ext uri="{FF2B5EF4-FFF2-40B4-BE49-F238E27FC236}">
-                  <a16:creationId xmlns:a16="http://schemas.microsoft.com/office/drawing/2014/main" id="{C7D9FA35-4A04-9507-79CE-ED38038D8BD4}"/>
+                  <a16:creationId xmlns:a16="http://schemas.microsoft.com/office/drawing/2014/main" id="{D6902A96-4D64-1DD1-6FEF-D0037D1124A1}"/>
                 </a:ext>
               </a:extLst>
             </p:cNvPr>
@@ -4070,7 +4070,7 @@
             <p:cNvPr id="11" name="TextBox 10">
               <a:extLst>
                 <a:ext uri="{FF2B5EF4-FFF2-40B4-BE49-F238E27FC236}">
-                  <a16:creationId xmlns:a16="http://schemas.microsoft.com/office/drawing/2014/main" id="{0EF263DC-B5B9-FCC7-7A04-17A8C3DB87CE}"/>
+                  <a16:creationId xmlns:a16="http://schemas.microsoft.com/office/drawing/2014/main" id="{F1DFC95D-C71D-B7F9-EE77-82996C412342}"/>
                 </a:ext>
               </a:extLst>
             </p:cNvPr>
@@ -4135,7 +4135,7 @@
           <p:cNvPr id="18" name="!!Stage_Sub_Card_1!!">
             <a:extLst>
               <a:ext uri="{FF2B5EF4-FFF2-40B4-BE49-F238E27FC236}">
-                <a16:creationId xmlns:a16="http://schemas.microsoft.com/office/drawing/2014/main" id="{0C53A580-399D-1394-267B-1A366CD367E3}"/>
+                <a16:creationId xmlns:a16="http://schemas.microsoft.com/office/drawing/2014/main" id="{80786240-F359-F94E-1F7C-11AE1C460CE3}"/>
               </a:ext>
             </a:extLst>
           </p:cNvPr>
@@ -4155,7 +4155,7 @@
             <p:cNvPr id="13" name="Rectangle: Rounded Corners 12">
               <a:extLst>
                 <a:ext uri="{FF2B5EF4-FFF2-40B4-BE49-F238E27FC236}">
-                  <a16:creationId xmlns:a16="http://schemas.microsoft.com/office/drawing/2014/main" id="{9FD8C567-591F-09FA-FA54-CD27D6861372}"/>
+                  <a16:creationId xmlns:a16="http://schemas.microsoft.com/office/drawing/2014/main" id="{388E13C7-D475-56AB-CF58-B552A70D1413}"/>
                 </a:ext>
               </a:extLst>
             </p:cNvPr>
@@ -4209,7 +4209,7 @@
             <p:cNvPr id="14" name="Oval 13">
               <a:extLst>
                 <a:ext uri="{FF2B5EF4-FFF2-40B4-BE49-F238E27FC236}">
-                  <a16:creationId xmlns:a16="http://schemas.microsoft.com/office/drawing/2014/main" id="{BF9CC8A1-63D8-58FA-0BB1-EFC1EB25A810}"/>
+                  <a16:creationId xmlns:a16="http://schemas.microsoft.com/office/drawing/2014/main" id="{28A2F204-4B06-007F-334F-B8EFAD6C0B60}"/>
                 </a:ext>
               </a:extLst>
             </p:cNvPr>
@@ -4277,7 +4277,7 @@
             <p:cNvPr id="16" name="Graphic 15">
               <a:extLst>
                 <a:ext uri="{FF2B5EF4-FFF2-40B4-BE49-F238E27FC236}">
-                  <a16:creationId xmlns:a16="http://schemas.microsoft.com/office/drawing/2014/main" id="{471A2320-FF7E-041D-D06B-69D073B04EE6}"/>
+                  <a16:creationId xmlns:a16="http://schemas.microsoft.com/office/drawing/2014/main" id="{6341997F-28AD-A3D8-AD4F-BCB0B8C51A9F}"/>
                 </a:ext>
               </a:extLst>
             </p:cNvPr>
@@ -4313,7 +4313,7 @@
             <p:cNvPr id="17" name="TextBox 16">
               <a:extLst>
                 <a:ext uri="{FF2B5EF4-FFF2-40B4-BE49-F238E27FC236}">
-                  <a16:creationId xmlns:a16="http://schemas.microsoft.com/office/drawing/2014/main" id="{69B6A6C7-5131-0D0A-E00B-9AD5ADA9D089}"/>
+                  <a16:creationId xmlns:a16="http://schemas.microsoft.com/office/drawing/2014/main" id="{7723C71F-4051-6CEA-D863-AC6B7929C2A2}"/>
                 </a:ext>
               </a:extLst>
             </p:cNvPr>
@@ -4375,7 +4375,7 @@
           <p:cNvPr id="24" name="!!Stage_Sub_Card_2!!">
             <a:extLst>
               <a:ext uri="{FF2B5EF4-FFF2-40B4-BE49-F238E27FC236}">
-                <a16:creationId xmlns:a16="http://schemas.microsoft.com/office/drawing/2014/main" id="{C582203B-E96F-B37A-88C7-03E4B450E4E4}"/>
+                <a16:creationId xmlns:a16="http://schemas.microsoft.com/office/drawing/2014/main" id="{2D1E0984-E1C5-7CB4-E217-AFAF8BFCE3D1}"/>
               </a:ext>
             </a:extLst>
           </p:cNvPr>
@@ -4395,7 +4395,7 @@
             <p:cNvPr id="19" name="Rectangle: Rounded Corners 18">
               <a:extLst>
                 <a:ext uri="{FF2B5EF4-FFF2-40B4-BE49-F238E27FC236}">
-                  <a16:creationId xmlns:a16="http://schemas.microsoft.com/office/drawing/2014/main" id="{DEF86FE3-1FF6-DFCC-B5C3-F7F659EBE0E9}"/>
+                  <a16:creationId xmlns:a16="http://schemas.microsoft.com/office/drawing/2014/main" id="{3A5C71BA-82C4-CB2E-B882-23D76C18150A}"/>
                 </a:ext>
               </a:extLst>
             </p:cNvPr>
@@ -4449,7 +4449,7 @@
             <p:cNvPr id="20" name="Oval 19">
               <a:extLst>
                 <a:ext uri="{FF2B5EF4-FFF2-40B4-BE49-F238E27FC236}">
-                  <a16:creationId xmlns:a16="http://schemas.microsoft.com/office/drawing/2014/main" id="{FE8ECDAC-4375-B2AA-5C6B-5AE9EFAF7FEE}"/>
+                  <a16:creationId xmlns:a16="http://schemas.microsoft.com/office/drawing/2014/main" id="{950E4013-1BF4-17D5-4BAE-FD7DCF84DDD0}"/>
                 </a:ext>
               </a:extLst>
             </p:cNvPr>
@@ -4517,7 +4517,7 @@
             <p:cNvPr id="22" name="Graphic 21">
               <a:extLst>
                 <a:ext uri="{FF2B5EF4-FFF2-40B4-BE49-F238E27FC236}">
-                  <a16:creationId xmlns:a16="http://schemas.microsoft.com/office/drawing/2014/main" id="{5972D9DF-404A-C8D7-FC9A-9FA11E3EFC27}"/>
+                  <a16:creationId xmlns:a16="http://schemas.microsoft.com/office/drawing/2014/main" id="{CCD0F62A-DA5F-6DF3-95A1-356CBA0DF7C9}"/>
                 </a:ext>
               </a:extLst>
             </p:cNvPr>
@@ -4553,7 +4553,7 @@
             <p:cNvPr id="23" name="TextBox 22">
               <a:extLst>
                 <a:ext uri="{FF2B5EF4-FFF2-40B4-BE49-F238E27FC236}">
-                  <a16:creationId xmlns:a16="http://schemas.microsoft.com/office/drawing/2014/main" id="{4CEB6DAB-8B5B-DE25-A23A-28AFF3ED3CC6}"/>
+                  <a16:creationId xmlns:a16="http://schemas.microsoft.com/office/drawing/2014/main" id="{F07A61CF-802A-3C81-9FDA-B904D2E9D751}"/>
                 </a:ext>
               </a:extLst>
             </p:cNvPr>
@@ -4615,7 +4615,7 @@
           <p:cNvPr id="30" name="!!Stage_Sub_Card_3!!">
             <a:extLst>
               <a:ext uri="{FF2B5EF4-FFF2-40B4-BE49-F238E27FC236}">
-                <a16:creationId xmlns:a16="http://schemas.microsoft.com/office/drawing/2014/main" id="{07996AB5-C81A-2317-3447-2B746F258EFC}"/>
+                <a16:creationId xmlns:a16="http://schemas.microsoft.com/office/drawing/2014/main" id="{75C2485C-6499-3D43-34D4-459309992AC6}"/>
               </a:ext>
             </a:extLst>
           </p:cNvPr>
@@ -4635,7 +4635,7 @@
             <p:cNvPr id="25" name="Rectangle: Rounded Corners 24">
               <a:extLst>
                 <a:ext uri="{FF2B5EF4-FFF2-40B4-BE49-F238E27FC236}">
-                  <a16:creationId xmlns:a16="http://schemas.microsoft.com/office/drawing/2014/main" id="{BBFD0742-2A0A-A76F-D21A-43B6E10B7B6A}"/>
+                  <a16:creationId xmlns:a16="http://schemas.microsoft.com/office/drawing/2014/main" id="{00FE3134-4076-188A-0F47-781F2924BCF9}"/>
                 </a:ext>
               </a:extLst>
             </p:cNvPr>
@@ -4689,7 +4689,7 @@
             <p:cNvPr id="26" name="Oval 25">
               <a:extLst>
                 <a:ext uri="{FF2B5EF4-FFF2-40B4-BE49-F238E27FC236}">
-                  <a16:creationId xmlns:a16="http://schemas.microsoft.com/office/drawing/2014/main" id="{675AAE08-CB81-1202-38C6-44FDBBDFC05E}"/>
+                  <a16:creationId xmlns:a16="http://schemas.microsoft.com/office/drawing/2014/main" id="{A38E346D-7457-385A-1169-4FFDFFDBAC09}"/>
                 </a:ext>
               </a:extLst>
             </p:cNvPr>
@@ -4757,7 +4757,7 @@
             <p:cNvPr id="28" name="Graphic 27">
               <a:extLst>
                 <a:ext uri="{FF2B5EF4-FFF2-40B4-BE49-F238E27FC236}">
-                  <a16:creationId xmlns:a16="http://schemas.microsoft.com/office/drawing/2014/main" id="{B17E0250-2D1B-5BC9-18CB-99E1EDCD40F5}"/>
+                  <a16:creationId xmlns:a16="http://schemas.microsoft.com/office/drawing/2014/main" id="{9639DF32-859D-4A1E-EB7D-E717C5F21B50}"/>
                 </a:ext>
               </a:extLst>
             </p:cNvPr>
@@ -4793,7 +4793,7 @@
             <p:cNvPr id="29" name="TextBox 28">
               <a:extLst>
                 <a:ext uri="{FF2B5EF4-FFF2-40B4-BE49-F238E27FC236}">
-                  <a16:creationId xmlns:a16="http://schemas.microsoft.com/office/drawing/2014/main" id="{CCBEA16D-756C-5E2C-C22B-5754FBEE5CF6}"/>
+                  <a16:creationId xmlns:a16="http://schemas.microsoft.com/office/drawing/2014/main" id="{CB77CDB2-2F5B-D377-A8DA-3779DDD1DEEE}"/>
                 </a:ext>
               </a:extLst>
             </p:cNvPr>
@@ -4855,7 +4855,7 @@
           <p:cNvPr id="31" name="!!Anchor_Source_Footer!!">
             <a:extLst>
               <a:ext uri="{FF2B5EF4-FFF2-40B4-BE49-F238E27FC236}">
-                <a16:creationId xmlns:a16="http://schemas.microsoft.com/office/drawing/2014/main" id="{5208C626-D7C2-A05C-6680-476733D85275}"/>
+                <a16:creationId xmlns:a16="http://schemas.microsoft.com/office/drawing/2014/main" id="{779EC69A-3334-9717-2E07-CBF9F8D1D612}"/>
               </a:ext>
             </a:extLst>
           </p:cNvPr>
@@ -4893,7 +4893,7 @@
     </p:spTree>
     <p:extLst>
       <p:ext uri="{BB962C8B-B14F-4D97-AF65-F5344CB8AC3E}">
-        <p14:creationId xmlns:p14="http://schemas.microsoft.com/office/powerpoint/2010/main" val="3840402858"/>
+        <p14:creationId xmlns:p14="http://schemas.microsoft.com/office/powerpoint/2010/main" val="3187329398"/>
       </p:ext>
     </p:extLst>
   </p:cSld>
@@ -4924,9 +4924,6 @@
                     <p:cTn id="3" fill="hold">
                       <p:stCondLst>
                         <p:cond delay="indefinite"/>
-                        <p:cond evt="onBegin" delay="0">
-                          <p:tn val="2"/>
-                        </p:cond>
                       </p:stCondLst>
                       <p:childTnLst>
                         <p:par>
@@ -4936,9 +4933,9 @@
                             </p:stCondLst>
                             <p:childTnLst>
                               <p:par>
-                                <p:cTn id="5" presetID="2" presetClass="entr" presetSubtype="1" accel="50000" decel="50000" fill="hold" nodeType="withEffect">
+                                <p:cTn id="5" presetID="2" presetClass="entr" presetSubtype="1" accel="50000" decel="50000" fill="hold" nodeType="clickEffect">
                                   <p:stCondLst>
-                                    <p:cond delay="120"/>
+                                    <p:cond delay="0"/>
                                   </p:stCondLst>
                                   <p:childTnLst>
                                     <p:set>
@@ -5008,15 +5005,33 @@
                                   </p:childTnLst>
                                 </p:cTn>
                               </p:par>
+                            </p:childTnLst>
+                          </p:cTn>
+                        </p:par>
+                      </p:childTnLst>
+                    </p:cTn>
+                  </p:par>
+                  <p:par>
+                    <p:cTn id="9" fill="hold">
+                      <p:stCondLst>
+                        <p:cond delay="indefinite"/>
+                      </p:stCondLst>
+                      <p:childTnLst>
+                        <p:par>
+                          <p:cTn id="10" fill="hold">
+                            <p:stCondLst>
+                              <p:cond delay="0"/>
+                            </p:stCondLst>
+                            <p:childTnLst>
                               <p:par>
-                                <p:cTn id="9" presetID="2" presetClass="entr" presetSubtype="1" accel="50000" decel="50000" fill="hold" nodeType="withEffect">
+                                <p:cTn id="11" presetID="2" presetClass="entr" presetSubtype="1" accel="50000" decel="50000" fill="hold" nodeType="clickEffect">
                                   <p:stCondLst>
-                                    <p:cond delay="240"/>
+                                    <p:cond delay="0"/>
                                   </p:stCondLst>
                                   <p:childTnLst>
                                     <p:set>
                                       <p:cBhvr>
-                                        <p:cTn id="10" dur="1" fill="hold">
+                                        <p:cTn id="12" dur="1" fill="hold">
                                           <p:stCondLst>
                                             <p:cond delay="0"/>
                                           </p:stCondLst>
@@ -5034,7 +5049,7 @@
                                     </p:set>
                                     <p:anim calcmode="lin" valueType="num">
                                       <p:cBhvr additive="base">
-                                        <p:cTn id="11" dur="500" fill="hold"/>
+                                        <p:cTn id="13" dur="500" fill="hold"/>
                                         <p:tgtEl>
                                           <p:spTgt spid="24"/>
                                         </p:tgtEl>
@@ -5057,7 +5072,7 @@
                                     </p:anim>
                                     <p:anim calcmode="lin" valueType="num">
                                       <p:cBhvr additive="base">
-                                        <p:cTn id="12" dur="500" fill="hold"/>
+                                        <p:cTn id="14" dur="500" fill="hold"/>
                                         <p:tgtEl>
                                           <p:spTgt spid="24"/>
                                         </p:tgtEl>
@@ -5081,15 +5096,33 @@
                                   </p:childTnLst>
                                 </p:cTn>
                               </p:par>
+                            </p:childTnLst>
+                          </p:cTn>
+                        </p:par>
+                      </p:childTnLst>
+                    </p:cTn>
+                  </p:par>
+                  <p:par>
+                    <p:cTn id="15" fill="hold">
+                      <p:stCondLst>
+                        <p:cond delay="indefinite"/>
+                      </p:stCondLst>
+                      <p:childTnLst>
+                        <p:par>
+                          <p:cTn id="16" fill="hold">
+                            <p:stCondLst>
+                              <p:cond delay="0"/>
+                            </p:stCondLst>
+                            <p:childTnLst>
                               <p:par>
-                                <p:cTn id="13" presetID="2" presetClass="entr" presetSubtype="1" accel="50000" decel="50000" fill="hold" nodeType="withEffect">
+                                <p:cTn id="17" presetID="2" presetClass="entr" presetSubtype="1" accel="50000" decel="50000" fill="hold" nodeType="clickEffect">
                                   <p:stCondLst>
-                                    <p:cond delay="360"/>
+                                    <p:cond delay="0"/>
                                   </p:stCondLst>
                                   <p:childTnLst>
                                     <p:set>
                                       <p:cBhvr>
-                                        <p:cTn id="14" dur="1" fill="hold">
+                                        <p:cTn id="18" dur="1" fill="hold">
                                           <p:stCondLst>
                                             <p:cond delay="0"/>
                                           </p:stCondLst>
@@ -5107,7 +5140,7 @@
                                     </p:set>
                                     <p:anim calcmode="lin" valueType="num">
                                       <p:cBhvr additive="base">
-                                        <p:cTn id="15" dur="500" fill="hold"/>
+                                        <p:cTn id="19" dur="500" fill="hold"/>
                                         <p:tgtEl>
                                           <p:spTgt spid="30"/>
                                         </p:tgtEl>
@@ -5130,7 +5163,7 @@
                                     </p:anim>
                                     <p:anim calcmode="lin" valueType="num">
                                       <p:cBhvr additive="base">
-                                        <p:cTn id="16" dur="500" fill="hold"/>
+                                        <p:cTn id="20" dur="500" fill="hold"/>
                                         <p:tgtEl>
                                           <p:spTgt spid="30"/>
                                         </p:tgtEl>
@@ -5215,7 +5248,7 @@
           <p:cNvPr id="2" name="!!Anchor_Kicker_Rail!!">
             <a:extLst>
               <a:ext uri="{FF2B5EF4-FFF2-40B4-BE49-F238E27FC236}">
-                <a16:creationId xmlns:a16="http://schemas.microsoft.com/office/drawing/2014/main" id="{C581F812-ABA7-2AAD-452D-48568A461430}"/>
+                <a16:creationId xmlns:a16="http://schemas.microsoft.com/office/drawing/2014/main" id="{A3C39ABF-9B16-5536-D790-EB437EFB109E}"/>
               </a:ext>
             </a:extLst>
           </p:cNvPr>
@@ -5255,7 +5288,7 @@
           <p:cNvPr id="3" name="!!Anchor_Slide_Tracker!!">
             <a:extLst>
               <a:ext uri="{FF2B5EF4-FFF2-40B4-BE49-F238E27FC236}">
-                <a16:creationId xmlns:a16="http://schemas.microsoft.com/office/drawing/2014/main" id="{6042BD29-A4E2-49E3-C9B1-A7B3FB5AB833}"/>
+                <a16:creationId xmlns:a16="http://schemas.microsoft.com/office/drawing/2014/main" id="{19390B49-20D4-5C47-6527-78501D197165}"/>
               </a:ext>
             </a:extLst>
           </p:cNvPr>
@@ -5296,7 +5329,7 @@
           <p:cNvPr id="4" name="!!Anchor_Assertion_Title!!">
             <a:extLst>
               <a:ext uri="{FF2B5EF4-FFF2-40B4-BE49-F238E27FC236}">
-                <a16:creationId xmlns:a16="http://schemas.microsoft.com/office/drawing/2014/main" id="{72F160C4-DBB9-F734-3CFE-35F9641ECF89}"/>
+                <a16:creationId xmlns:a16="http://schemas.microsoft.com/office/drawing/2014/main" id="{190FDC3A-B687-ED54-EC9C-AD1EAE165548}"/>
               </a:ext>
             </a:extLst>
           </p:cNvPr>
@@ -5336,7 +5369,7 @@
           <p:cNvPr id="6" name="!!Stage_Hero_Container!!">
             <a:extLst>
               <a:ext uri="{FF2B5EF4-FFF2-40B4-BE49-F238E27FC236}">
-                <a16:creationId xmlns:a16="http://schemas.microsoft.com/office/drawing/2014/main" id="{C6C9B212-66A4-248E-6E9D-372BF6CBFB1B}"/>
+                <a16:creationId xmlns:a16="http://schemas.microsoft.com/office/drawing/2014/main" id="{DF0032B2-B9C8-1182-5812-102F2AFC1828}"/>
               </a:ext>
             </a:extLst>
           </p:cNvPr>
@@ -5377,7 +5410,7 @@
           <p:cNvPr id="12" name="!!Stage_Sub_Card_1!!">
             <a:extLst>
               <a:ext uri="{FF2B5EF4-FFF2-40B4-BE49-F238E27FC236}">
-                <a16:creationId xmlns:a16="http://schemas.microsoft.com/office/drawing/2014/main" id="{48419D12-7608-930F-0910-DBE88FD19024}"/>
+                <a16:creationId xmlns:a16="http://schemas.microsoft.com/office/drawing/2014/main" id="{943029AA-F65D-6EFC-C1B9-2BE8230120DF}"/>
               </a:ext>
             </a:extLst>
           </p:cNvPr>
@@ -5397,7 +5430,7 @@
             <p:cNvPr id="7" name="Rectangle: Rounded Corners 6">
               <a:extLst>
                 <a:ext uri="{FF2B5EF4-FFF2-40B4-BE49-F238E27FC236}">
-                  <a16:creationId xmlns:a16="http://schemas.microsoft.com/office/drawing/2014/main" id="{090C1DDA-0DC3-DA85-E163-9277B9CA8085}"/>
+                  <a16:creationId xmlns:a16="http://schemas.microsoft.com/office/drawing/2014/main" id="{AAA54C43-F99A-F3E5-9BE2-1E058551A8F3}"/>
                 </a:ext>
               </a:extLst>
             </p:cNvPr>
@@ -5451,7 +5484,7 @@
             <p:cNvPr id="8" name="Oval 7">
               <a:extLst>
                 <a:ext uri="{FF2B5EF4-FFF2-40B4-BE49-F238E27FC236}">
-                  <a16:creationId xmlns:a16="http://schemas.microsoft.com/office/drawing/2014/main" id="{A1DB5797-7B67-1C00-6A4C-41209474A8E9}"/>
+                  <a16:creationId xmlns:a16="http://schemas.microsoft.com/office/drawing/2014/main" id="{D12C88E6-5B46-2588-9BBC-1ADD7E67437A}"/>
                 </a:ext>
               </a:extLst>
             </p:cNvPr>
@@ -5519,7 +5552,7 @@
             <p:cNvPr id="10" name="Graphic 9">
               <a:extLst>
                 <a:ext uri="{FF2B5EF4-FFF2-40B4-BE49-F238E27FC236}">
-                  <a16:creationId xmlns:a16="http://schemas.microsoft.com/office/drawing/2014/main" id="{63E01B56-4393-C770-0786-0ABFCD84CA44}"/>
+                  <a16:creationId xmlns:a16="http://schemas.microsoft.com/office/drawing/2014/main" id="{7E1E1557-AFD1-48F4-D468-A9A4CAA948A8}"/>
                 </a:ext>
               </a:extLst>
             </p:cNvPr>
@@ -5555,7 +5588,7 @@
             <p:cNvPr id="11" name="TextBox 10">
               <a:extLst>
                 <a:ext uri="{FF2B5EF4-FFF2-40B4-BE49-F238E27FC236}">
-                  <a16:creationId xmlns:a16="http://schemas.microsoft.com/office/drawing/2014/main" id="{3FFAAAA9-2129-9DDD-A1FF-04EB404BF121}"/>
+                  <a16:creationId xmlns:a16="http://schemas.microsoft.com/office/drawing/2014/main" id="{B2436E2B-F032-3CAF-0417-80F147F6925D}"/>
                 </a:ext>
               </a:extLst>
             </p:cNvPr>
@@ -5617,7 +5650,7 @@
           <p:cNvPr id="18" name="!!Stage_Sub_Card_2!!">
             <a:extLst>
               <a:ext uri="{FF2B5EF4-FFF2-40B4-BE49-F238E27FC236}">
-                <a16:creationId xmlns:a16="http://schemas.microsoft.com/office/drawing/2014/main" id="{7F88643A-FBF4-9B7B-AED4-2898F6302BB6}"/>
+                <a16:creationId xmlns:a16="http://schemas.microsoft.com/office/drawing/2014/main" id="{5F454539-CDAD-5C08-390B-2D32E53192C0}"/>
               </a:ext>
             </a:extLst>
           </p:cNvPr>
@@ -5637,7 +5670,7 @@
             <p:cNvPr id="13" name="Rectangle: Rounded Corners 12">
               <a:extLst>
                 <a:ext uri="{FF2B5EF4-FFF2-40B4-BE49-F238E27FC236}">
-                  <a16:creationId xmlns:a16="http://schemas.microsoft.com/office/drawing/2014/main" id="{55D83DB4-E0B8-4DE8-EA05-D37FCC04B6C8}"/>
+                  <a16:creationId xmlns:a16="http://schemas.microsoft.com/office/drawing/2014/main" id="{D689B63B-F837-7D9B-F12E-601C35CF66CD}"/>
                 </a:ext>
               </a:extLst>
             </p:cNvPr>
@@ -5691,7 +5724,7 @@
             <p:cNvPr id="14" name="Oval 13">
               <a:extLst>
                 <a:ext uri="{FF2B5EF4-FFF2-40B4-BE49-F238E27FC236}">
-                  <a16:creationId xmlns:a16="http://schemas.microsoft.com/office/drawing/2014/main" id="{0969C933-0C6F-DB09-131C-2E228F4B128C}"/>
+                  <a16:creationId xmlns:a16="http://schemas.microsoft.com/office/drawing/2014/main" id="{3403E67C-B177-A33C-DC87-636CE70AD274}"/>
                 </a:ext>
               </a:extLst>
             </p:cNvPr>
@@ -5759,7 +5792,7 @@
             <p:cNvPr id="16" name="Graphic 15">
               <a:extLst>
                 <a:ext uri="{FF2B5EF4-FFF2-40B4-BE49-F238E27FC236}">
-                  <a16:creationId xmlns:a16="http://schemas.microsoft.com/office/drawing/2014/main" id="{F2EDEE26-1B19-20FB-18AC-BD92CB75975A}"/>
+                  <a16:creationId xmlns:a16="http://schemas.microsoft.com/office/drawing/2014/main" id="{255667D1-2E94-02BF-A400-D22ECDB40CBC}"/>
                 </a:ext>
               </a:extLst>
             </p:cNvPr>
@@ -5795,7 +5828,7 @@
             <p:cNvPr id="17" name="TextBox 16">
               <a:extLst>
                 <a:ext uri="{FF2B5EF4-FFF2-40B4-BE49-F238E27FC236}">
-                  <a16:creationId xmlns:a16="http://schemas.microsoft.com/office/drawing/2014/main" id="{90E49469-D9C6-F14F-5B34-8AC22F7E33A5}"/>
+                  <a16:creationId xmlns:a16="http://schemas.microsoft.com/office/drawing/2014/main" id="{AF2E0D49-7E30-3128-2313-BE8C0147ED35}"/>
                 </a:ext>
               </a:extLst>
             </p:cNvPr>
@@ -5857,7 +5890,7 @@
           <p:cNvPr id="24" name="!!Stage_Sub_Card_3!!">
             <a:extLst>
               <a:ext uri="{FF2B5EF4-FFF2-40B4-BE49-F238E27FC236}">
-                <a16:creationId xmlns:a16="http://schemas.microsoft.com/office/drawing/2014/main" id="{3C12F895-8274-B1F7-83A6-EF3613E6B2DF}"/>
+                <a16:creationId xmlns:a16="http://schemas.microsoft.com/office/drawing/2014/main" id="{3A7A3990-BEE7-A1B5-2D56-DFBF4F6673FC}"/>
               </a:ext>
             </a:extLst>
           </p:cNvPr>
@@ -5877,7 +5910,7 @@
             <p:cNvPr id="19" name="Rectangle: Rounded Corners 18">
               <a:extLst>
                 <a:ext uri="{FF2B5EF4-FFF2-40B4-BE49-F238E27FC236}">
-                  <a16:creationId xmlns:a16="http://schemas.microsoft.com/office/drawing/2014/main" id="{D02B4211-B415-E1E2-AD1E-D5B852067982}"/>
+                  <a16:creationId xmlns:a16="http://schemas.microsoft.com/office/drawing/2014/main" id="{6BB70502-E5FB-E0D2-045A-AFD9E4589FC9}"/>
                 </a:ext>
               </a:extLst>
             </p:cNvPr>
@@ -5931,7 +5964,7 @@
             <p:cNvPr id="20" name="Oval 19">
               <a:extLst>
                 <a:ext uri="{FF2B5EF4-FFF2-40B4-BE49-F238E27FC236}">
-                  <a16:creationId xmlns:a16="http://schemas.microsoft.com/office/drawing/2014/main" id="{A5F8CA77-F61A-7AC0-ED2C-957660273E11}"/>
+                  <a16:creationId xmlns:a16="http://schemas.microsoft.com/office/drawing/2014/main" id="{223986A4-FB7E-B745-6626-F11BC6D79049}"/>
                 </a:ext>
               </a:extLst>
             </p:cNvPr>
@@ -5999,7 +6032,7 @@
             <p:cNvPr id="22" name="Graphic 21">
               <a:extLst>
                 <a:ext uri="{FF2B5EF4-FFF2-40B4-BE49-F238E27FC236}">
-                  <a16:creationId xmlns:a16="http://schemas.microsoft.com/office/drawing/2014/main" id="{BD3E7C00-5F45-6F06-FD60-40765F55CC68}"/>
+                  <a16:creationId xmlns:a16="http://schemas.microsoft.com/office/drawing/2014/main" id="{54D660C7-AE17-FBEE-F479-8FE264E199C7}"/>
                 </a:ext>
               </a:extLst>
             </p:cNvPr>
@@ -6035,7 +6068,7 @@
             <p:cNvPr id="23" name="TextBox 22">
               <a:extLst>
                 <a:ext uri="{FF2B5EF4-FFF2-40B4-BE49-F238E27FC236}">
-                  <a16:creationId xmlns:a16="http://schemas.microsoft.com/office/drawing/2014/main" id="{BD72C355-1755-90D1-89E5-C7E48EAC6E7A}"/>
+                  <a16:creationId xmlns:a16="http://schemas.microsoft.com/office/drawing/2014/main" id="{984072D8-9A30-88E3-F6CF-3F84889A67A2}"/>
                 </a:ext>
               </a:extLst>
             </p:cNvPr>
@@ -6097,7 +6130,7 @@
           <p:cNvPr id="25" name="!!Anchor_Source_Footer!!">
             <a:extLst>
               <a:ext uri="{FF2B5EF4-FFF2-40B4-BE49-F238E27FC236}">
-                <a16:creationId xmlns:a16="http://schemas.microsoft.com/office/drawing/2014/main" id="{00C5D6D5-B4DC-CD15-DD32-E0A410678141}"/>
+                <a16:creationId xmlns:a16="http://schemas.microsoft.com/office/drawing/2014/main" id="{A6DDA124-E34B-CE08-08C9-8ADE196E8651}"/>
               </a:ext>
             </a:extLst>
           </p:cNvPr>
@@ -6135,7 +6168,7 @@
     </p:spTree>
     <p:extLst>
       <p:ext uri="{BB962C8B-B14F-4D97-AF65-F5344CB8AC3E}">
-        <p14:creationId xmlns:p14="http://schemas.microsoft.com/office/powerpoint/2010/main" val="1266772223"/>
+        <p14:creationId xmlns:p14="http://schemas.microsoft.com/office/powerpoint/2010/main" val="96839406"/>
       </p:ext>
     </p:extLst>
   </p:cSld>
@@ -6166,9 +6199,6 @@
                     <p:cTn id="3" fill="hold">
                       <p:stCondLst>
                         <p:cond delay="indefinite"/>
-                        <p:cond evt="onBegin" delay="0">
-                          <p:tn val="2"/>
-                        </p:cond>
                       </p:stCondLst>
                       <p:childTnLst>
                         <p:par>
@@ -6178,9 +6208,9 @@
                             </p:stCondLst>
                             <p:childTnLst>
                               <p:par>
-                                <p:cTn id="5" presetID="2" presetClass="entr" presetSubtype="1" accel="50000" decel="50000" fill="hold" nodeType="withEffect">
+                                <p:cTn id="5" presetID="2" presetClass="entr" presetSubtype="1" accel="50000" decel="50000" fill="hold" nodeType="clickEffect">
                                   <p:stCondLst>
-                                    <p:cond delay="120"/>
+                                    <p:cond delay="0"/>
                                   </p:stCondLst>
                                   <p:childTnLst>
                                     <p:set>
@@ -6250,15 +6280,33 @@
                                   </p:childTnLst>
                                 </p:cTn>
                               </p:par>
+                            </p:childTnLst>
+                          </p:cTn>
+                        </p:par>
+                      </p:childTnLst>
+                    </p:cTn>
+                  </p:par>
+                  <p:par>
+                    <p:cTn id="9" fill="hold">
+                      <p:stCondLst>
+                        <p:cond delay="indefinite"/>
+                      </p:stCondLst>
+                      <p:childTnLst>
+                        <p:par>
+                          <p:cTn id="10" fill="hold">
+                            <p:stCondLst>
+                              <p:cond delay="0"/>
+                            </p:stCondLst>
+                            <p:childTnLst>
                               <p:par>
-                                <p:cTn id="9" presetID="2" presetClass="entr" presetSubtype="1" accel="50000" decel="50000" fill="hold" nodeType="withEffect">
+                                <p:cTn id="11" presetID="2" presetClass="entr" presetSubtype="1" accel="50000" decel="50000" fill="hold" nodeType="clickEffect">
                                   <p:stCondLst>
-                                    <p:cond delay="240"/>
+                                    <p:cond delay="0"/>
                                   </p:stCondLst>
                                   <p:childTnLst>
                                     <p:set>
                                       <p:cBhvr>
-                                        <p:cTn id="10" dur="1" fill="hold">
+                                        <p:cTn id="12" dur="1" fill="hold">
                                           <p:stCondLst>
                                             <p:cond delay="0"/>
                                           </p:stCondLst>
@@ -6276,7 +6324,7 @@
                                     </p:set>
                                     <p:anim calcmode="lin" valueType="num">
                                       <p:cBhvr additive="base">
-                                        <p:cTn id="11" dur="500" fill="hold"/>
+                                        <p:cTn id="13" dur="500" fill="hold"/>
                                         <p:tgtEl>
                                           <p:spTgt spid="18"/>
                                         </p:tgtEl>
@@ -6299,7 +6347,7 @@
                                     </p:anim>
                                     <p:anim calcmode="lin" valueType="num">
                                       <p:cBhvr additive="base">
-                                        <p:cTn id="12" dur="500" fill="hold"/>
+                                        <p:cTn id="14" dur="500" fill="hold"/>
                                         <p:tgtEl>
                                           <p:spTgt spid="18"/>
                                         </p:tgtEl>
@@ -6323,15 +6371,33 @@
                                   </p:childTnLst>
                                 </p:cTn>
                               </p:par>
+                            </p:childTnLst>
+                          </p:cTn>
+                        </p:par>
+                      </p:childTnLst>
+                    </p:cTn>
+                  </p:par>
+                  <p:par>
+                    <p:cTn id="15" fill="hold">
+                      <p:stCondLst>
+                        <p:cond delay="indefinite"/>
+                      </p:stCondLst>
+                      <p:childTnLst>
+                        <p:par>
+                          <p:cTn id="16" fill="hold">
+                            <p:stCondLst>
+                              <p:cond delay="0"/>
+                            </p:stCondLst>
+                            <p:childTnLst>
                               <p:par>
-                                <p:cTn id="13" presetID="2" presetClass="entr" presetSubtype="1" accel="50000" decel="50000" fill="hold" nodeType="withEffect">
+                                <p:cTn id="17" presetID="2" presetClass="entr" presetSubtype="1" accel="50000" decel="50000" fill="hold" nodeType="clickEffect">
                                   <p:stCondLst>
-                                    <p:cond delay="360"/>
+                                    <p:cond delay="0"/>
                                   </p:stCondLst>
                                   <p:childTnLst>
                                     <p:set>
                                       <p:cBhvr>
-                                        <p:cTn id="14" dur="1" fill="hold">
+                                        <p:cTn id="18" dur="1" fill="hold">
                                           <p:stCondLst>
                                             <p:cond delay="0"/>
                                           </p:stCondLst>
@@ -6349,7 +6415,7 @@
                                     </p:set>
                                     <p:anim calcmode="lin" valueType="num">
                                       <p:cBhvr additive="base">
-                                        <p:cTn id="15" dur="500" fill="hold"/>
+                                        <p:cTn id="19" dur="500" fill="hold"/>
                                         <p:tgtEl>
                                           <p:spTgt spid="24"/>
                                         </p:tgtEl>
@@ -6372,7 +6438,7 @@
                                     </p:anim>
                                     <p:anim calcmode="lin" valueType="num">
                                       <p:cBhvr additive="base">
-                                        <p:cTn id="16" dur="500" fill="hold"/>
+                                        <p:cTn id="20" dur="500" fill="hold"/>
                                         <p:tgtEl>
                                           <p:spTgt spid="24"/>
                                         </p:tgtEl>
@@ -6457,7 +6523,7 @@
           <p:cNvPr id="2" name="!!Anchor_Kicker_Rail!!">
             <a:extLst>
               <a:ext uri="{FF2B5EF4-FFF2-40B4-BE49-F238E27FC236}">
-                <a16:creationId xmlns:a16="http://schemas.microsoft.com/office/drawing/2014/main" id="{8EDA12AE-92A0-451D-1AD3-8113790FF552}"/>
+                <a16:creationId xmlns:a16="http://schemas.microsoft.com/office/drawing/2014/main" id="{B3E126F8-9C4D-782E-A086-25228783CB0D}"/>
               </a:ext>
             </a:extLst>
           </p:cNvPr>
@@ -6497,7 +6563,7 @@
           <p:cNvPr id="3" name="!!Anchor_Slide_Tracker!!">
             <a:extLst>
               <a:ext uri="{FF2B5EF4-FFF2-40B4-BE49-F238E27FC236}">
-                <a16:creationId xmlns:a16="http://schemas.microsoft.com/office/drawing/2014/main" id="{9D89CF36-D434-CA64-A74B-677F601E28FD}"/>
+                <a16:creationId xmlns:a16="http://schemas.microsoft.com/office/drawing/2014/main" id="{D66D3F9F-B90E-CFF3-8E95-C20396880067}"/>
               </a:ext>
             </a:extLst>
           </p:cNvPr>
@@ -6538,7 +6604,7 @@
           <p:cNvPr id="4" name="!!Anchor_Assertion_Title!!">
             <a:extLst>
               <a:ext uri="{FF2B5EF4-FFF2-40B4-BE49-F238E27FC236}">
-                <a16:creationId xmlns:a16="http://schemas.microsoft.com/office/drawing/2014/main" id="{177B3AF7-34A5-A71D-A99E-709D0DFE09DE}"/>
+                <a16:creationId xmlns:a16="http://schemas.microsoft.com/office/drawing/2014/main" id="{9E195254-AE79-266F-11E0-8C761D20019F}"/>
               </a:ext>
             </a:extLst>
           </p:cNvPr>
@@ -6584,7 +6650,7 @@
           <p:cNvPr id="12" name="!!Stage_Hero_Container!!">
             <a:extLst>
               <a:ext uri="{FF2B5EF4-FFF2-40B4-BE49-F238E27FC236}">
-                <a16:creationId xmlns:a16="http://schemas.microsoft.com/office/drawing/2014/main" id="{0051A7E7-10D2-6F63-8418-2A3847370F7B}"/>
+                <a16:creationId xmlns:a16="http://schemas.microsoft.com/office/drawing/2014/main" id="{F671D210-3269-CDAB-BAB6-98383F4A5586}"/>
               </a:ext>
             </a:extLst>
           </p:cNvPr>
@@ -6604,7 +6670,7 @@
             <p:cNvPr id="6" name="Picture 5">
               <a:extLst>
                 <a:ext uri="{FF2B5EF4-FFF2-40B4-BE49-F238E27FC236}">
-                  <a16:creationId xmlns:a16="http://schemas.microsoft.com/office/drawing/2014/main" id="{EE855841-D33C-712E-CA40-62CF6D8A6646}"/>
+                  <a16:creationId xmlns:a16="http://schemas.microsoft.com/office/drawing/2014/main" id="{875824D2-F0AE-E54F-3762-285C137E31A7}"/>
                 </a:ext>
               </a:extLst>
             </p:cNvPr>
@@ -6645,7 +6711,7 @@
             <p:cNvPr id="7" name="Rectangle: Rounded Corners 6">
               <a:extLst>
                 <a:ext uri="{FF2B5EF4-FFF2-40B4-BE49-F238E27FC236}">
-                  <a16:creationId xmlns:a16="http://schemas.microsoft.com/office/drawing/2014/main" id="{8073E0E0-982C-706B-89FE-D40B2250951B}"/>
+                  <a16:creationId xmlns:a16="http://schemas.microsoft.com/office/drawing/2014/main" id="{973C554E-2516-7966-518C-656DB797CE92}"/>
                 </a:ext>
               </a:extLst>
             </p:cNvPr>
@@ -6699,7 +6765,7 @@
             <p:cNvPr id="8" name="Oval 7">
               <a:extLst>
                 <a:ext uri="{FF2B5EF4-FFF2-40B4-BE49-F238E27FC236}">
-                  <a16:creationId xmlns:a16="http://schemas.microsoft.com/office/drawing/2014/main" id="{7B80C15E-4C79-387A-D7F6-CA9A382E4451}"/>
+                  <a16:creationId xmlns:a16="http://schemas.microsoft.com/office/drawing/2014/main" id="{49994AFD-01B1-95BB-3E43-A41A4DB209B9}"/>
                 </a:ext>
               </a:extLst>
             </p:cNvPr>
@@ -6767,7 +6833,7 @@
             <p:cNvPr id="10" name="Graphic 9">
               <a:extLst>
                 <a:ext uri="{FF2B5EF4-FFF2-40B4-BE49-F238E27FC236}">
-                  <a16:creationId xmlns:a16="http://schemas.microsoft.com/office/drawing/2014/main" id="{A164844A-9FF3-8F16-76E0-349F75189CE9}"/>
+                  <a16:creationId xmlns:a16="http://schemas.microsoft.com/office/drawing/2014/main" id="{3C83B20E-FF9E-2993-C315-5B4D2C690ACC}"/>
                 </a:ext>
               </a:extLst>
             </p:cNvPr>
@@ -6803,7 +6869,7 @@
             <p:cNvPr id="11" name="TextBox 10">
               <a:extLst>
                 <a:ext uri="{FF2B5EF4-FFF2-40B4-BE49-F238E27FC236}">
-                  <a16:creationId xmlns:a16="http://schemas.microsoft.com/office/drawing/2014/main" id="{A390A6E5-60B7-DF4C-526F-F1B742378F44}"/>
+                  <a16:creationId xmlns:a16="http://schemas.microsoft.com/office/drawing/2014/main" id="{1F30B201-D870-48F2-1884-7507E6D025BA}"/>
                 </a:ext>
               </a:extLst>
             </p:cNvPr>
@@ -6868,7 +6934,7 @@
           <p:cNvPr id="18" name="!!Stage_Sub_Card_1!!">
             <a:extLst>
               <a:ext uri="{FF2B5EF4-FFF2-40B4-BE49-F238E27FC236}">
-                <a16:creationId xmlns:a16="http://schemas.microsoft.com/office/drawing/2014/main" id="{A750B454-0DFC-8374-DCD3-9EF0123D5943}"/>
+                <a16:creationId xmlns:a16="http://schemas.microsoft.com/office/drawing/2014/main" id="{AE6897B1-6E38-8B90-4F7B-2C09FE462F96}"/>
               </a:ext>
             </a:extLst>
           </p:cNvPr>
@@ -6888,7 +6954,7 @@
             <p:cNvPr id="13" name="Rectangle: Rounded Corners 12">
               <a:extLst>
                 <a:ext uri="{FF2B5EF4-FFF2-40B4-BE49-F238E27FC236}">
-                  <a16:creationId xmlns:a16="http://schemas.microsoft.com/office/drawing/2014/main" id="{00CBE49B-BBB9-5121-081E-577FDE6D89C1}"/>
+                  <a16:creationId xmlns:a16="http://schemas.microsoft.com/office/drawing/2014/main" id="{8B953523-4A39-36A7-12D3-E7314AECB08F}"/>
                 </a:ext>
               </a:extLst>
             </p:cNvPr>
@@ -6942,7 +7008,7 @@
             <p:cNvPr id="14" name="Oval 13">
               <a:extLst>
                 <a:ext uri="{FF2B5EF4-FFF2-40B4-BE49-F238E27FC236}">
-                  <a16:creationId xmlns:a16="http://schemas.microsoft.com/office/drawing/2014/main" id="{B0ED0087-D2BF-D589-243C-59B884C641E9}"/>
+                  <a16:creationId xmlns:a16="http://schemas.microsoft.com/office/drawing/2014/main" id="{E2B79609-1433-C8AB-893D-36100F40AD28}"/>
                 </a:ext>
               </a:extLst>
             </p:cNvPr>
@@ -7010,7 +7076,7 @@
             <p:cNvPr id="16" name="Graphic 15">
               <a:extLst>
                 <a:ext uri="{FF2B5EF4-FFF2-40B4-BE49-F238E27FC236}">
-                  <a16:creationId xmlns:a16="http://schemas.microsoft.com/office/drawing/2014/main" id="{809EF95B-ABCC-5888-9369-59A7392D33FA}"/>
+                  <a16:creationId xmlns:a16="http://schemas.microsoft.com/office/drawing/2014/main" id="{324637EB-1CFC-A785-B54C-27E37941AE8B}"/>
                 </a:ext>
               </a:extLst>
             </p:cNvPr>
@@ -7046,7 +7112,7 @@
             <p:cNvPr id="17" name="TextBox 16">
               <a:extLst>
                 <a:ext uri="{FF2B5EF4-FFF2-40B4-BE49-F238E27FC236}">
-                  <a16:creationId xmlns:a16="http://schemas.microsoft.com/office/drawing/2014/main" id="{16A2C29C-E918-9C30-5DE6-92A41CF76FB4}"/>
+                  <a16:creationId xmlns:a16="http://schemas.microsoft.com/office/drawing/2014/main" id="{B94D0BEE-80E5-26E3-F357-DD9B6D638853}"/>
                 </a:ext>
               </a:extLst>
             </p:cNvPr>
@@ -7108,7 +7174,7 @@
           <p:cNvPr id="24" name="!!Stage_Sub_Card_2!!">
             <a:extLst>
               <a:ext uri="{FF2B5EF4-FFF2-40B4-BE49-F238E27FC236}">
-                <a16:creationId xmlns:a16="http://schemas.microsoft.com/office/drawing/2014/main" id="{BE3E5588-B638-97FD-E388-F15BF5DEF3B2}"/>
+                <a16:creationId xmlns:a16="http://schemas.microsoft.com/office/drawing/2014/main" id="{DF46DD44-C13F-59B5-1ABB-E77E2D782836}"/>
               </a:ext>
             </a:extLst>
           </p:cNvPr>
@@ -7128,7 +7194,7 @@
             <p:cNvPr id="19" name="Rectangle: Rounded Corners 18">
               <a:extLst>
                 <a:ext uri="{FF2B5EF4-FFF2-40B4-BE49-F238E27FC236}">
-                  <a16:creationId xmlns:a16="http://schemas.microsoft.com/office/drawing/2014/main" id="{E06EF194-5E65-213E-3B66-C181428370FE}"/>
+                  <a16:creationId xmlns:a16="http://schemas.microsoft.com/office/drawing/2014/main" id="{8D1611CA-C7B4-9DC9-02DD-CE259585BA77}"/>
                 </a:ext>
               </a:extLst>
             </p:cNvPr>
@@ -7182,7 +7248,7 @@
             <p:cNvPr id="20" name="Oval 19">
               <a:extLst>
                 <a:ext uri="{FF2B5EF4-FFF2-40B4-BE49-F238E27FC236}">
-                  <a16:creationId xmlns:a16="http://schemas.microsoft.com/office/drawing/2014/main" id="{FA1D0E1E-0AE1-D189-2D0B-8D234083B259}"/>
+                  <a16:creationId xmlns:a16="http://schemas.microsoft.com/office/drawing/2014/main" id="{20958AB5-FB5D-5DBB-6014-98FA0D2D68A4}"/>
                 </a:ext>
               </a:extLst>
             </p:cNvPr>
@@ -7250,7 +7316,7 @@
             <p:cNvPr id="22" name="Graphic 21">
               <a:extLst>
                 <a:ext uri="{FF2B5EF4-FFF2-40B4-BE49-F238E27FC236}">
-                  <a16:creationId xmlns:a16="http://schemas.microsoft.com/office/drawing/2014/main" id="{F07FEB7E-786B-E0F9-3196-659F6E4C3031}"/>
+                  <a16:creationId xmlns:a16="http://schemas.microsoft.com/office/drawing/2014/main" id="{93F8E18E-9F6A-7F68-0D7C-EB738BD7C35B}"/>
                 </a:ext>
               </a:extLst>
             </p:cNvPr>
@@ -7286,7 +7352,7 @@
             <p:cNvPr id="23" name="TextBox 22">
               <a:extLst>
                 <a:ext uri="{FF2B5EF4-FFF2-40B4-BE49-F238E27FC236}">
-                  <a16:creationId xmlns:a16="http://schemas.microsoft.com/office/drawing/2014/main" id="{3167294D-1BCB-F66F-402C-B4BE65AD0502}"/>
+                  <a16:creationId xmlns:a16="http://schemas.microsoft.com/office/drawing/2014/main" id="{9D2CFEB5-0539-986F-FDBB-219FE0FA4C2D}"/>
                 </a:ext>
               </a:extLst>
             </p:cNvPr>
@@ -7348,7 +7414,7 @@
           <p:cNvPr id="30" name="!!Stage_Sub_Card_3!!">
             <a:extLst>
               <a:ext uri="{FF2B5EF4-FFF2-40B4-BE49-F238E27FC236}">
-                <a16:creationId xmlns:a16="http://schemas.microsoft.com/office/drawing/2014/main" id="{8AAA1921-F146-BCA8-6F71-5662C5A0A2E1}"/>
+                <a16:creationId xmlns:a16="http://schemas.microsoft.com/office/drawing/2014/main" id="{5D9E5008-D7F4-BB6A-86AA-44C8FCC3679C}"/>
               </a:ext>
             </a:extLst>
           </p:cNvPr>
@@ -7368,7 +7434,7 @@
             <p:cNvPr id="25" name="Rectangle: Rounded Corners 24">
               <a:extLst>
                 <a:ext uri="{FF2B5EF4-FFF2-40B4-BE49-F238E27FC236}">
-                  <a16:creationId xmlns:a16="http://schemas.microsoft.com/office/drawing/2014/main" id="{5D1DEB8F-87B1-925A-FCCD-A42E97AD43AB}"/>
+                  <a16:creationId xmlns:a16="http://schemas.microsoft.com/office/drawing/2014/main" id="{31E90E1A-5B71-EEA0-207B-81AA48179036}"/>
                 </a:ext>
               </a:extLst>
             </p:cNvPr>
@@ -7422,7 +7488,7 @@
             <p:cNvPr id="26" name="Oval 25">
               <a:extLst>
                 <a:ext uri="{FF2B5EF4-FFF2-40B4-BE49-F238E27FC236}">
-                  <a16:creationId xmlns:a16="http://schemas.microsoft.com/office/drawing/2014/main" id="{80EB579A-45D8-E043-6879-EAD6244627EA}"/>
+                  <a16:creationId xmlns:a16="http://schemas.microsoft.com/office/drawing/2014/main" id="{904C64CB-E427-3F23-C55E-4C1138F7529A}"/>
                 </a:ext>
               </a:extLst>
             </p:cNvPr>
@@ -7490,7 +7556,7 @@
             <p:cNvPr id="28" name="Graphic 27">
               <a:extLst>
                 <a:ext uri="{FF2B5EF4-FFF2-40B4-BE49-F238E27FC236}">
-                  <a16:creationId xmlns:a16="http://schemas.microsoft.com/office/drawing/2014/main" id="{5CCA7B5B-A30A-4EFA-369A-076E9DD500D3}"/>
+                  <a16:creationId xmlns:a16="http://schemas.microsoft.com/office/drawing/2014/main" id="{AA315073-FDE6-5714-A1BF-1420DAA2D5D8}"/>
                 </a:ext>
               </a:extLst>
             </p:cNvPr>
@@ -7526,7 +7592,7 @@
             <p:cNvPr id="29" name="TextBox 28">
               <a:extLst>
                 <a:ext uri="{FF2B5EF4-FFF2-40B4-BE49-F238E27FC236}">
-                  <a16:creationId xmlns:a16="http://schemas.microsoft.com/office/drawing/2014/main" id="{09A9D379-EBA0-28D9-BBC3-073E8F013097}"/>
+                  <a16:creationId xmlns:a16="http://schemas.microsoft.com/office/drawing/2014/main" id="{954373A9-939F-D1A0-902A-990C1104D0A3}"/>
                 </a:ext>
               </a:extLst>
             </p:cNvPr>
@@ -7588,7 +7654,7 @@
           <p:cNvPr id="31" name="!!Anchor_Source_Footer!!">
             <a:extLst>
               <a:ext uri="{FF2B5EF4-FFF2-40B4-BE49-F238E27FC236}">
-                <a16:creationId xmlns:a16="http://schemas.microsoft.com/office/drawing/2014/main" id="{55A1A13F-F03F-B937-CDA1-156B32F58593}"/>
+                <a16:creationId xmlns:a16="http://schemas.microsoft.com/office/drawing/2014/main" id="{F5A0EC2B-AFA3-C80F-8284-6FB0D260D244}"/>
               </a:ext>
             </a:extLst>
           </p:cNvPr>
@@ -7626,7 +7692,7 @@
     </p:spTree>
     <p:extLst>
       <p:ext uri="{BB962C8B-B14F-4D97-AF65-F5344CB8AC3E}">
-        <p14:creationId xmlns:p14="http://schemas.microsoft.com/office/powerpoint/2010/main" val="2633509880"/>
+        <p14:creationId xmlns:p14="http://schemas.microsoft.com/office/powerpoint/2010/main" val="2191196913"/>
       </p:ext>
     </p:extLst>
   </p:cSld>
@@ -7657,9 +7723,6 @@
                     <p:cTn id="3" fill="hold">
                       <p:stCondLst>
                         <p:cond delay="indefinite"/>
-                        <p:cond evt="onBegin" delay="0">
-                          <p:tn val="2"/>
-                        </p:cond>
                       </p:stCondLst>
                       <p:childTnLst>
                         <p:par>
@@ -7669,9 +7732,9 @@
                             </p:stCondLst>
                             <p:childTnLst>
                               <p:par>
-                                <p:cTn id="5" presetID="2" presetClass="entr" presetSubtype="1" accel="50000" decel="50000" fill="hold" nodeType="withEffect">
+                                <p:cTn id="5" presetID="2" presetClass="entr" presetSubtype="1" accel="50000" decel="50000" fill="hold" nodeType="clickEffect">
                                   <p:stCondLst>
-                                    <p:cond delay="120"/>
+                                    <p:cond delay="0"/>
                                   </p:stCondLst>
                                   <p:childTnLst>
                                     <p:set>
@@ -7741,15 +7804,33 @@
                                   </p:childTnLst>
                                 </p:cTn>
                               </p:par>
+                            </p:childTnLst>
+                          </p:cTn>
+                        </p:par>
+                      </p:childTnLst>
+                    </p:cTn>
+                  </p:par>
+                  <p:par>
+                    <p:cTn id="9" fill="hold">
+                      <p:stCondLst>
+                        <p:cond delay="indefinite"/>
+                      </p:stCondLst>
+                      <p:childTnLst>
+                        <p:par>
+                          <p:cTn id="10" fill="hold">
+                            <p:stCondLst>
+                              <p:cond delay="0"/>
+                            </p:stCondLst>
+                            <p:childTnLst>
                               <p:par>
-                                <p:cTn id="9" presetID="2" presetClass="entr" presetSubtype="1" accel="50000" decel="50000" fill="hold" nodeType="withEffect">
+                                <p:cTn id="11" presetID="2" presetClass="entr" presetSubtype="1" accel="50000" decel="50000" fill="hold" nodeType="clickEffect">
                                   <p:stCondLst>
-                                    <p:cond delay="240"/>
+                                    <p:cond delay="0"/>
                                   </p:stCondLst>
                                   <p:childTnLst>
                                     <p:set>
                                       <p:cBhvr>
-                                        <p:cTn id="10" dur="1" fill="hold">
+                                        <p:cTn id="12" dur="1" fill="hold">
                                           <p:stCondLst>
                                             <p:cond delay="0"/>
                                           </p:stCondLst>
@@ -7767,7 +7848,7 @@
                                     </p:set>
                                     <p:anim calcmode="lin" valueType="num">
                                       <p:cBhvr additive="base">
-                                        <p:cTn id="11" dur="500" fill="hold"/>
+                                        <p:cTn id="13" dur="500" fill="hold"/>
                                         <p:tgtEl>
                                           <p:spTgt spid="24"/>
                                         </p:tgtEl>
@@ -7790,7 +7871,7 @@
                                     </p:anim>
                                     <p:anim calcmode="lin" valueType="num">
                                       <p:cBhvr additive="base">
-                                        <p:cTn id="12" dur="500" fill="hold"/>
+                                        <p:cTn id="14" dur="500" fill="hold"/>
                                         <p:tgtEl>
                                           <p:spTgt spid="24"/>
                                         </p:tgtEl>
@@ -7814,15 +7895,33 @@
                                   </p:childTnLst>
                                 </p:cTn>
                               </p:par>
+                            </p:childTnLst>
+                          </p:cTn>
+                        </p:par>
+                      </p:childTnLst>
+                    </p:cTn>
+                  </p:par>
+                  <p:par>
+                    <p:cTn id="15" fill="hold">
+                      <p:stCondLst>
+                        <p:cond delay="indefinite"/>
+                      </p:stCondLst>
+                      <p:childTnLst>
+                        <p:par>
+                          <p:cTn id="16" fill="hold">
+                            <p:stCondLst>
+                              <p:cond delay="0"/>
+                            </p:stCondLst>
+                            <p:childTnLst>
                               <p:par>
-                                <p:cTn id="13" presetID="2" presetClass="entr" presetSubtype="1" accel="50000" decel="50000" fill="hold" nodeType="withEffect">
+                                <p:cTn id="17" presetID="2" presetClass="entr" presetSubtype="1" accel="50000" decel="50000" fill="hold" nodeType="clickEffect">
                                   <p:stCondLst>
-                                    <p:cond delay="360"/>
+                                    <p:cond delay="0"/>
                                   </p:stCondLst>
                                   <p:childTnLst>
                                     <p:set>
                                       <p:cBhvr>
-                                        <p:cTn id="14" dur="1" fill="hold">
+                                        <p:cTn id="18" dur="1" fill="hold">
                                           <p:stCondLst>
                                             <p:cond delay="0"/>
                                           </p:stCondLst>
@@ -7840,7 +7939,7 @@
                                     </p:set>
                                     <p:anim calcmode="lin" valueType="num">
                                       <p:cBhvr additive="base">
-                                        <p:cTn id="15" dur="500" fill="hold"/>
+                                        <p:cTn id="19" dur="500" fill="hold"/>
                                         <p:tgtEl>
                                           <p:spTgt spid="30"/>
                                         </p:tgtEl>
@@ -7863,7 +7962,7 @@
                                     </p:anim>
                                     <p:anim calcmode="lin" valueType="num">
                                       <p:cBhvr additive="base">
-                                        <p:cTn id="16" dur="500" fill="hold"/>
+                                        <p:cTn id="20" dur="500" fill="hold"/>
                                         <p:tgtEl>
                                           <p:spTgt spid="30"/>
                                         </p:tgtEl>
@@ -7948,7 +8047,7 @@
           <p:cNvPr id="2" name="!!Anchor_Kicker_Rail!!">
             <a:extLst>
               <a:ext uri="{FF2B5EF4-FFF2-40B4-BE49-F238E27FC236}">
-                <a16:creationId xmlns:a16="http://schemas.microsoft.com/office/drawing/2014/main" id="{E1263983-5EAA-8EC7-3640-A087A97DD791}"/>
+                <a16:creationId xmlns:a16="http://schemas.microsoft.com/office/drawing/2014/main" id="{9E2FD240-8293-BF77-876B-8D84F6BC9A3E}"/>
               </a:ext>
             </a:extLst>
           </p:cNvPr>
@@ -7988,7 +8087,7 @@
           <p:cNvPr id="3" name="!!Anchor_Slide_Tracker!!">
             <a:extLst>
               <a:ext uri="{FF2B5EF4-FFF2-40B4-BE49-F238E27FC236}">
-                <a16:creationId xmlns:a16="http://schemas.microsoft.com/office/drawing/2014/main" id="{D430C268-DDE8-4DA0-9D73-9F3F205D6D8F}"/>
+                <a16:creationId xmlns:a16="http://schemas.microsoft.com/office/drawing/2014/main" id="{A337B0AC-6277-6929-85A2-5D232DFDE387}"/>
               </a:ext>
             </a:extLst>
           </p:cNvPr>
@@ -8029,7 +8128,7 @@
           <p:cNvPr id="4" name="!!Anchor_Assertion_Title!!">
             <a:extLst>
               <a:ext uri="{FF2B5EF4-FFF2-40B4-BE49-F238E27FC236}">
-                <a16:creationId xmlns:a16="http://schemas.microsoft.com/office/drawing/2014/main" id="{62A899B4-BB71-044B-9851-933C445F2373}"/>
+                <a16:creationId xmlns:a16="http://schemas.microsoft.com/office/drawing/2014/main" id="{49ADD8F6-4066-AE85-D40E-F80DFB207085}"/>
               </a:ext>
             </a:extLst>
           </p:cNvPr>
@@ -8075,7 +8174,7 @@
           <p:cNvPr id="10" name="!!Stage_Hero_Container!!">
             <a:extLst>
               <a:ext uri="{FF2B5EF4-FFF2-40B4-BE49-F238E27FC236}">
-                <a16:creationId xmlns:a16="http://schemas.microsoft.com/office/drawing/2014/main" id="{5A7D4AE8-093C-633B-4A70-B32C0E6AC46F}"/>
+                <a16:creationId xmlns:a16="http://schemas.microsoft.com/office/drawing/2014/main" id="{7571C092-9405-F90E-C0CE-3E9959C0C4E9}"/>
               </a:ext>
             </a:extLst>
           </p:cNvPr>
@@ -8095,7 +8194,7 @@
             <p:cNvPr id="5" name="Rectangle: Rounded Corners 4">
               <a:extLst>
                 <a:ext uri="{FF2B5EF4-FFF2-40B4-BE49-F238E27FC236}">
-                  <a16:creationId xmlns:a16="http://schemas.microsoft.com/office/drawing/2014/main" id="{8783D0EA-46AE-13B2-18A0-43A0EFD4FC56}"/>
+                  <a16:creationId xmlns:a16="http://schemas.microsoft.com/office/drawing/2014/main" id="{760AE12D-F667-F352-44FA-F1DA23A98A09}"/>
                 </a:ext>
               </a:extLst>
             </p:cNvPr>
@@ -8149,7 +8248,7 @@
             <p:cNvPr id="6" name="Rectangle 5">
               <a:extLst>
                 <a:ext uri="{FF2B5EF4-FFF2-40B4-BE49-F238E27FC236}">
-                  <a16:creationId xmlns:a16="http://schemas.microsoft.com/office/drawing/2014/main" id="{D56F0572-90CA-32A0-728C-E7BCDA063D71}"/>
+                  <a16:creationId xmlns:a16="http://schemas.microsoft.com/office/drawing/2014/main" id="{102E4A0A-3062-CA77-329E-D4DA218E9662}"/>
                 </a:ext>
               </a:extLst>
             </p:cNvPr>
@@ -8225,7 +8324,7 @@
             <p:cNvPr id="8" name="Graphic 7">
               <a:extLst>
                 <a:ext uri="{FF2B5EF4-FFF2-40B4-BE49-F238E27FC236}">
-                  <a16:creationId xmlns:a16="http://schemas.microsoft.com/office/drawing/2014/main" id="{1E8C8F8E-EC99-F50B-5BBA-0E72F0D4F505}"/>
+                  <a16:creationId xmlns:a16="http://schemas.microsoft.com/office/drawing/2014/main" id="{8060BB11-ED71-97CA-CEBA-31C338353113}"/>
                 </a:ext>
               </a:extLst>
             </p:cNvPr>
@@ -8261,7 +8360,7 @@
             <p:cNvPr id="9" name="TextBox 8">
               <a:extLst>
                 <a:ext uri="{FF2B5EF4-FFF2-40B4-BE49-F238E27FC236}">
-                  <a16:creationId xmlns:a16="http://schemas.microsoft.com/office/drawing/2014/main" id="{331ADE02-576B-8FC5-BF56-54755CFDE3F9}"/>
+                  <a16:creationId xmlns:a16="http://schemas.microsoft.com/office/drawing/2014/main" id="{A04C6726-F68D-46F9-FA53-E6B0CB644F7B}"/>
                 </a:ext>
               </a:extLst>
             </p:cNvPr>
@@ -8323,7 +8422,7 @@
           <p:cNvPr id="16" name="!!Stage_Sub_Card_1!!">
             <a:extLst>
               <a:ext uri="{FF2B5EF4-FFF2-40B4-BE49-F238E27FC236}">
-                <a16:creationId xmlns:a16="http://schemas.microsoft.com/office/drawing/2014/main" id="{080A7C13-6721-7360-F827-85C8CBF99154}"/>
+                <a16:creationId xmlns:a16="http://schemas.microsoft.com/office/drawing/2014/main" id="{B0363EBD-3DC7-73CF-2D06-B823ADCB7E1B}"/>
               </a:ext>
             </a:extLst>
           </p:cNvPr>
@@ -8343,7 +8442,7 @@
             <p:cNvPr id="11" name="Rectangle: Rounded Corners 10">
               <a:extLst>
                 <a:ext uri="{FF2B5EF4-FFF2-40B4-BE49-F238E27FC236}">
-                  <a16:creationId xmlns:a16="http://schemas.microsoft.com/office/drawing/2014/main" id="{1F87B226-91E2-6FE8-16ED-40180C121F3F}"/>
+                  <a16:creationId xmlns:a16="http://schemas.microsoft.com/office/drawing/2014/main" id="{EBD93793-DA36-3C2C-3FD4-96964ABD1F07}"/>
                 </a:ext>
               </a:extLst>
             </p:cNvPr>
@@ -8397,7 +8496,7 @@
             <p:cNvPr id="12" name="Rectangle 11">
               <a:extLst>
                 <a:ext uri="{FF2B5EF4-FFF2-40B4-BE49-F238E27FC236}">
-                  <a16:creationId xmlns:a16="http://schemas.microsoft.com/office/drawing/2014/main" id="{C8E01539-550F-6A9D-F42B-3F0ADB1AFEF1}"/>
+                  <a16:creationId xmlns:a16="http://schemas.microsoft.com/office/drawing/2014/main" id="{A64CF0F4-DC49-70A1-C358-6CE66FD2C7BB}"/>
                 </a:ext>
               </a:extLst>
             </p:cNvPr>
@@ -8473,7 +8572,7 @@
             <p:cNvPr id="14" name="Graphic 13">
               <a:extLst>
                 <a:ext uri="{FF2B5EF4-FFF2-40B4-BE49-F238E27FC236}">
-                  <a16:creationId xmlns:a16="http://schemas.microsoft.com/office/drawing/2014/main" id="{1C152750-6692-2862-8660-99615E3EFEDD}"/>
+                  <a16:creationId xmlns:a16="http://schemas.microsoft.com/office/drawing/2014/main" id="{05AB069E-F9B0-782E-51FA-8088BC743E56}"/>
                 </a:ext>
               </a:extLst>
             </p:cNvPr>
@@ -8509,7 +8608,7 @@
             <p:cNvPr id="15" name="TextBox 14">
               <a:extLst>
                 <a:ext uri="{FF2B5EF4-FFF2-40B4-BE49-F238E27FC236}">
-                  <a16:creationId xmlns:a16="http://schemas.microsoft.com/office/drawing/2014/main" id="{E3FB9C62-AD95-FB31-FFED-F11519BFCB90}"/>
+                  <a16:creationId xmlns:a16="http://schemas.microsoft.com/office/drawing/2014/main" id="{AE201D04-3FC3-4182-9AB4-ACCA1DEDC714}"/>
                 </a:ext>
               </a:extLst>
             </p:cNvPr>
@@ -8571,7 +8670,7 @@
           <p:cNvPr id="22" name="!!Stage_Sub_Card_2!!">
             <a:extLst>
               <a:ext uri="{FF2B5EF4-FFF2-40B4-BE49-F238E27FC236}">
-                <a16:creationId xmlns:a16="http://schemas.microsoft.com/office/drawing/2014/main" id="{853F7791-181C-03DD-1145-D0E8A62B0ADA}"/>
+                <a16:creationId xmlns:a16="http://schemas.microsoft.com/office/drawing/2014/main" id="{89A0EA00-9053-EC2A-0CAF-A678108E1D57}"/>
               </a:ext>
             </a:extLst>
           </p:cNvPr>
@@ -8591,7 +8690,7 @@
             <p:cNvPr id="17" name="Rectangle: Rounded Corners 16">
               <a:extLst>
                 <a:ext uri="{FF2B5EF4-FFF2-40B4-BE49-F238E27FC236}">
-                  <a16:creationId xmlns:a16="http://schemas.microsoft.com/office/drawing/2014/main" id="{791FA9D2-0022-6294-BB41-D69CA2AC6029}"/>
+                  <a16:creationId xmlns:a16="http://schemas.microsoft.com/office/drawing/2014/main" id="{C2735974-73C6-DFDD-2F5F-BE486CA8FD6F}"/>
                 </a:ext>
               </a:extLst>
             </p:cNvPr>
@@ -8645,7 +8744,7 @@
             <p:cNvPr id="18" name="Rectangle 17">
               <a:extLst>
                 <a:ext uri="{FF2B5EF4-FFF2-40B4-BE49-F238E27FC236}">
-                  <a16:creationId xmlns:a16="http://schemas.microsoft.com/office/drawing/2014/main" id="{FBAD8321-9AF0-AFC2-FD58-1F6CDA45D76F}"/>
+                  <a16:creationId xmlns:a16="http://schemas.microsoft.com/office/drawing/2014/main" id="{52A1FC55-7FAC-0AE2-A1CC-3296CD9EDBA7}"/>
                 </a:ext>
               </a:extLst>
             </p:cNvPr>
@@ -8721,7 +8820,7 @@
             <p:cNvPr id="20" name="Graphic 19">
               <a:extLst>
                 <a:ext uri="{FF2B5EF4-FFF2-40B4-BE49-F238E27FC236}">
-                  <a16:creationId xmlns:a16="http://schemas.microsoft.com/office/drawing/2014/main" id="{4EE1C29D-D4B0-89D4-FFC5-16577CC8E187}"/>
+                  <a16:creationId xmlns:a16="http://schemas.microsoft.com/office/drawing/2014/main" id="{5F1C37C1-C641-3DA8-F312-CB762A6EC8DC}"/>
                 </a:ext>
               </a:extLst>
             </p:cNvPr>
@@ -8757,7 +8856,7 @@
             <p:cNvPr id="21" name="TextBox 20">
               <a:extLst>
                 <a:ext uri="{FF2B5EF4-FFF2-40B4-BE49-F238E27FC236}">
-                  <a16:creationId xmlns:a16="http://schemas.microsoft.com/office/drawing/2014/main" id="{6FE0D311-C2CF-07C3-B855-BD61B183FC09}"/>
+                  <a16:creationId xmlns:a16="http://schemas.microsoft.com/office/drawing/2014/main" id="{87964A8E-C54B-B01A-7E52-59314BA9EFE3}"/>
                 </a:ext>
               </a:extLst>
             </p:cNvPr>
@@ -8819,7 +8918,7 @@
           <p:cNvPr id="23" name="!!Anchor_Source_Footer!!">
             <a:extLst>
               <a:ext uri="{FF2B5EF4-FFF2-40B4-BE49-F238E27FC236}">
-                <a16:creationId xmlns:a16="http://schemas.microsoft.com/office/drawing/2014/main" id="{9A48BB64-947E-6264-3E93-3C6757CA825D}"/>
+                <a16:creationId xmlns:a16="http://schemas.microsoft.com/office/drawing/2014/main" id="{47A9EE99-0A2B-D080-D05C-0CADDD931A91}"/>
               </a:ext>
             </a:extLst>
           </p:cNvPr>
@@ -8863,7 +8962,7 @@
     </p:spTree>
     <p:extLst>
       <p:ext uri="{BB962C8B-B14F-4D97-AF65-F5344CB8AC3E}">
-        <p14:creationId xmlns:p14="http://schemas.microsoft.com/office/powerpoint/2010/main" val="29541330"/>
+        <p14:creationId xmlns:p14="http://schemas.microsoft.com/office/powerpoint/2010/main" val="3689600171"/>
       </p:ext>
     </p:extLst>
   </p:cSld>
@@ -8894,9 +8993,6 @@
                     <p:cTn id="3" fill="hold">
                       <p:stCondLst>
                         <p:cond delay="indefinite"/>
-                        <p:cond evt="onBegin" delay="0">
-                          <p:tn val="2"/>
-                        </p:cond>
                       </p:stCondLst>
                       <p:childTnLst>
                         <p:par>
@@ -8906,9 +9002,9 @@
                             </p:stCondLst>
                             <p:childTnLst>
                               <p:par>
-                                <p:cTn id="5" presetID="2" presetClass="entr" presetSubtype="1" accel="50000" decel="50000" fill="hold" nodeType="withEffect">
+                                <p:cTn id="5" presetID="2" presetClass="entr" presetSubtype="1" accel="50000" decel="50000" fill="hold" nodeType="clickEffect">
                                   <p:stCondLst>
-                                    <p:cond delay="120"/>
+                                    <p:cond delay="0"/>
                                   </p:stCondLst>
                                   <p:childTnLst>
                                     <p:set>
@@ -8978,15 +9074,33 @@
                                   </p:childTnLst>
                                 </p:cTn>
                               </p:par>
+                            </p:childTnLst>
+                          </p:cTn>
+                        </p:par>
+                      </p:childTnLst>
+                    </p:cTn>
+                  </p:par>
+                  <p:par>
+                    <p:cTn id="9" fill="hold">
+                      <p:stCondLst>
+                        <p:cond delay="indefinite"/>
+                      </p:stCondLst>
+                      <p:childTnLst>
+                        <p:par>
+                          <p:cTn id="10" fill="hold">
+                            <p:stCondLst>
+                              <p:cond delay="0"/>
+                            </p:stCondLst>
+                            <p:childTnLst>
                               <p:par>
-                                <p:cTn id="9" presetID="2" presetClass="entr" presetSubtype="1" accel="50000" decel="50000" fill="hold" nodeType="withEffect">
+                                <p:cTn id="11" presetID="2" presetClass="entr" presetSubtype="1" accel="50000" decel="50000" fill="hold" nodeType="clickEffect">
                                   <p:stCondLst>
-                                    <p:cond delay="240"/>
+                                    <p:cond delay="0"/>
                                   </p:stCondLst>
                                   <p:childTnLst>
                                     <p:set>
                                       <p:cBhvr>
-                                        <p:cTn id="10" dur="1" fill="hold">
+                                        <p:cTn id="12" dur="1" fill="hold">
                                           <p:stCondLst>
                                             <p:cond delay="0"/>
                                           </p:stCondLst>
@@ -9004,7 +9118,7 @@
                                     </p:set>
                                     <p:anim calcmode="lin" valueType="num">
                                       <p:cBhvr additive="base">
-                                        <p:cTn id="11" dur="500" fill="hold"/>
+                                        <p:cTn id="13" dur="500" fill="hold"/>
                                         <p:tgtEl>
                                           <p:spTgt spid="22"/>
                                         </p:tgtEl>
@@ -9027,7 +9141,7 @@
                                     </p:anim>
                                     <p:anim calcmode="lin" valueType="num">
                                       <p:cBhvr additive="base">
-                                        <p:cTn id="12" dur="500" fill="hold"/>
+                                        <p:cTn id="14" dur="500" fill="hold"/>
                                         <p:tgtEl>
                                           <p:spTgt spid="22"/>
                                         </p:tgtEl>
@@ -9112,7 +9226,7 @@
           <p:cNvPr id="2" name="!!Anchor_Kicker_Rail!!">
             <a:extLst>
               <a:ext uri="{FF2B5EF4-FFF2-40B4-BE49-F238E27FC236}">
-                <a16:creationId xmlns:a16="http://schemas.microsoft.com/office/drawing/2014/main" id="{F87A6933-861A-881F-7F21-14A7F5971FFD}"/>
+                <a16:creationId xmlns:a16="http://schemas.microsoft.com/office/drawing/2014/main" id="{767E434F-51C0-C538-790D-CD64FB890E6B}"/>
               </a:ext>
             </a:extLst>
           </p:cNvPr>
@@ -9152,7 +9266,7 @@
           <p:cNvPr id="3" name="!!Anchor_Slide_Tracker!!">
             <a:extLst>
               <a:ext uri="{FF2B5EF4-FFF2-40B4-BE49-F238E27FC236}">
-                <a16:creationId xmlns:a16="http://schemas.microsoft.com/office/drawing/2014/main" id="{D876C711-C69D-02D7-7A66-1BAD782118C7}"/>
+                <a16:creationId xmlns:a16="http://schemas.microsoft.com/office/drawing/2014/main" id="{F1956794-BF34-5ACE-5B45-3330303B15E1}"/>
               </a:ext>
             </a:extLst>
           </p:cNvPr>
@@ -9193,7 +9307,7 @@
           <p:cNvPr id="4" name="!!Anchor_Assertion_Title!!">
             <a:extLst>
               <a:ext uri="{FF2B5EF4-FFF2-40B4-BE49-F238E27FC236}">
-                <a16:creationId xmlns:a16="http://schemas.microsoft.com/office/drawing/2014/main" id="{83C0CCED-93E9-4E62-80E2-099C2D0A0345}"/>
+                <a16:creationId xmlns:a16="http://schemas.microsoft.com/office/drawing/2014/main" id="{0D1644C4-982A-6C49-550C-8275B67DE652}"/>
               </a:ext>
             </a:extLst>
           </p:cNvPr>
@@ -9233,7 +9347,7 @@
           <p:cNvPr id="11" name="!!Stage_Hero_Container!!">
             <a:extLst>
               <a:ext uri="{FF2B5EF4-FFF2-40B4-BE49-F238E27FC236}">
-                <a16:creationId xmlns:a16="http://schemas.microsoft.com/office/drawing/2014/main" id="{7E9FDCD3-D162-3055-8FA3-0152BFB14A03}"/>
+                <a16:creationId xmlns:a16="http://schemas.microsoft.com/office/drawing/2014/main" id="{213CE72E-82C8-4882-FE54-3D2288ED82FD}"/>
               </a:ext>
             </a:extLst>
           </p:cNvPr>
@@ -9253,7 +9367,7 @@
             <p:cNvPr id="5" name="Rectangle: Rounded Corners 4">
               <a:extLst>
                 <a:ext uri="{FF2B5EF4-FFF2-40B4-BE49-F238E27FC236}">
-                  <a16:creationId xmlns:a16="http://schemas.microsoft.com/office/drawing/2014/main" id="{81D10B8B-A247-FF92-CD3D-12B741F24004}"/>
+                  <a16:creationId xmlns:a16="http://schemas.microsoft.com/office/drawing/2014/main" id="{13084B8C-F99E-B16A-E309-039B9F863CE7}"/>
                 </a:ext>
               </a:extLst>
             </p:cNvPr>
@@ -9307,7 +9421,7 @@
             <p:cNvPr id="6" name="Rectangle 5">
               <a:extLst>
                 <a:ext uri="{FF2B5EF4-FFF2-40B4-BE49-F238E27FC236}">
-                  <a16:creationId xmlns:a16="http://schemas.microsoft.com/office/drawing/2014/main" id="{68C0DE6D-DA5A-12FC-A9B8-91DEAB16E327}"/>
+                  <a16:creationId xmlns:a16="http://schemas.microsoft.com/office/drawing/2014/main" id="{122C5B89-0E2E-6759-A937-044FA9413FF8}"/>
                 </a:ext>
               </a:extLst>
             </p:cNvPr>
@@ -9375,7 +9489,7 @@
             <p:cNvPr id="7" name="Oval 6">
               <a:extLst>
                 <a:ext uri="{FF2B5EF4-FFF2-40B4-BE49-F238E27FC236}">
-                  <a16:creationId xmlns:a16="http://schemas.microsoft.com/office/drawing/2014/main" id="{3C031629-C926-1D26-9D90-630B6A663C81}"/>
+                  <a16:creationId xmlns:a16="http://schemas.microsoft.com/office/drawing/2014/main" id="{DE6D3B29-DE55-E891-AEF6-CB8F1C20CB40}"/>
                 </a:ext>
               </a:extLst>
             </p:cNvPr>
@@ -9443,7 +9557,7 @@
             <p:cNvPr id="9" name="Graphic 8">
               <a:extLst>
                 <a:ext uri="{FF2B5EF4-FFF2-40B4-BE49-F238E27FC236}">
-                  <a16:creationId xmlns:a16="http://schemas.microsoft.com/office/drawing/2014/main" id="{4888FC0C-D366-F767-7F79-3BD485B88F3D}"/>
+                  <a16:creationId xmlns:a16="http://schemas.microsoft.com/office/drawing/2014/main" id="{4B2A39C8-B584-6110-5269-B782A89F48FD}"/>
                 </a:ext>
               </a:extLst>
             </p:cNvPr>
@@ -9479,7 +9593,7 @@
             <p:cNvPr id="10" name="TextBox 9">
               <a:extLst>
                 <a:ext uri="{FF2B5EF4-FFF2-40B4-BE49-F238E27FC236}">
-                  <a16:creationId xmlns:a16="http://schemas.microsoft.com/office/drawing/2014/main" id="{081DDA82-7A6B-B311-8ED1-8BC66A47FCCF}"/>
+                  <a16:creationId xmlns:a16="http://schemas.microsoft.com/office/drawing/2014/main" id="{9895ABCD-1CB7-0C21-F086-FD13246154A2}"/>
                 </a:ext>
               </a:extLst>
             </p:cNvPr>
@@ -9544,7 +9658,7 @@
           <p:cNvPr id="18" name="!!Stage_Sub_Card_1!!">
             <a:extLst>
               <a:ext uri="{FF2B5EF4-FFF2-40B4-BE49-F238E27FC236}">
-                <a16:creationId xmlns:a16="http://schemas.microsoft.com/office/drawing/2014/main" id="{C274F319-24D4-411D-472D-FD718CCBC166}"/>
+                <a16:creationId xmlns:a16="http://schemas.microsoft.com/office/drawing/2014/main" id="{3FD051C6-45B0-C333-09B1-F89E84DBF0AE}"/>
               </a:ext>
             </a:extLst>
           </p:cNvPr>
@@ -9564,7 +9678,7 @@
             <p:cNvPr id="12" name="Rectangle: Rounded Corners 11">
               <a:extLst>
                 <a:ext uri="{FF2B5EF4-FFF2-40B4-BE49-F238E27FC236}">
-                  <a16:creationId xmlns:a16="http://schemas.microsoft.com/office/drawing/2014/main" id="{862FA262-13EA-8BF0-60BD-A4389C89B7D0}"/>
+                  <a16:creationId xmlns:a16="http://schemas.microsoft.com/office/drawing/2014/main" id="{DDED1327-CFDA-42DA-44F4-B772DE222C50}"/>
                 </a:ext>
               </a:extLst>
             </p:cNvPr>
@@ -9618,7 +9732,7 @@
             <p:cNvPr id="13" name="Rectangle 12">
               <a:extLst>
                 <a:ext uri="{FF2B5EF4-FFF2-40B4-BE49-F238E27FC236}">
-                  <a16:creationId xmlns:a16="http://schemas.microsoft.com/office/drawing/2014/main" id="{C938985C-52C8-3143-6B56-842EABA7D617}"/>
+                  <a16:creationId xmlns:a16="http://schemas.microsoft.com/office/drawing/2014/main" id="{7B6D6D03-B1FA-8950-FD9F-7EC8D981470D}"/>
                 </a:ext>
               </a:extLst>
             </p:cNvPr>
@@ -9686,7 +9800,7 @@
             <p:cNvPr id="14" name="Oval 13">
               <a:extLst>
                 <a:ext uri="{FF2B5EF4-FFF2-40B4-BE49-F238E27FC236}">
-                  <a16:creationId xmlns:a16="http://schemas.microsoft.com/office/drawing/2014/main" id="{697C94F0-95BD-E00D-8910-659550592D1A}"/>
+                  <a16:creationId xmlns:a16="http://schemas.microsoft.com/office/drawing/2014/main" id="{86C578E6-F209-C8AF-A647-05C95F27D466}"/>
                 </a:ext>
               </a:extLst>
             </p:cNvPr>
@@ -9754,7 +9868,7 @@
             <p:cNvPr id="16" name="Graphic 15">
               <a:extLst>
                 <a:ext uri="{FF2B5EF4-FFF2-40B4-BE49-F238E27FC236}">
-                  <a16:creationId xmlns:a16="http://schemas.microsoft.com/office/drawing/2014/main" id="{5A16A0E6-A52A-FA2A-10DF-24E844F82989}"/>
+                  <a16:creationId xmlns:a16="http://schemas.microsoft.com/office/drawing/2014/main" id="{F74AE98E-6E44-7307-E4A5-60B12CEA2540}"/>
                 </a:ext>
               </a:extLst>
             </p:cNvPr>
@@ -9790,7 +9904,7 @@
             <p:cNvPr id="17" name="TextBox 16">
               <a:extLst>
                 <a:ext uri="{FF2B5EF4-FFF2-40B4-BE49-F238E27FC236}">
-                  <a16:creationId xmlns:a16="http://schemas.microsoft.com/office/drawing/2014/main" id="{9717B460-0396-07EF-F871-80E335F997EB}"/>
+                  <a16:creationId xmlns:a16="http://schemas.microsoft.com/office/drawing/2014/main" id="{F5C7EAD0-C89C-4BB2-80E0-4D1049CDD53F}"/>
                 </a:ext>
               </a:extLst>
             </p:cNvPr>
@@ -9849,7 +9963,7 @@
           <p:cNvPr id="25" name="!!Stage_Sub_Card_2!!">
             <a:extLst>
               <a:ext uri="{FF2B5EF4-FFF2-40B4-BE49-F238E27FC236}">
-                <a16:creationId xmlns:a16="http://schemas.microsoft.com/office/drawing/2014/main" id="{4CE89469-418D-17CA-C729-B604BF87BAD2}"/>
+                <a16:creationId xmlns:a16="http://schemas.microsoft.com/office/drawing/2014/main" id="{0C1EA1DE-C127-6DF5-1538-8B10CD957479}"/>
               </a:ext>
             </a:extLst>
           </p:cNvPr>
@@ -9869,7 +9983,7 @@
             <p:cNvPr id="19" name="Rectangle: Rounded Corners 18">
               <a:extLst>
                 <a:ext uri="{FF2B5EF4-FFF2-40B4-BE49-F238E27FC236}">
-                  <a16:creationId xmlns:a16="http://schemas.microsoft.com/office/drawing/2014/main" id="{30EB920E-10EE-EC85-DAAE-D738A8290B90}"/>
+                  <a16:creationId xmlns:a16="http://schemas.microsoft.com/office/drawing/2014/main" id="{1F218B81-3D6D-EF85-8270-40843FDE49CA}"/>
                 </a:ext>
               </a:extLst>
             </p:cNvPr>
@@ -9923,7 +10037,7 @@
             <p:cNvPr id="20" name="Rectangle 19">
               <a:extLst>
                 <a:ext uri="{FF2B5EF4-FFF2-40B4-BE49-F238E27FC236}">
-                  <a16:creationId xmlns:a16="http://schemas.microsoft.com/office/drawing/2014/main" id="{1E5AB526-8768-BC48-4607-D55319669278}"/>
+                  <a16:creationId xmlns:a16="http://schemas.microsoft.com/office/drawing/2014/main" id="{F71DCD28-025A-92E3-8918-FBB686776CB5}"/>
                 </a:ext>
               </a:extLst>
             </p:cNvPr>
@@ -9991,7 +10105,7 @@
             <p:cNvPr id="21" name="Oval 20">
               <a:extLst>
                 <a:ext uri="{FF2B5EF4-FFF2-40B4-BE49-F238E27FC236}">
-                  <a16:creationId xmlns:a16="http://schemas.microsoft.com/office/drawing/2014/main" id="{165F0B63-EF55-7FFE-0576-F3E91C407DAF}"/>
+                  <a16:creationId xmlns:a16="http://schemas.microsoft.com/office/drawing/2014/main" id="{2CF8088B-6D25-10D6-88F7-15CB3BCED1A2}"/>
                 </a:ext>
               </a:extLst>
             </p:cNvPr>
@@ -10059,7 +10173,7 @@
             <p:cNvPr id="23" name="Graphic 22">
               <a:extLst>
                 <a:ext uri="{FF2B5EF4-FFF2-40B4-BE49-F238E27FC236}">
-                  <a16:creationId xmlns:a16="http://schemas.microsoft.com/office/drawing/2014/main" id="{9FA00C54-41D3-1B53-49E0-8A262842F67B}"/>
+                  <a16:creationId xmlns:a16="http://schemas.microsoft.com/office/drawing/2014/main" id="{15633A83-FC2E-C199-3737-9C5BF32C8997}"/>
                 </a:ext>
               </a:extLst>
             </p:cNvPr>
@@ -10095,7 +10209,7 @@
             <p:cNvPr id="24" name="TextBox 23">
               <a:extLst>
                 <a:ext uri="{FF2B5EF4-FFF2-40B4-BE49-F238E27FC236}">
-                  <a16:creationId xmlns:a16="http://schemas.microsoft.com/office/drawing/2014/main" id="{7642BDE0-DD44-4AA1-9BB1-747723EA9794}"/>
+                  <a16:creationId xmlns:a16="http://schemas.microsoft.com/office/drawing/2014/main" id="{25028C7F-28EC-A4DC-CF17-B0EA964428CC}"/>
                 </a:ext>
               </a:extLst>
             </p:cNvPr>
@@ -10160,7 +10274,7 @@
           <p:cNvPr id="26" name="!!Anchor_Source_Footer!!">
             <a:extLst>
               <a:ext uri="{FF2B5EF4-FFF2-40B4-BE49-F238E27FC236}">
-                <a16:creationId xmlns:a16="http://schemas.microsoft.com/office/drawing/2014/main" id="{06DBC5CC-5B1D-4FEC-3861-8DCCB13F3435}"/>
+                <a16:creationId xmlns:a16="http://schemas.microsoft.com/office/drawing/2014/main" id="{E80AE1EC-B6CF-CA4B-9EA2-F82384882CAA}"/>
               </a:ext>
             </a:extLst>
           </p:cNvPr>
@@ -10198,7 +10312,7 @@
     </p:spTree>
     <p:extLst>
       <p:ext uri="{BB962C8B-B14F-4D97-AF65-F5344CB8AC3E}">
-        <p14:creationId xmlns:p14="http://schemas.microsoft.com/office/powerpoint/2010/main" val="2065706489"/>
+        <p14:creationId xmlns:p14="http://schemas.microsoft.com/office/powerpoint/2010/main" val="455287044"/>
       </p:ext>
     </p:extLst>
   </p:cSld>
@@ -10229,9 +10343,6 @@
                     <p:cTn id="3" fill="hold">
                       <p:stCondLst>
                         <p:cond delay="indefinite"/>
-                        <p:cond evt="onBegin" delay="0">
-                          <p:tn val="2"/>
-                        </p:cond>
                       </p:stCondLst>
                       <p:childTnLst>
                         <p:par>
@@ -10241,9 +10352,9 @@
                             </p:stCondLst>
                             <p:childTnLst>
                               <p:par>
-                                <p:cTn id="5" presetID="2" presetClass="entr" presetSubtype="1" accel="50000" decel="50000" fill="hold" nodeType="withEffect">
+                                <p:cTn id="5" presetID="2" presetClass="entr" presetSubtype="1" accel="50000" decel="50000" fill="hold" nodeType="clickEffect">
                                   <p:stCondLst>
-                                    <p:cond delay="140"/>
+                                    <p:cond delay="0"/>
                                   </p:stCondLst>
                                   <p:childTnLst>
                                     <p:set>
@@ -10313,15 +10424,33 @@
                                   </p:childTnLst>
                                 </p:cTn>
                               </p:par>
+                            </p:childTnLst>
+                          </p:cTn>
+                        </p:par>
+                      </p:childTnLst>
+                    </p:cTn>
+                  </p:par>
+                  <p:par>
+                    <p:cTn id="9" fill="hold">
+                      <p:stCondLst>
+                        <p:cond delay="indefinite"/>
+                      </p:stCondLst>
+                      <p:childTnLst>
+                        <p:par>
+                          <p:cTn id="10" fill="hold">
+                            <p:stCondLst>
+                              <p:cond delay="0"/>
+                            </p:stCondLst>
+                            <p:childTnLst>
                               <p:par>
-                                <p:cTn id="9" presetID="2" presetClass="entr" presetSubtype="1" accel="50000" decel="50000" fill="hold" nodeType="withEffect">
+                                <p:cTn id="11" presetID="2" presetClass="entr" presetSubtype="1" accel="50000" decel="50000" fill="hold" nodeType="clickEffect">
                                   <p:stCondLst>
-                                    <p:cond delay="280"/>
+                                    <p:cond delay="0"/>
                                   </p:stCondLst>
                                   <p:childTnLst>
                                     <p:set>
                                       <p:cBhvr>
-                                        <p:cTn id="10" dur="1" fill="hold">
+                                        <p:cTn id="12" dur="1" fill="hold">
                                           <p:stCondLst>
                                             <p:cond delay="0"/>
                                           </p:stCondLst>
@@ -10339,7 +10468,7 @@
                                     </p:set>
                                     <p:anim calcmode="lin" valueType="num">
                                       <p:cBhvr additive="base">
-                                        <p:cTn id="11" dur="500" fill="hold"/>
+                                        <p:cTn id="13" dur="500" fill="hold"/>
                                         <p:tgtEl>
                                           <p:spTgt spid="25"/>
                                         </p:tgtEl>
@@ -10362,7 +10491,7 @@
                                     </p:anim>
                                     <p:anim calcmode="lin" valueType="num">
                                       <p:cBhvr additive="base">
-                                        <p:cTn id="12" dur="500" fill="hold"/>
+                                        <p:cTn id="14" dur="500" fill="hold"/>
                                         <p:tgtEl>
                                           <p:spTgt spid="25"/>
                                         </p:tgtEl>
@@ -10447,7 +10576,7 @@
           <p:cNvPr id="2" name="!!Anchor_Kicker_Rail!!">
             <a:extLst>
               <a:ext uri="{FF2B5EF4-FFF2-40B4-BE49-F238E27FC236}">
-                <a16:creationId xmlns:a16="http://schemas.microsoft.com/office/drawing/2014/main" id="{54ECB1BC-1A28-8A34-B822-C25AC9079709}"/>
+                <a16:creationId xmlns:a16="http://schemas.microsoft.com/office/drawing/2014/main" id="{1D5E19C2-4E67-3C38-08AD-05F5A617C1F2}"/>
               </a:ext>
             </a:extLst>
           </p:cNvPr>
@@ -10487,7 +10616,7 @@
           <p:cNvPr id="3" name="!!Anchor_Slide_Tracker!!">
             <a:extLst>
               <a:ext uri="{FF2B5EF4-FFF2-40B4-BE49-F238E27FC236}">
-                <a16:creationId xmlns:a16="http://schemas.microsoft.com/office/drawing/2014/main" id="{B6E18C9D-03A1-276F-4C94-7DED8BE05361}"/>
+                <a16:creationId xmlns:a16="http://schemas.microsoft.com/office/drawing/2014/main" id="{2F13DE3A-080D-AA61-8188-B0DBB6A83913}"/>
               </a:ext>
             </a:extLst>
           </p:cNvPr>
@@ -10528,7 +10657,7 @@
           <p:cNvPr id="4" name="!!Anchor_Assertion_Title!!">
             <a:extLst>
               <a:ext uri="{FF2B5EF4-FFF2-40B4-BE49-F238E27FC236}">
-                <a16:creationId xmlns:a16="http://schemas.microsoft.com/office/drawing/2014/main" id="{7881321D-5208-D93B-97A0-05A3ED0C5886}"/>
+                <a16:creationId xmlns:a16="http://schemas.microsoft.com/office/drawing/2014/main" id="{74E191E1-FB69-0256-3FC1-4F7A4E29B0E2}"/>
               </a:ext>
             </a:extLst>
           </p:cNvPr>
@@ -10574,7 +10703,7 @@
           <p:cNvPr id="11" name="!!Stage_Hero_Container!!">
             <a:extLst>
               <a:ext uri="{FF2B5EF4-FFF2-40B4-BE49-F238E27FC236}">
-                <a16:creationId xmlns:a16="http://schemas.microsoft.com/office/drawing/2014/main" id="{87619A90-BFEE-1412-C818-818560358335}"/>
+                <a16:creationId xmlns:a16="http://schemas.microsoft.com/office/drawing/2014/main" id="{87381660-9AB6-93F5-66C3-C5385091F8FA}"/>
               </a:ext>
             </a:extLst>
           </p:cNvPr>
@@ -10594,7 +10723,7 @@
             <p:cNvPr id="5" name="Rectangle: Rounded Corners 4">
               <a:extLst>
                 <a:ext uri="{FF2B5EF4-FFF2-40B4-BE49-F238E27FC236}">
-                  <a16:creationId xmlns:a16="http://schemas.microsoft.com/office/drawing/2014/main" id="{85C30617-B46C-F1A2-E903-047500EF75A2}"/>
+                  <a16:creationId xmlns:a16="http://schemas.microsoft.com/office/drawing/2014/main" id="{9E90D226-C69E-7CA6-8B9A-7B1C75641612}"/>
                 </a:ext>
               </a:extLst>
             </p:cNvPr>
@@ -10648,7 +10777,7 @@
             <p:cNvPr id="6" name="Rectangle: Rounded Corners 5">
               <a:extLst>
                 <a:ext uri="{FF2B5EF4-FFF2-40B4-BE49-F238E27FC236}">
-                  <a16:creationId xmlns:a16="http://schemas.microsoft.com/office/drawing/2014/main" id="{E140B68F-0A93-C2B9-69C4-DAB0D7F06A6D}"/>
+                  <a16:creationId xmlns:a16="http://schemas.microsoft.com/office/drawing/2014/main" id="{9A93970E-148E-FCF9-7058-53F5636FE3F1}"/>
                 </a:ext>
               </a:extLst>
             </p:cNvPr>
@@ -10724,7 +10853,7 @@
             <p:cNvPr id="7" name="Oval 6">
               <a:extLst>
                 <a:ext uri="{FF2B5EF4-FFF2-40B4-BE49-F238E27FC236}">
-                  <a16:creationId xmlns:a16="http://schemas.microsoft.com/office/drawing/2014/main" id="{ACBBDE4D-6958-8D7A-A392-5A8C44371DC5}"/>
+                  <a16:creationId xmlns:a16="http://schemas.microsoft.com/office/drawing/2014/main" id="{EF42FB63-8F4D-1655-7889-1BC5B620572C}"/>
                 </a:ext>
               </a:extLst>
             </p:cNvPr>
@@ -10792,7 +10921,7 @@
             <p:cNvPr id="9" name="Graphic 8">
               <a:extLst>
                 <a:ext uri="{FF2B5EF4-FFF2-40B4-BE49-F238E27FC236}">
-                  <a16:creationId xmlns:a16="http://schemas.microsoft.com/office/drawing/2014/main" id="{622DDCBD-C8E4-B40D-2F33-D16DE8C6AECF}"/>
+                  <a16:creationId xmlns:a16="http://schemas.microsoft.com/office/drawing/2014/main" id="{9D034943-102D-D4F0-E518-FEC03775F86C}"/>
                 </a:ext>
               </a:extLst>
             </p:cNvPr>
@@ -10828,7 +10957,7 @@
             <p:cNvPr id="10" name="TextBox 9">
               <a:extLst>
                 <a:ext uri="{FF2B5EF4-FFF2-40B4-BE49-F238E27FC236}">
-                  <a16:creationId xmlns:a16="http://schemas.microsoft.com/office/drawing/2014/main" id="{25CB6D2D-5F5F-4B09-045F-F8F8C98AFF97}"/>
+                  <a16:creationId xmlns:a16="http://schemas.microsoft.com/office/drawing/2014/main" id="{E8221954-02BE-D86F-C387-52C59B671FD8}"/>
                 </a:ext>
               </a:extLst>
             </p:cNvPr>
@@ -10893,7 +11022,7 @@
           <p:cNvPr id="18" name="!!Stage_Sub_Card_1!!">
             <a:extLst>
               <a:ext uri="{FF2B5EF4-FFF2-40B4-BE49-F238E27FC236}">
-                <a16:creationId xmlns:a16="http://schemas.microsoft.com/office/drawing/2014/main" id="{02508CE3-4CD1-45FA-400B-B85728EC4F87}"/>
+                <a16:creationId xmlns:a16="http://schemas.microsoft.com/office/drawing/2014/main" id="{79D95E7B-1667-501C-6B74-0C39EDDC0D40}"/>
               </a:ext>
             </a:extLst>
           </p:cNvPr>
@@ -10913,7 +11042,7 @@
             <p:cNvPr id="12" name="Rectangle: Rounded Corners 11">
               <a:extLst>
                 <a:ext uri="{FF2B5EF4-FFF2-40B4-BE49-F238E27FC236}">
-                  <a16:creationId xmlns:a16="http://schemas.microsoft.com/office/drawing/2014/main" id="{BBAEFFB7-6051-0146-CFB2-7C2A115EDCE0}"/>
+                  <a16:creationId xmlns:a16="http://schemas.microsoft.com/office/drawing/2014/main" id="{79954534-3516-A013-0468-1FD8A2C29646}"/>
                 </a:ext>
               </a:extLst>
             </p:cNvPr>
@@ -10967,7 +11096,7 @@
             <p:cNvPr id="13" name="Rectangle: Rounded Corners 12">
               <a:extLst>
                 <a:ext uri="{FF2B5EF4-FFF2-40B4-BE49-F238E27FC236}">
-                  <a16:creationId xmlns:a16="http://schemas.microsoft.com/office/drawing/2014/main" id="{1D367177-38EF-2ED4-8E68-8FA3B3103FF5}"/>
+                  <a16:creationId xmlns:a16="http://schemas.microsoft.com/office/drawing/2014/main" id="{1A1B48EE-1D21-7673-E05A-C7B83E19B4C6}"/>
                 </a:ext>
               </a:extLst>
             </p:cNvPr>
@@ -11043,7 +11172,7 @@
             <p:cNvPr id="14" name="Oval 13">
               <a:extLst>
                 <a:ext uri="{FF2B5EF4-FFF2-40B4-BE49-F238E27FC236}">
-                  <a16:creationId xmlns:a16="http://schemas.microsoft.com/office/drawing/2014/main" id="{2A798DC6-94A2-8CEF-9C76-B0A99A9BF911}"/>
+                  <a16:creationId xmlns:a16="http://schemas.microsoft.com/office/drawing/2014/main" id="{8E5FFF79-545D-2BE1-94FD-74FA9C073667}"/>
                 </a:ext>
               </a:extLst>
             </p:cNvPr>
@@ -11111,7 +11240,7 @@
             <p:cNvPr id="16" name="Graphic 15">
               <a:extLst>
                 <a:ext uri="{FF2B5EF4-FFF2-40B4-BE49-F238E27FC236}">
-                  <a16:creationId xmlns:a16="http://schemas.microsoft.com/office/drawing/2014/main" id="{7EBCA0BB-0B37-3424-0FF1-B750FC26A999}"/>
+                  <a16:creationId xmlns:a16="http://schemas.microsoft.com/office/drawing/2014/main" id="{CD093870-E4A7-06A0-0638-0D968BDC4593}"/>
                 </a:ext>
               </a:extLst>
             </p:cNvPr>
@@ -11147,7 +11276,7 @@
             <p:cNvPr id="17" name="TextBox 16">
               <a:extLst>
                 <a:ext uri="{FF2B5EF4-FFF2-40B4-BE49-F238E27FC236}">
-                  <a16:creationId xmlns:a16="http://schemas.microsoft.com/office/drawing/2014/main" id="{40576DE1-396A-2FBF-678D-A53EB5250E53}"/>
+                  <a16:creationId xmlns:a16="http://schemas.microsoft.com/office/drawing/2014/main" id="{04773A56-3BC1-A799-2B98-C852A9E818B4}"/>
                 </a:ext>
               </a:extLst>
             </p:cNvPr>
@@ -11209,7 +11338,7 @@
           <p:cNvPr id="25" name="!!Stage_Sub_Card_2!!">
             <a:extLst>
               <a:ext uri="{FF2B5EF4-FFF2-40B4-BE49-F238E27FC236}">
-                <a16:creationId xmlns:a16="http://schemas.microsoft.com/office/drawing/2014/main" id="{E1D739A7-1427-6A66-831E-E6343B6540FE}"/>
+                <a16:creationId xmlns:a16="http://schemas.microsoft.com/office/drawing/2014/main" id="{8363A14A-185D-EB87-DDA9-EA1777D4DDE5}"/>
               </a:ext>
             </a:extLst>
           </p:cNvPr>
@@ -11229,7 +11358,7 @@
             <p:cNvPr id="19" name="Rectangle: Rounded Corners 18">
               <a:extLst>
                 <a:ext uri="{FF2B5EF4-FFF2-40B4-BE49-F238E27FC236}">
-                  <a16:creationId xmlns:a16="http://schemas.microsoft.com/office/drawing/2014/main" id="{73499E52-7752-0788-C510-7E3B09C1B622}"/>
+                  <a16:creationId xmlns:a16="http://schemas.microsoft.com/office/drawing/2014/main" id="{2B768160-2FB1-9E64-D882-1B10601248FC}"/>
                 </a:ext>
               </a:extLst>
             </p:cNvPr>
@@ -11283,7 +11412,7 @@
             <p:cNvPr id="20" name="Rectangle: Rounded Corners 19">
               <a:extLst>
                 <a:ext uri="{FF2B5EF4-FFF2-40B4-BE49-F238E27FC236}">
-                  <a16:creationId xmlns:a16="http://schemas.microsoft.com/office/drawing/2014/main" id="{B8E6162F-220F-D0E2-4BD0-1D1EA5B20F43}"/>
+                  <a16:creationId xmlns:a16="http://schemas.microsoft.com/office/drawing/2014/main" id="{0FAC24AF-4FFE-601D-85A3-2F7FC23D7A15}"/>
                 </a:ext>
               </a:extLst>
             </p:cNvPr>
@@ -11359,7 +11488,7 @@
             <p:cNvPr id="21" name="Oval 20">
               <a:extLst>
                 <a:ext uri="{FF2B5EF4-FFF2-40B4-BE49-F238E27FC236}">
-                  <a16:creationId xmlns:a16="http://schemas.microsoft.com/office/drawing/2014/main" id="{59237E78-60F2-6DE3-9C5C-4C654029BE3F}"/>
+                  <a16:creationId xmlns:a16="http://schemas.microsoft.com/office/drawing/2014/main" id="{051E3C5C-3C41-C386-93D9-34F73AB6A4E5}"/>
                 </a:ext>
               </a:extLst>
             </p:cNvPr>
@@ -11427,7 +11556,7 @@
             <p:cNvPr id="23" name="Graphic 22">
               <a:extLst>
                 <a:ext uri="{FF2B5EF4-FFF2-40B4-BE49-F238E27FC236}">
-                  <a16:creationId xmlns:a16="http://schemas.microsoft.com/office/drawing/2014/main" id="{1A84B2A2-4F04-6C9C-BA11-73D4B0E54F01}"/>
+                  <a16:creationId xmlns:a16="http://schemas.microsoft.com/office/drawing/2014/main" id="{5C90271F-6737-7CF0-4BA7-CB6CA638EAB2}"/>
                 </a:ext>
               </a:extLst>
             </p:cNvPr>
@@ -11463,7 +11592,7 @@
             <p:cNvPr id="24" name="TextBox 23">
               <a:extLst>
                 <a:ext uri="{FF2B5EF4-FFF2-40B4-BE49-F238E27FC236}">
-                  <a16:creationId xmlns:a16="http://schemas.microsoft.com/office/drawing/2014/main" id="{4081F108-FA32-1D06-57A5-5357F5CF67F0}"/>
+                  <a16:creationId xmlns:a16="http://schemas.microsoft.com/office/drawing/2014/main" id="{090395DA-B4BA-1C7B-DAAA-98EC3FC7F318}"/>
                 </a:ext>
               </a:extLst>
             </p:cNvPr>
@@ -11525,7 +11654,7 @@
           <p:cNvPr id="26" name="!!Anchor_Source_Footer!!">
             <a:extLst>
               <a:ext uri="{FF2B5EF4-FFF2-40B4-BE49-F238E27FC236}">
-                <a16:creationId xmlns:a16="http://schemas.microsoft.com/office/drawing/2014/main" id="{3ECB00F4-6086-FB06-FA7A-30D119C35765}"/>
+                <a16:creationId xmlns:a16="http://schemas.microsoft.com/office/drawing/2014/main" id="{CDD98A5B-AD99-BD2B-6956-1A6C9C7AE850}"/>
               </a:ext>
             </a:extLst>
           </p:cNvPr>
@@ -11563,7 +11692,7 @@
     </p:spTree>
     <p:extLst>
       <p:ext uri="{BB962C8B-B14F-4D97-AF65-F5344CB8AC3E}">
-        <p14:creationId xmlns:p14="http://schemas.microsoft.com/office/powerpoint/2010/main" val="3165860284"/>
+        <p14:creationId xmlns:p14="http://schemas.microsoft.com/office/powerpoint/2010/main" val="2996919246"/>
       </p:ext>
     </p:extLst>
   </p:cSld>
@@ -11594,9 +11723,6 @@
                     <p:cTn id="3" fill="hold">
                       <p:stCondLst>
                         <p:cond delay="indefinite"/>
-                        <p:cond evt="onBegin" delay="0">
-                          <p:tn val="2"/>
-                        </p:cond>
                       </p:stCondLst>
                       <p:childTnLst>
                         <p:par>
@@ -11606,9 +11732,9 @@
                             </p:stCondLst>
                             <p:childTnLst>
                               <p:par>
-                                <p:cTn id="5" presetID="2" presetClass="entr" presetSubtype="1" accel="50000" decel="50000" fill="hold" nodeType="withEffect">
+                                <p:cTn id="5" presetID="2" presetClass="entr" presetSubtype="1" accel="50000" decel="50000" fill="hold" nodeType="clickEffect">
                                   <p:stCondLst>
-                                    <p:cond delay="120"/>
+                                    <p:cond delay="0"/>
                                   </p:stCondLst>
                                   <p:childTnLst>
                                     <p:set>
@@ -11678,15 +11804,33 @@
                                   </p:childTnLst>
                                 </p:cTn>
                               </p:par>
+                            </p:childTnLst>
+                          </p:cTn>
+                        </p:par>
+                      </p:childTnLst>
+                    </p:cTn>
+                  </p:par>
+                  <p:par>
+                    <p:cTn id="9" fill="hold">
+                      <p:stCondLst>
+                        <p:cond delay="indefinite"/>
+                      </p:stCondLst>
+                      <p:childTnLst>
+                        <p:par>
+                          <p:cTn id="10" fill="hold">
+                            <p:stCondLst>
+                              <p:cond delay="0"/>
+                            </p:stCondLst>
+                            <p:childTnLst>
                               <p:par>
-                                <p:cTn id="9" presetID="2" presetClass="entr" presetSubtype="1" accel="50000" decel="50000" fill="hold" nodeType="withEffect">
+                                <p:cTn id="11" presetID="2" presetClass="entr" presetSubtype="1" accel="50000" decel="50000" fill="hold" nodeType="clickEffect">
                                   <p:stCondLst>
-                                    <p:cond delay="240"/>
+                                    <p:cond delay="0"/>
                                   </p:stCondLst>
                                   <p:childTnLst>
                                     <p:set>
                                       <p:cBhvr>
-                                        <p:cTn id="10" dur="1" fill="hold">
+                                        <p:cTn id="12" dur="1" fill="hold">
                                           <p:stCondLst>
                                             <p:cond delay="0"/>
                                           </p:stCondLst>
@@ -11704,7 +11848,7 @@
                                     </p:set>
                                     <p:anim calcmode="lin" valueType="num">
                                       <p:cBhvr additive="base">
-                                        <p:cTn id="11" dur="500" fill="hold"/>
+                                        <p:cTn id="13" dur="500" fill="hold"/>
                                         <p:tgtEl>
                                           <p:spTgt spid="25"/>
                                         </p:tgtEl>
@@ -11727,7 +11871,7 @@
                                     </p:anim>
                                     <p:anim calcmode="lin" valueType="num">
                                       <p:cBhvr additive="base">
-                                        <p:cTn id="12" dur="500" fill="hold"/>
+                                        <p:cTn id="14" dur="500" fill="hold"/>
                                         <p:tgtEl>
                                           <p:spTgt spid="25"/>
                                         </p:tgtEl>
@@ -11812,7 +11956,7 @@
           <p:cNvPr id="2" name="!!Anchor_Kicker_Rail!!">
             <a:extLst>
               <a:ext uri="{FF2B5EF4-FFF2-40B4-BE49-F238E27FC236}">
-                <a16:creationId xmlns:a16="http://schemas.microsoft.com/office/drawing/2014/main" id="{8871BEDA-9F2D-C159-7EF5-975EA8DE6170}"/>
+                <a16:creationId xmlns:a16="http://schemas.microsoft.com/office/drawing/2014/main" id="{6E085EB6-22D1-2660-1C1C-5B58FD159538}"/>
               </a:ext>
             </a:extLst>
           </p:cNvPr>
@@ -11852,7 +11996,7 @@
           <p:cNvPr id="3" name="!!Anchor_Slide_Tracker!!">
             <a:extLst>
               <a:ext uri="{FF2B5EF4-FFF2-40B4-BE49-F238E27FC236}">
-                <a16:creationId xmlns:a16="http://schemas.microsoft.com/office/drawing/2014/main" id="{2F1D2D61-4D7D-841B-0B8D-BDBE05E1557F}"/>
+                <a16:creationId xmlns:a16="http://schemas.microsoft.com/office/drawing/2014/main" id="{EFAD13B5-D294-C953-27C1-2DE5960E0DFA}"/>
               </a:ext>
             </a:extLst>
           </p:cNvPr>
@@ -11893,7 +12037,7 @@
           <p:cNvPr id="4" name="!!Anchor_Assertion_Title!!">
             <a:extLst>
               <a:ext uri="{FF2B5EF4-FFF2-40B4-BE49-F238E27FC236}">
-                <a16:creationId xmlns:a16="http://schemas.microsoft.com/office/drawing/2014/main" id="{DEAC01D3-58AA-2F4B-C39C-5B5D4E298649}"/>
+                <a16:creationId xmlns:a16="http://schemas.microsoft.com/office/drawing/2014/main" id="{4F735221-84B5-2CFD-71C9-2AF8867807B5}"/>
               </a:ext>
             </a:extLst>
           </p:cNvPr>
@@ -11933,7 +12077,7 @@
           <p:cNvPr id="12" name="!!Stage_Hero_Container!!">
             <a:extLst>
               <a:ext uri="{FF2B5EF4-FFF2-40B4-BE49-F238E27FC236}">
-                <a16:creationId xmlns:a16="http://schemas.microsoft.com/office/drawing/2014/main" id="{CE7BDA62-AF6C-1782-A7C6-3815451ECD94}"/>
+                <a16:creationId xmlns:a16="http://schemas.microsoft.com/office/drawing/2014/main" id="{B0029C39-94B1-E9D9-0155-A9DC6CA816B4}"/>
               </a:ext>
             </a:extLst>
           </p:cNvPr>
@@ -11953,7 +12097,7 @@
             <p:cNvPr id="6" name="Picture 5">
               <a:extLst>
                 <a:ext uri="{FF2B5EF4-FFF2-40B4-BE49-F238E27FC236}">
-                  <a16:creationId xmlns:a16="http://schemas.microsoft.com/office/drawing/2014/main" id="{8A42C3A3-7082-998E-ABE4-D1E500A57E36}"/>
+                  <a16:creationId xmlns:a16="http://schemas.microsoft.com/office/drawing/2014/main" id="{23B28CD4-8833-C301-52CE-5C4502AA307B}"/>
                 </a:ext>
               </a:extLst>
             </p:cNvPr>
@@ -11994,7 +12138,7 @@
             <p:cNvPr id="7" name="Rectangle: Rounded Corners 6">
               <a:extLst>
                 <a:ext uri="{FF2B5EF4-FFF2-40B4-BE49-F238E27FC236}">
-                  <a16:creationId xmlns:a16="http://schemas.microsoft.com/office/drawing/2014/main" id="{F6178DD8-A252-0543-182C-0EDEEC303DD0}"/>
+                  <a16:creationId xmlns:a16="http://schemas.microsoft.com/office/drawing/2014/main" id="{930C68E1-058C-317B-1193-CFC6ED766A0B}"/>
                 </a:ext>
               </a:extLst>
             </p:cNvPr>
@@ -12048,7 +12192,7 @@
             <p:cNvPr id="8" name="Oval 7">
               <a:extLst>
                 <a:ext uri="{FF2B5EF4-FFF2-40B4-BE49-F238E27FC236}">
-                  <a16:creationId xmlns:a16="http://schemas.microsoft.com/office/drawing/2014/main" id="{0680B720-9831-C354-C421-570B05120CB5}"/>
+                  <a16:creationId xmlns:a16="http://schemas.microsoft.com/office/drawing/2014/main" id="{92C0E8AD-AE79-36E1-8557-59B8F5358568}"/>
                 </a:ext>
               </a:extLst>
             </p:cNvPr>
@@ -12116,7 +12260,7 @@
             <p:cNvPr id="10" name="Graphic 9">
               <a:extLst>
                 <a:ext uri="{FF2B5EF4-FFF2-40B4-BE49-F238E27FC236}">
-                  <a16:creationId xmlns:a16="http://schemas.microsoft.com/office/drawing/2014/main" id="{A726FC76-543C-232B-7383-8CCDF7144795}"/>
+                  <a16:creationId xmlns:a16="http://schemas.microsoft.com/office/drawing/2014/main" id="{B411D321-E352-5747-612F-FAFCBB705B92}"/>
                 </a:ext>
               </a:extLst>
             </p:cNvPr>
@@ -12152,7 +12296,7 @@
             <p:cNvPr id="11" name="TextBox 10">
               <a:extLst>
                 <a:ext uri="{FF2B5EF4-FFF2-40B4-BE49-F238E27FC236}">
-                  <a16:creationId xmlns:a16="http://schemas.microsoft.com/office/drawing/2014/main" id="{057E94E3-9840-AE7C-C62F-01177DD81A87}"/>
+                  <a16:creationId xmlns:a16="http://schemas.microsoft.com/office/drawing/2014/main" id="{C9296128-EDB1-EB41-B34D-82485472B584}"/>
                 </a:ext>
               </a:extLst>
             </p:cNvPr>
@@ -12211,7 +12355,7 @@
           <p:cNvPr id="18" name="!!Stage_Sub_Card_1!!">
             <a:extLst>
               <a:ext uri="{FF2B5EF4-FFF2-40B4-BE49-F238E27FC236}">
-                <a16:creationId xmlns:a16="http://schemas.microsoft.com/office/drawing/2014/main" id="{B5572DF9-536D-EF6C-1506-9BECE635C97E}"/>
+                <a16:creationId xmlns:a16="http://schemas.microsoft.com/office/drawing/2014/main" id="{A9CE39F1-79A4-2F20-C631-11A081C43838}"/>
               </a:ext>
             </a:extLst>
           </p:cNvPr>
@@ -12231,7 +12375,7 @@
             <p:cNvPr id="13" name="Rectangle: Rounded Corners 12">
               <a:extLst>
                 <a:ext uri="{FF2B5EF4-FFF2-40B4-BE49-F238E27FC236}">
-                  <a16:creationId xmlns:a16="http://schemas.microsoft.com/office/drawing/2014/main" id="{85AA4DC2-8976-A0B7-365A-EF7DA5DC98FF}"/>
+                  <a16:creationId xmlns:a16="http://schemas.microsoft.com/office/drawing/2014/main" id="{0D7EFD22-E3A7-8E24-12D7-EAF5483628E9}"/>
                 </a:ext>
               </a:extLst>
             </p:cNvPr>
@@ -12285,7 +12429,7 @@
             <p:cNvPr id="14" name="Oval 13">
               <a:extLst>
                 <a:ext uri="{FF2B5EF4-FFF2-40B4-BE49-F238E27FC236}">
-                  <a16:creationId xmlns:a16="http://schemas.microsoft.com/office/drawing/2014/main" id="{42BE70E1-E50C-D926-5956-01FB2D408D2A}"/>
+                  <a16:creationId xmlns:a16="http://schemas.microsoft.com/office/drawing/2014/main" id="{59A30CE8-044A-A319-8F43-C8CFCBAA0FF4}"/>
                 </a:ext>
               </a:extLst>
             </p:cNvPr>
@@ -12353,7 +12497,7 @@
             <p:cNvPr id="16" name="Graphic 15">
               <a:extLst>
                 <a:ext uri="{FF2B5EF4-FFF2-40B4-BE49-F238E27FC236}">
-                  <a16:creationId xmlns:a16="http://schemas.microsoft.com/office/drawing/2014/main" id="{82D0E914-02DE-1C24-FDDA-8EAAED2515BA}"/>
+                  <a16:creationId xmlns:a16="http://schemas.microsoft.com/office/drawing/2014/main" id="{98D09CEB-D334-845C-E0A2-33BBC05BF947}"/>
                 </a:ext>
               </a:extLst>
             </p:cNvPr>
@@ -12389,7 +12533,7 @@
             <p:cNvPr id="17" name="TextBox 16">
               <a:extLst>
                 <a:ext uri="{FF2B5EF4-FFF2-40B4-BE49-F238E27FC236}">
-                  <a16:creationId xmlns:a16="http://schemas.microsoft.com/office/drawing/2014/main" id="{DF917504-9343-BCF1-11CF-EAD6A8EC1FBF}"/>
+                  <a16:creationId xmlns:a16="http://schemas.microsoft.com/office/drawing/2014/main" id="{CE3A5BA1-0CA0-8CA1-483D-BD80B6AEA312}"/>
                 </a:ext>
               </a:extLst>
             </p:cNvPr>
@@ -12451,7 +12595,7 @@
           <p:cNvPr id="24" name="!!Stage_Sub_Card_2!!">
             <a:extLst>
               <a:ext uri="{FF2B5EF4-FFF2-40B4-BE49-F238E27FC236}">
-                <a16:creationId xmlns:a16="http://schemas.microsoft.com/office/drawing/2014/main" id="{1EBAAF7E-8BD4-631B-9782-0D2B2F68DF59}"/>
+                <a16:creationId xmlns:a16="http://schemas.microsoft.com/office/drawing/2014/main" id="{5BA79BD7-F41F-5C6E-87F3-9237D195F53F}"/>
               </a:ext>
             </a:extLst>
           </p:cNvPr>
@@ -12471,7 +12615,7 @@
             <p:cNvPr id="19" name="Rectangle: Rounded Corners 18">
               <a:extLst>
                 <a:ext uri="{FF2B5EF4-FFF2-40B4-BE49-F238E27FC236}">
-                  <a16:creationId xmlns:a16="http://schemas.microsoft.com/office/drawing/2014/main" id="{D917E227-9999-D6D4-599A-5CD3D9C639E3}"/>
+                  <a16:creationId xmlns:a16="http://schemas.microsoft.com/office/drawing/2014/main" id="{1F0C9C5D-0F01-E44A-ECAD-F4E7D638523F}"/>
                 </a:ext>
               </a:extLst>
             </p:cNvPr>
@@ -12525,7 +12669,7 @@
             <p:cNvPr id="20" name="Oval 19">
               <a:extLst>
                 <a:ext uri="{FF2B5EF4-FFF2-40B4-BE49-F238E27FC236}">
-                  <a16:creationId xmlns:a16="http://schemas.microsoft.com/office/drawing/2014/main" id="{C7507302-F5C7-8E9C-3193-D730B030FAB4}"/>
+                  <a16:creationId xmlns:a16="http://schemas.microsoft.com/office/drawing/2014/main" id="{DF70D576-5853-E83B-96BA-18859E9C0EB0}"/>
                 </a:ext>
               </a:extLst>
             </p:cNvPr>
@@ -12593,7 +12737,7 @@
             <p:cNvPr id="22" name="Graphic 21">
               <a:extLst>
                 <a:ext uri="{FF2B5EF4-FFF2-40B4-BE49-F238E27FC236}">
-                  <a16:creationId xmlns:a16="http://schemas.microsoft.com/office/drawing/2014/main" id="{062D18A4-D413-6B58-83E2-C31B6E08D8C0}"/>
+                  <a16:creationId xmlns:a16="http://schemas.microsoft.com/office/drawing/2014/main" id="{1D3A3B61-C539-CAD4-3DD6-7F87687910D1}"/>
                 </a:ext>
               </a:extLst>
             </p:cNvPr>
@@ -12629,7 +12773,7 @@
             <p:cNvPr id="23" name="TextBox 22">
               <a:extLst>
                 <a:ext uri="{FF2B5EF4-FFF2-40B4-BE49-F238E27FC236}">
-                  <a16:creationId xmlns:a16="http://schemas.microsoft.com/office/drawing/2014/main" id="{764F33B3-BD1F-3D3D-B955-44AD172AD2C1}"/>
+                  <a16:creationId xmlns:a16="http://schemas.microsoft.com/office/drawing/2014/main" id="{8A773A45-2D0B-3F4F-B58B-84EBED44D663}"/>
                 </a:ext>
               </a:extLst>
             </p:cNvPr>
@@ -12685,7 +12829,7 @@
           <p:cNvPr id="25" name="!!Anchor_Source_Footer!!">
             <a:extLst>
               <a:ext uri="{FF2B5EF4-FFF2-40B4-BE49-F238E27FC236}">
-                <a16:creationId xmlns:a16="http://schemas.microsoft.com/office/drawing/2014/main" id="{3801A7EA-AEFE-1A74-7FCC-4C099F00D389}"/>
+                <a16:creationId xmlns:a16="http://schemas.microsoft.com/office/drawing/2014/main" id="{877F37B9-9FDE-A6CC-99DB-1E184851D17B}"/>
               </a:ext>
             </a:extLst>
           </p:cNvPr>
@@ -12729,7 +12873,7 @@
     </p:spTree>
     <p:extLst>
       <p:ext uri="{BB962C8B-B14F-4D97-AF65-F5344CB8AC3E}">
-        <p14:creationId xmlns:p14="http://schemas.microsoft.com/office/powerpoint/2010/main" val="3044231513"/>
+        <p14:creationId xmlns:p14="http://schemas.microsoft.com/office/powerpoint/2010/main" val="1531850624"/>
       </p:ext>
     </p:extLst>
   </p:cSld>
@@ -12760,9 +12904,6 @@
                     <p:cTn id="3" fill="hold">
                       <p:stCondLst>
                         <p:cond delay="indefinite"/>
-                        <p:cond evt="onBegin" delay="0">
-                          <p:tn val="2"/>
-                        </p:cond>
                       </p:stCondLst>
                       <p:childTnLst>
                         <p:par>
@@ -12772,9 +12913,9 @@
                             </p:stCondLst>
                             <p:childTnLst>
                               <p:par>
-                                <p:cTn id="5" presetID="2" presetClass="entr" presetSubtype="1" accel="50000" decel="50000" fill="hold" nodeType="withEffect">
+                                <p:cTn id="5" presetID="2" presetClass="entr" presetSubtype="1" accel="50000" decel="50000" fill="hold" nodeType="clickEffect">
                                   <p:stCondLst>
-                                    <p:cond delay="120"/>
+                                    <p:cond delay="0"/>
                                   </p:stCondLst>
                                   <p:childTnLst>
                                     <p:set>
@@ -12844,15 +12985,33 @@
                                   </p:childTnLst>
                                 </p:cTn>
                               </p:par>
+                            </p:childTnLst>
+                          </p:cTn>
+                        </p:par>
+                      </p:childTnLst>
+                    </p:cTn>
+                  </p:par>
+                  <p:par>
+                    <p:cTn id="9" fill="hold">
+                      <p:stCondLst>
+                        <p:cond delay="indefinite"/>
+                      </p:stCondLst>
+                      <p:childTnLst>
+                        <p:par>
+                          <p:cTn id="10" fill="hold">
+                            <p:stCondLst>
+                              <p:cond delay="0"/>
+                            </p:stCondLst>
+                            <p:childTnLst>
                               <p:par>
-                                <p:cTn id="9" presetID="2" presetClass="entr" presetSubtype="1" accel="50000" decel="50000" fill="hold" nodeType="withEffect">
+                                <p:cTn id="11" presetID="2" presetClass="entr" presetSubtype="1" accel="50000" decel="50000" fill="hold" nodeType="clickEffect">
                                   <p:stCondLst>
-                                    <p:cond delay="240"/>
+                                    <p:cond delay="0"/>
                                   </p:stCondLst>
                                   <p:childTnLst>
                                     <p:set>
                                       <p:cBhvr>
-                                        <p:cTn id="10" dur="1" fill="hold">
+                                        <p:cTn id="12" dur="1" fill="hold">
                                           <p:stCondLst>
                                             <p:cond delay="0"/>
                                           </p:stCondLst>
@@ -12870,7 +13029,7 @@
                                     </p:set>
                                     <p:anim calcmode="lin" valueType="num">
                                       <p:cBhvr additive="base">
-                                        <p:cTn id="11" dur="500" fill="hold"/>
+                                        <p:cTn id="13" dur="500" fill="hold"/>
                                         <p:tgtEl>
                                           <p:spTgt spid="24"/>
                                         </p:tgtEl>
@@ -12893,7 +13052,7 @@
                                     </p:anim>
                                     <p:anim calcmode="lin" valueType="num">
                                       <p:cBhvr additive="base">
-                                        <p:cTn id="12" dur="500" fill="hold"/>
+                                        <p:cTn id="14" dur="500" fill="hold"/>
                                         <p:tgtEl>
                                           <p:spTgt spid="24"/>
                                         </p:tgtEl>
@@ -12978,7 +13137,7 @@
           <p:cNvPr id="2" name="!!Anchor_Kicker_Rail!!">
             <a:extLst>
               <a:ext uri="{FF2B5EF4-FFF2-40B4-BE49-F238E27FC236}">
-                <a16:creationId xmlns:a16="http://schemas.microsoft.com/office/drawing/2014/main" id="{EA844624-6169-2F88-FB89-5DD7EEBDF984}"/>
+                <a16:creationId xmlns:a16="http://schemas.microsoft.com/office/drawing/2014/main" id="{B9FE2F04-3413-A0EA-9368-465CEE6927C9}"/>
               </a:ext>
             </a:extLst>
           </p:cNvPr>
@@ -13018,7 +13177,7 @@
           <p:cNvPr id="3" name="!!Anchor_Slide_Tracker!!">
             <a:extLst>
               <a:ext uri="{FF2B5EF4-FFF2-40B4-BE49-F238E27FC236}">
-                <a16:creationId xmlns:a16="http://schemas.microsoft.com/office/drawing/2014/main" id="{AA6A29C3-95DB-4C59-4F61-8D3F45B8AC57}"/>
+                <a16:creationId xmlns:a16="http://schemas.microsoft.com/office/drawing/2014/main" id="{09DB9390-A08D-851D-5BD8-6C765AFA81FE}"/>
               </a:ext>
             </a:extLst>
           </p:cNvPr>
@@ -13059,7 +13218,7 @@
           <p:cNvPr id="4" name="!!Anchor_Assertion_Title!!">
             <a:extLst>
               <a:ext uri="{FF2B5EF4-FFF2-40B4-BE49-F238E27FC236}">
-                <a16:creationId xmlns:a16="http://schemas.microsoft.com/office/drawing/2014/main" id="{D79F1AF2-FF10-47EE-6BA8-4E83A920C344}"/>
+                <a16:creationId xmlns:a16="http://schemas.microsoft.com/office/drawing/2014/main" id="{E0134D2E-287B-9C72-DDAD-5818B1170709}"/>
               </a:ext>
             </a:extLst>
           </p:cNvPr>
@@ -13105,7 +13264,7 @@
           <p:cNvPr id="11" name="!!Stage_Hero_Container!!">
             <a:extLst>
               <a:ext uri="{FF2B5EF4-FFF2-40B4-BE49-F238E27FC236}">
-                <a16:creationId xmlns:a16="http://schemas.microsoft.com/office/drawing/2014/main" id="{34EA833B-8CD8-539D-1B84-C32A5348F660}"/>
+                <a16:creationId xmlns:a16="http://schemas.microsoft.com/office/drawing/2014/main" id="{EA728A3A-7F82-0654-FEB3-65D22A2279F2}"/>
               </a:ext>
             </a:extLst>
           </p:cNvPr>
@@ -13125,7 +13284,7 @@
             <p:cNvPr id="5" name="Rectangle: Rounded Corners 4">
               <a:extLst>
                 <a:ext uri="{FF2B5EF4-FFF2-40B4-BE49-F238E27FC236}">
-                  <a16:creationId xmlns:a16="http://schemas.microsoft.com/office/drawing/2014/main" id="{322C1249-280A-5DE7-F7EA-B3E64E59EF4F}"/>
+                  <a16:creationId xmlns:a16="http://schemas.microsoft.com/office/drawing/2014/main" id="{BB34A38F-8F9E-D0D1-B78B-30221245B5CA}"/>
                 </a:ext>
               </a:extLst>
             </p:cNvPr>
@@ -13179,7 +13338,7 @@
             <p:cNvPr id="6" name="Rectangle: Rounded Corners 5">
               <a:extLst>
                 <a:ext uri="{FF2B5EF4-FFF2-40B4-BE49-F238E27FC236}">
-                  <a16:creationId xmlns:a16="http://schemas.microsoft.com/office/drawing/2014/main" id="{C3BF613F-0C55-B03E-6E0E-DA409705206C}"/>
+                  <a16:creationId xmlns:a16="http://schemas.microsoft.com/office/drawing/2014/main" id="{EF566987-9C71-EF6B-DF45-2B4ABA36C567}"/>
                 </a:ext>
               </a:extLst>
             </p:cNvPr>
@@ -13255,7 +13414,7 @@
             <p:cNvPr id="7" name="Oval 6">
               <a:extLst>
                 <a:ext uri="{FF2B5EF4-FFF2-40B4-BE49-F238E27FC236}">
-                  <a16:creationId xmlns:a16="http://schemas.microsoft.com/office/drawing/2014/main" id="{D8C2E8C8-EE9D-7388-9DD3-303D8D0CDE29}"/>
+                  <a16:creationId xmlns:a16="http://schemas.microsoft.com/office/drawing/2014/main" id="{1D98AC0E-DA25-CA38-82AB-703317FF48A3}"/>
                 </a:ext>
               </a:extLst>
             </p:cNvPr>
@@ -13323,7 +13482,7 @@
             <p:cNvPr id="9" name="Graphic 8">
               <a:extLst>
                 <a:ext uri="{FF2B5EF4-FFF2-40B4-BE49-F238E27FC236}">
-                  <a16:creationId xmlns:a16="http://schemas.microsoft.com/office/drawing/2014/main" id="{9D9E8724-E861-115C-852C-1B4AB8404C5D}"/>
+                  <a16:creationId xmlns:a16="http://schemas.microsoft.com/office/drawing/2014/main" id="{4B73B36D-E574-B271-80C6-D436E4351A2B}"/>
                 </a:ext>
               </a:extLst>
             </p:cNvPr>
@@ -13359,7 +13518,7 @@
             <p:cNvPr id="10" name="TextBox 9">
               <a:extLst>
                 <a:ext uri="{FF2B5EF4-FFF2-40B4-BE49-F238E27FC236}">
-                  <a16:creationId xmlns:a16="http://schemas.microsoft.com/office/drawing/2014/main" id="{6FB09E56-4208-9CE5-D921-C48784802F3E}"/>
+                  <a16:creationId xmlns:a16="http://schemas.microsoft.com/office/drawing/2014/main" id="{9033DF5F-9134-FA78-C999-347396642612}"/>
                 </a:ext>
               </a:extLst>
             </p:cNvPr>
@@ -13424,7 +13583,7 @@
           <p:cNvPr id="18" name="!!Stage_Sub_Card_1!!">
             <a:extLst>
               <a:ext uri="{FF2B5EF4-FFF2-40B4-BE49-F238E27FC236}">
-                <a16:creationId xmlns:a16="http://schemas.microsoft.com/office/drawing/2014/main" id="{6731564C-33BA-41CA-E150-0EEC6652103D}"/>
+                <a16:creationId xmlns:a16="http://schemas.microsoft.com/office/drawing/2014/main" id="{C55427BF-2A74-4B03-904E-759D36FB0B92}"/>
               </a:ext>
             </a:extLst>
           </p:cNvPr>
@@ -13444,7 +13603,7 @@
             <p:cNvPr id="12" name="Rectangle: Rounded Corners 11">
               <a:extLst>
                 <a:ext uri="{FF2B5EF4-FFF2-40B4-BE49-F238E27FC236}">
-                  <a16:creationId xmlns:a16="http://schemas.microsoft.com/office/drawing/2014/main" id="{46B3ADF7-9B9E-4457-EF4D-A13C220635A5}"/>
+                  <a16:creationId xmlns:a16="http://schemas.microsoft.com/office/drawing/2014/main" id="{CBF31EDE-4740-B5D6-302E-6C59EAED00FF}"/>
                 </a:ext>
               </a:extLst>
             </p:cNvPr>
@@ -13498,7 +13657,7 @@
             <p:cNvPr id="13" name="Rectangle: Rounded Corners 12">
               <a:extLst>
                 <a:ext uri="{FF2B5EF4-FFF2-40B4-BE49-F238E27FC236}">
-                  <a16:creationId xmlns:a16="http://schemas.microsoft.com/office/drawing/2014/main" id="{A671823C-94A7-AFCA-1459-1C49203F4F37}"/>
+                  <a16:creationId xmlns:a16="http://schemas.microsoft.com/office/drawing/2014/main" id="{157CCC2C-6AB7-6224-40CF-F2D6BF83ACA5}"/>
                 </a:ext>
               </a:extLst>
             </p:cNvPr>
@@ -13580,7 +13739,7 @@
             <p:cNvPr id="14" name="Oval 13">
               <a:extLst>
                 <a:ext uri="{FF2B5EF4-FFF2-40B4-BE49-F238E27FC236}">
-                  <a16:creationId xmlns:a16="http://schemas.microsoft.com/office/drawing/2014/main" id="{3ED604B7-C9EB-D7AA-453C-ED35382216F8}"/>
+                  <a16:creationId xmlns:a16="http://schemas.microsoft.com/office/drawing/2014/main" id="{020CBC57-B4D0-1550-11D5-2CB9D591F687}"/>
                 </a:ext>
               </a:extLst>
             </p:cNvPr>
@@ -13648,7 +13807,7 @@
             <p:cNvPr id="16" name="Graphic 15">
               <a:extLst>
                 <a:ext uri="{FF2B5EF4-FFF2-40B4-BE49-F238E27FC236}">
-                  <a16:creationId xmlns:a16="http://schemas.microsoft.com/office/drawing/2014/main" id="{0FE36ED2-A45F-9F46-4E02-9BE75609A99A}"/>
+                  <a16:creationId xmlns:a16="http://schemas.microsoft.com/office/drawing/2014/main" id="{39B59D33-A532-7EED-B61B-2184B118CFCB}"/>
                 </a:ext>
               </a:extLst>
             </p:cNvPr>
@@ -13684,7 +13843,7 @@
             <p:cNvPr id="17" name="TextBox 16">
               <a:extLst>
                 <a:ext uri="{FF2B5EF4-FFF2-40B4-BE49-F238E27FC236}">
-                  <a16:creationId xmlns:a16="http://schemas.microsoft.com/office/drawing/2014/main" id="{27B850B9-E0F8-21AB-51DE-87D48B47DB41}"/>
+                  <a16:creationId xmlns:a16="http://schemas.microsoft.com/office/drawing/2014/main" id="{C926A944-CD1E-BA38-3255-3792192B5715}"/>
                 </a:ext>
               </a:extLst>
             </p:cNvPr>
@@ -13749,7 +13908,7 @@
           <p:cNvPr id="19" name="!!Anchor_Source_Footer!!">
             <a:extLst>
               <a:ext uri="{FF2B5EF4-FFF2-40B4-BE49-F238E27FC236}">
-                <a16:creationId xmlns:a16="http://schemas.microsoft.com/office/drawing/2014/main" id="{41B27067-FEEB-04BC-2A2A-1D95B4AFFA02}"/>
+                <a16:creationId xmlns:a16="http://schemas.microsoft.com/office/drawing/2014/main" id="{945B00FD-549D-EDF6-754C-03B958895E9E}"/>
               </a:ext>
             </a:extLst>
           </p:cNvPr>
@@ -13787,7 +13946,7 @@
     </p:spTree>
     <p:extLst>
       <p:ext uri="{BB962C8B-B14F-4D97-AF65-F5344CB8AC3E}">
-        <p14:creationId xmlns:p14="http://schemas.microsoft.com/office/powerpoint/2010/main" val="2841330065"/>
+        <p14:creationId xmlns:p14="http://schemas.microsoft.com/office/powerpoint/2010/main" val="4146242950"/>
       </p:ext>
     </p:extLst>
   </p:cSld>
@@ -13818,9 +13977,6 @@
                     <p:cTn id="3" fill="hold">
                       <p:stCondLst>
                         <p:cond delay="indefinite"/>
-                        <p:cond evt="onBegin" delay="0">
-                          <p:tn val="2"/>
-                        </p:cond>
                       </p:stCondLst>
                       <p:childTnLst>
                         <p:par>
@@ -13830,9 +13986,9 @@
                             </p:stCondLst>
                             <p:childTnLst>
                               <p:par>
-                                <p:cTn id="5" presetID="2" presetClass="entr" presetSubtype="1" accel="50000" decel="50000" fill="hold" nodeType="withEffect">
+                                <p:cTn id="5" presetID="2" presetClass="entr" presetSubtype="1" accel="50000" decel="50000" fill="hold" nodeType="clickEffect">
                                   <p:stCondLst>
-                                    <p:cond delay="180"/>
+                                    <p:cond delay="0"/>
                                   </p:stCondLst>
                                   <p:childTnLst>
                                     <p:set>
@@ -13963,7 +14119,7 @@
           <p:cNvPr id="2" name="!!Anchor_Kicker_Rail!!">
             <a:extLst>
               <a:ext uri="{FF2B5EF4-FFF2-40B4-BE49-F238E27FC236}">
-                <a16:creationId xmlns:a16="http://schemas.microsoft.com/office/drawing/2014/main" id="{A3A0AEAB-6CC0-D2AA-26D9-591E4E2B7225}"/>
+                <a16:creationId xmlns:a16="http://schemas.microsoft.com/office/drawing/2014/main" id="{DDCD4A05-6F6F-AEF0-A0BC-8BD541DDAF43}"/>
               </a:ext>
             </a:extLst>
           </p:cNvPr>
@@ -14003,7 +14159,7 @@
           <p:cNvPr id="3" name="!!Anchor_Slide_Tracker!!">
             <a:extLst>
               <a:ext uri="{FF2B5EF4-FFF2-40B4-BE49-F238E27FC236}">
-                <a16:creationId xmlns:a16="http://schemas.microsoft.com/office/drawing/2014/main" id="{853AF669-0375-AB9F-865F-37AB76C02B44}"/>
+                <a16:creationId xmlns:a16="http://schemas.microsoft.com/office/drawing/2014/main" id="{9C47655B-4A6F-1A9B-87D2-7325D864BD16}"/>
               </a:ext>
             </a:extLst>
           </p:cNvPr>
@@ -14044,7 +14200,7 @@
           <p:cNvPr id="4" name="!!Anchor_Assertion_Title!!">
             <a:extLst>
               <a:ext uri="{FF2B5EF4-FFF2-40B4-BE49-F238E27FC236}">
-                <a16:creationId xmlns:a16="http://schemas.microsoft.com/office/drawing/2014/main" id="{CD8053A8-F82F-6C5A-A973-961C2EF5AF70}"/>
+                <a16:creationId xmlns:a16="http://schemas.microsoft.com/office/drawing/2014/main" id="{C7DF9009-63E6-235F-099F-466F80FC5B0D}"/>
               </a:ext>
             </a:extLst>
           </p:cNvPr>
@@ -14084,7 +14240,7 @@
           <p:cNvPr id="11" name="!!Stage_Hero_Container!!">
             <a:extLst>
               <a:ext uri="{FF2B5EF4-FFF2-40B4-BE49-F238E27FC236}">
-                <a16:creationId xmlns:a16="http://schemas.microsoft.com/office/drawing/2014/main" id="{831B9F7D-1BE7-0F36-6AE6-41F137B35E84}"/>
+                <a16:creationId xmlns:a16="http://schemas.microsoft.com/office/drawing/2014/main" id="{52195D35-CEB3-31FF-D0CA-98AD58AB4C49}"/>
               </a:ext>
             </a:extLst>
           </p:cNvPr>
@@ -14104,7 +14260,7 @@
             <p:cNvPr id="5" name="Rectangle: Rounded Corners 4">
               <a:extLst>
                 <a:ext uri="{FF2B5EF4-FFF2-40B4-BE49-F238E27FC236}">
-                  <a16:creationId xmlns:a16="http://schemas.microsoft.com/office/drawing/2014/main" id="{7BE5E768-31AB-396A-7B66-9BE7E312EA28}"/>
+                  <a16:creationId xmlns:a16="http://schemas.microsoft.com/office/drawing/2014/main" id="{8EA22488-64D1-DC7A-47B0-120DA31FEF0D}"/>
                 </a:ext>
               </a:extLst>
             </p:cNvPr>
@@ -14158,7 +14314,7 @@
             <p:cNvPr id="6" name="Rectangle: Rounded Corners 5">
               <a:extLst>
                 <a:ext uri="{FF2B5EF4-FFF2-40B4-BE49-F238E27FC236}">
-                  <a16:creationId xmlns:a16="http://schemas.microsoft.com/office/drawing/2014/main" id="{C61BECAF-C8FE-E38B-D215-BE394253E200}"/>
+                  <a16:creationId xmlns:a16="http://schemas.microsoft.com/office/drawing/2014/main" id="{3B056316-5A6F-677C-E694-5DF4063F46D7}"/>
                 </a:ext>
               </a:extLst>
             </p:cNvPr>
@@ -14234,7 +14390,7 @@
             <p:cNvPr id="7" name="Oval 6">
               <a:extLst>
                 <a:ext uri="{FF2B5EF4-FFF2-40B4-BE49-F238E27FC236}">
-                  <a16:creationId xmlns:a16="http://schemas.microsoft.com/office/drawing/2014/main" id="{B00C766F-947F-4EAD-086B-AC3C36BB25E5}"/>
+                  <a16:creationId xmlns:a16="http://schemas.microsoft.com/office/drawing/2014/main" id="{7DAAC35E-BDB8-5C40-6791-F255D5E274C4}"/>
                 </a:ext>
               </a:extLst>
             </p:cNvPr>
@@ -14302,7 +14458,7 @@
             <p:cNvPr id="9" name="Graphic 8">
               <a:extLst>
                 <a:ext uri="{FF2B5EF4-FFF2-40B4-BE49-F238E27FC236}">
-                  <a16:creationId xmlns:a16="http://schemas.microsoft.com/office/drawing/2014/main" id="{D485D935-F21F-27CD-D215-6B20105D6BBD}"/>
+                  <a16:creationId xmlns:a16="http://schemas.microsoft.com/office/drawing/2014/main" id="{6DB1B99A-C40C-13A4-C33A-0185BE29549A}"/>
                 </a:ext>
               </a:extLst>
             </p:cNvPr>
@@ -14338,7 +14494,7 @@
             <p:cNvPr id="10" name="TextBox 9">
               <a:extLst>
                 <a:ext uri="{FF2B5EF4-FFF2-40B4-BE49-F238E27FC236}">
-                  <a16:creationId xmlns:a16="http://schemas.microsoft.com/office/drawing/2014/main" id="{265B0E76-EF00-5705-D949-DB0D36E2B56A}"/>
+                  <a16:creationId xmlns:a16="http://schemas.microsoft.com/office/drawing/2014/main" id="{A747A8A1-A088-ECD4-52A9-76F49190BBBE}"/>
                 </a:ext>
               </a:extLst>
             </p:cNvPr>
@@ -14403,7 +14559,7 @@
           <p:cNvPr id="18" name="!!Stage_Sub_Card_1!!">
             <a:extLst>
               <a:ext uri="{FF2B5EF4-FFF2-40B4-BE49-F238E27FC236}">
-                <a16:creationId xmlns:a16="http://schemas.microsoft.com/office/drawing/2014/main" id="{D75FA351-B815-FC87-023A-8FB3C7400098}"/>
+                <a16:creationId xmlns:a16="http://schemas.microsoft.com/office/drawing/2014/main" id="{A314A3B2-E66F-E871-4D4B-66172A9EB4E0}"/>
               </a:ext>
             </a:extLst>
           </p:cNvPr>
@@ -14423,7 +14579,7 @@
             <p:cNvPr id="12" name="Rectangle: Rounded Corners 11">
               <a:extLst>
                 <a:ext uri="{FF2B5EF4-FFF2-40B4-BE49-F238E27FC236}">
-                  <a16:creationId xmlns:a16="http://schemas.microsoft.com/office/drawing/2014/main" id="{52D12E1D-2C8F-F4EB-E938-247306A2D49C}"/>
+                  <a16:creationId xmlns:a16="http://schemas.microsoft.com/office/drawing/2014/main" id="{B0206219-07D9-4C30-8D95-D3B681B91B61}"/>
                 </a:ext>
               </a:extLst>
             </p:cNvPr>
@@ -14477,7 +14633,7 @@
             <p:cNvPr id="13" name="Rectangle: Rounded Corners 12">
               <a:extLst>
                 <a:ext uri="{FF2B5EF4-FFF2-40B4-BE49-F238E27FC236}">
-                  <a16:creationId xmlns:a16="http://schemas.microsoft.com/office/drawing/2014/main" id="{2A52B22D-8310-8E93-D225-F5284CE1EEF4}"/>
+                  <a16:creationId xmlns:a16="http://schemas.microsoft.com/office/drawing/2014/main" id="{F2BCA3C9-AAC0-55CD-8C46-7A48967AFB80}"/>
                 </a:ext>
               </a:extLst>
             </p:cNvPr>
@@ -14559,7 +14715,7 @@
             <p:cNvPr id="14" name="Oval 13">
               <a:extLst>
                 <a:ext uri="{FF2B5EF4-FFF2-40B4-BE49-F238E27FC236}">
-                  <a16:creationId xmlns:a16="http://schemas.microsoft.com/office/drawing/2014/main" id="{7CA69F7E-1949-B72B-9E86-2634B108D079}"/>
+                  <a16:creationId xmlns:a16="http://schemas.microsoft.com/office/drawing/2014/main" id="{8D07AF44-6994-A225-6210-F8E2A3A9440E}"/>
                 </a:ext>
               </a:extLst>
             </p:cNvPr>
@@ -14627,7 +14783,7 @@
             <p:cNvPr id="16" name="Graphic 15">
               <a:extLst>
                 <a:ext uri="{FF2B5EF4-FFF2-40B4-BE49-F238E27FC236}">
-                  <a16:creationId xmlns:a16="http://schemas.microsoft.com/office/drawing/2014/main" id="{C696A70F-CCC1-0D0F-6EF3-FB499E8829CA}"/>
+                  <a16:creationId xmlns:a16="http://schemas.microsoft.com/office/drawing/2014/main" id="{11D7C4BA-E4A3-875C-E586-7EE2D8A4138C}"/>
                 </a:ext>
               </a:extLst>
             </p:cNvPr>
@@ -14663,7 +14819,7 @@
             <p:cNvPr id="17" name="TextBox 16">
               <a:extLst>
                 <a:ext uri="{FF2B5EF4-FFF2-40B4-BE49-F238E27FC236}">
-                  <a16:creationId xmlns:a16="http://schemas.microsoft.com/office/drawing/2014/main" id="{62F5E067-DB2B-BEE7-67C8-1305E89BF7B1}"/>
+                  <a16:creationId xmlns:a16="http://schemas.microsoft.com/office/drawing/2014/main" id="{EFCE2E24-1E50-C4CC-8269-FDC07A4F158A}"/>
                 </a:ext>
               </a:extLst>
             </p:cNvPr>
@@ -14728,7 +14884,7 @@
           <p:cNvPr id="19" name="!!Anchor_Source_Footer!!">
             <a:extLst>
               <a:ext uri="{FF2B5EF4-FFF2-40B4-BE49-F238E27FC236}">
-                <a16:creationId xmlns:a16="http://schemas.microsoft.com/office/drawing/2014/main" id="{6F070FBA-6AC3-6419-C418-797FDF9C8255}"/>
+                <a16:creationId xmlns:a16="http://schemas.microsoft.com/office/drawing/2014/main" id="{E8CBCE4B-7C06-2BFE-45D5-518CD4E0AE05}"/>
               </a:ext>
             </a:extLst>
           </p:cNvPr>
@@ -14772,7 +14928,7 @@
     </p:spTree>
     <p:extLst>
       <p:ext uri="{BB962C8B-B14F-4D97-AF65-F5344CB8AC3E}">
-        <p14:creationId xmlns:p14="http://schemas.microsoft.com/office/powerpoint/2010/main" val="385985756"/>
+        <p14:creationId xmlns:p14="http://schemas.microsoft.com/office/powerpoint/2010/main" val="2359633719"/>
       </p:ext>
     </p:extLst>
   </p:cSld>
@@ -14803,9 +14959,6 @@
                     <p:cTn id="3" fill="hold">
                       <p:stCondLst>
                         <p:cond delay="indefinite"/>
-                        <p:cond evt="onBegin" delay="0">
-                          <p:tn val="2"/>
-                        </p:cond>
                       </p:stCondLst>
                       <p:childTnLst>
                         <p:par>
@@ -14815,9 +14968,9 @@
                             </p:stCondLst>
                             <p:childTnLst>
                               <p:par>
-                                <p:cTn id="5" presetID="2" presetClass="entr" presetSubtype="1" accel="50000" decel="50000" fill="hold" nodeType="withEffect">
+                                <p:cTn id="5" presetID="2" presetClass="entr" presetSubtype="1" accel="50000" decel="50000" fill="hold" nodeType="clickEffect">
                                   <p:stCondLst>
-                                    <p:cond delay="180"/>
+                                    <p:cond delay="0"/>
                                   </p:stCondLst>
                                   <p:childTnLst>
                                     <p:set>
@@ -14948,7 +15101,7 @@
           <p:cNvPr id="2" name="!!Anchor_Kicker_Rail!!">
             <a:extLst>
               <a:ext uri="{FF2B5EF4-FFF2-40B4-BE49-F238E27FC236}">
-                <a16:creationId xmlns:a16="http://schemas.microsoft.com/office/drawing/2014/main" id="{5CF8B498-54C8-2BDA-2B53-FEF6E576E2D8}"/>
+                <a16:creationId xmlns:a16="http://schemas.microsoft.com/office/drawing/2014/main" id="{FBF12605-6349-F645-4521-0A3202FBFEB3}"/>
               </a:ext>
             </a:extLst>
           </p:cNvPr>
@@ -14988,7 +15141,7 @@
           <p:cNvPr id="3" name="!!Anchor_Slide_Tracker!!">
             <a:extLst>
               <a:ext uri="{FF2B5EF4-FFF2-40B4-BE49-F238E27FC236}">
-                <a16:creationId xmlns:a16="http://schemas.microsoft.com/office/drawing/2014/main" id="{44FD186F-9044-663C-2679-CAA9E311C6C9}"/>
+                <a16:creationId xmlns:a16="http://schemas.microsoft.com/office/drawing/2014/main" id="{55FD5796-8948-4663-4EB0-A48DE63D8F6A}"/>
               </a:ext>
             </a:extLst>
           </p:cNvPr>
@@ -15029,7 +15182,7 @@
           <p:cNvPr id="4" name="!!Anchor_Assertion_Title!!">
             <a:extLst>
               <a:ext uri="{FF2B5EF4-FFF2-40B4-BE49-F238E27FC236}">
-                <a16:creationId xmlns:a16="http://schemas.microsoft.com/office/drawing/2014/main" id="{5D8732C3-D94C-8014-ECB6-E1475E090930}"/>
+                <a16:creationId xmlns:a16="http://schemas.microsoft.com/office/drawing/2014/main" id="{3B3B2E49-BD4E-5BB0-018B-E4FC96770BA6}"/>
               </a:ext>
             </a:extLst>
           </p:cNvPr>
@@ -15075,7 +15228,7 @@
           <p:cNvPr id="6" name="!!Stage_Hero_Container!!">
             <a:extLst>
               <a:ext uri="{FF2B5EF4-FFF2-40B4-BE49-F238E27FC236}">
-                <a16:creationId xmlns:a16="http://schemas.microsoft.com/office/drawing/2014/main" id="{E2B075E5-04B7-75B8-9F61-547DD1F89087}"/>
+                <a16:creationId xmlns:a16="http://schemas.microsoft.com/office/drawing/2014/main" id="{D6305A17-6347-0B90-DB91-6279E7D2CDE7}"/>
               </a:ext>
             </a:extLst>
           </p:cNvPr>
@@ -15116,7 +15269,7 @@
           <p:cNvPr id="12" name="!!Stage_Sub_Card_1!!">
             <a:extLst>
               <a:ext uri="{FF2B5EF4-FFF2-40B4-BE49-F238E27FC236}">
-                <a16:creationId xmlns:a16="http://schemas.microsoft.com/office/drawing/2014/main" id="{DE508965-D18E-7CE3-A92A-788B9008E2BF}"/>
+                <a16:creationId xmlns:a16="http://schemas.microsoft.com/office/drawing/2014/main" id="{B0087FEA-AD11-1875-E02D-ED668F8C3484}"/>
               </a:ext>
             </a:extLst>
           </p:cNvPr>
@@ -15136,7 +15289,7 @@
             <p:cNvPr id="7" name="Rectangle: Rounded Corners 6">
               <a:extLst>
                 <a:ext uri="{FF2B5EF4-FFF2-40B4-BE49-F238E27FC236}">
-                  <a16:creationId xmlns:a16="http://schemas.microsoft.com/office/drawing/2014/main" id="{9A60EB84-498A-8E8A-A6A8-F010090A54B5}"/>
+                  <a16:creationId xmlns:a16="http://schemas.microsoft.com/office/drawing/2014/main" id="{6B6C1F20-9C11-2890-ECD4-3601E488E846}"/>
                 </a:ext>
               </a:extLst>
             </p:cNvPr>
@@ -15190,7 +15343,7 @@
             <p:cNvPr id="8" name="Oval 7">
               <a:extLst>
                 <a:ext uri="{FF2B5EF4-FFF2-40B4-BE49-F238E27FC236}">
-                  <a16:creationId xmlns:a16="http://schemas.microsoft.com/office/drawing/2014/main" id="{2942CA70-C0CA-CDC4-67DB-3314061425F7}"/>
+                  <a16:creationId xmlns:a16="http://schemas.microsoft.com/office/drawing/2014/main" id="{E7EE3055-6212-9575-EC42-E0F29F6788B9}"/>
                 </a:ext>
               </a:extLst>
             </p:cNvPr>
@@ -15258,7 +15411,7 @@
             <p:cNvPr id="10" name="Graphic 9">
               <a:extLst>
                 <a:ext uri="{FF2B5EF4-FFF2-40B4-BE49-F238E27FC236}">
-                  <a16:creationId xmlns:a16="http://schemas.microsoft.com/office/drawing/2014/main" id="{6DD32692-EE71-25FF-404E-C32E306CC238}"/>
+                  <a16:creationId xmlns:a16="http://schemas.microsoft.com/office/drawing/2014/main" id="{1ED6F665-3909-9A40-9464-FD21FC81DE39}"/>
                 </a:ext>
               </a:extLst>
             </p:cNvPr>
@@ -15294,7 +15447,7 @@
             <p:cNvPr id="11" name="TextBox 10">
               <a:extLst>
                 <a:ext uri="{FF2B5EF4-FFF2-40B4-BE49-F238E27FC236}">
-                  <a16:creationId xmlns:a16="http://schemas.microsoft.com/office/drawing/2014/main" id="{A0AA200F-41E8-D076-2F00-13B7FDBFDF12}"/>
+                  <a16:creationId xmlns:a16="http://schemas.microsoft.com/office/drawing/2014/main" id="{9F7DDDB5-CF23-5172-DB88-574A31C90682}"/>
                 </a:ext>
               </a:extLst>
             </p:cNvPr>
@@ -15356,7 +15509,7 @@
           <p:cNvPr id="18" name="!!Stage_Sub_Card_2!!">
             <a:extLst>
               <a:ext uri="{FF2B5EF4-FFF2-40B4-BE49-F238E27FC236}">
-                <a16:creationId xmlns:a16="http://schemas.microsoft.com/office/drawing/2014/main" id="{06378729-2A43-CB7A-F982-EB16A2099473}"/>
+                <a16:creationId xmlns:a16="http://schemas.microsoft.com/office/drawing/2014/main" id="{93A0FD02-C243-0669-2285-13E25BDE183E}"/>
               </a:ext>
             </a:extLst>
           </p:cNvPr>
@@ -15376,7 +15529,7 @@
             <p:cNvPr id="13" name="Rectangle: Rounded Corners 12">
               <a:extLst>
                 <a:ext uri="{FF2B5EF4-FFF2-40B4-BE49-F238E27FC236}">
-                  <a16:creationId xmlns:a16="http://schemas.microsoft.com/office/drawing/2014/main" id="{33EB8ECC-A194-4126-D929-9969B701396C}"/>
+                  <a16:creationId xmlns:a16="http://schemas.microsoft.com/office/drawing/2014/main" id="{63AA5600-A60D-FDEF-1A83-53E01C992823}"/>
                 </a:ext>
               </a:extLst>
             </p:cNvPr>
@@ -15430,7 +15583,7 @@
             <p:cNvPr id="14" name="Oval 13">
               <a:extLst>
                 <a:ext uri="{FF2B5EF4-FFF2-40B4-BE49-F238E27FC236}">
-                  <a16:creationId xmlns:a16="http://schemas.microsoft.com/office/drawing/2014/main" id="{B4C11862-02FA-31C5-BFF4-1A26E6741105}"/>
+                  <a16:creationId xmlns:a16="http://schemas.microsoft.com/office/drawing/2014/main" id="{D57356B9-BBBB-CF40-8B25-4DA83EF29B1F}"/>
                 </a:ext>
               </a:extLst>
             </p:cNvPr>
@@ -15498,7 +15651,7 @@
             <p:cNvPr id="16" name="Graphic 15">
               <a:extLst>
                 <a:ext uri="{FF2B5EF4-FFF2-40B4-BE49-F238E27FC236}">
-                  <a16:creationId xmlns:a16="http://schemas.microsoft.com/office/drawing/2014/main" id="{8DC117E4-D56C-3985-0B0E-558A49E57FE8}"/>
+                  <a16:creationId xmlns:a16="http://schemas.microsoft.com/office/drawing/2014/main" id="{4703E2D9-D5FD-4577-E359-54C0ACDBC78B}"/>
                 </a:ext>
               </a:extLst>
             </p:cNvPr>
@@ -15534,7 +15687,7 @@
             <p:cNvPr id="17" name="TextBox 16">
               <a:extLst>
                 <a:ext uri="{FF2B5EF4-FFF2-40B4-BE49-F238E27FC236}">
-                  <a16:creationId xmlns:a16="http://schemas.microsoft.com/office/drawing/2014/main" id="{A63A3F43-0EC5-FCBD-7CCA-62FCA1CED8B9}"/>
+                  <a16:creationId xmlns:a16="http://schemas.microsoft.com/office/drawing/2014/main" id="{D61FE39D-01F9-4B8C-79C2-830D798853BC}"/>
                 </a:ext>
               </a:extLst>
             </p:cNvPr>
@@ -15596,7 +15749,7 @@
           <p:cNvPr id="24" name="!!Stage_Sub_Card_3!!">
             <a:extLst>
               <a:ext uri="{FF2B5EF4-FFF2-40B4-BE49-F238E27FC236}">
-                <a16:creationId xmlns:a16="http://schemas.microsoft.com/office/drawing/2014/main" id="{C0F2555B-7B8A-037F-B3E2-D0FBAD996994}"/>
+                <a16:creationId xmlns:a16="http://schemas.microsoft.com/office/drawing/2014/main" id="{E7E7F833-777F-D410-ADFC-8F86241F38E9}"/>
               </a:ext>
             </a:extLst>
           </p:cNvPr>
@@ -15616,7 +15769,7 @@
             <p:cNvPr id="19" name="Rectangle: Rounded Corners 18">
               <a:extLst>
                 <a:ext uri="{FF2B5EF4-FFF2-40B4-BE49-F238E27FC236}">
-                  <a16:creationId xmlns:a16="http://schemas.microsoft.com/office/drawing/2014/main" id="{E4322AAD-0640-EA59-63C0-8F95BD38F38A}"/>
+                  <a16:creationId xmlns:a16="http://schemas.microsoft.com/office/drawing/2014/main" id="{F3B14E63-D9D7-A8C0-D79D-887EFB29CF55}"/>
                 </a:ext>
               </a:extLst>
             </p:cNvPr>
@@ -15670,7 +15823,7 @@
             <p:cNvPr id="20" name="Oval 19">
               <a:extLst>
                 <a:ext uri="{FF2B5EF4-FFF2-40B4-BE49-F238E27FC236}">
-                  <a16:creationId xmlns:a16="http://schemas.microsoft.com/office/drawing/2014/main" id="{8CACFC5C-9ECC-17FD-D085-7286094EE1E3}"/>
+                  <a16:creationId xmlns:a16="http://schemas.microsoft.com/office/drawing/2014/main" id="{C3DCF365-CEED-5D7A-FE1A-26A47D1D911F}"/>
                 </a:ext>
               </a:extLst>
             </p:cNvPr>
@@ -15738,7 +15891,7 @@
             <p:cNvPr id="22" name="Graphic 21">
               <a:extLst>
                 <a:ext uri="{FF2B5EF4-FFF2-40B4-BE49-F238E27FC236}">
-                  <a16:creationId xmlns:a16="http://schemas.microsoft.com/office/drawing/2014/main" id="{5899F48A-7B12-D0E5-C280-2D122FE280C5}"/>
+                  <a16:creationId xmlns:a16="http://schemas.microsoft.com/office/drawing/2014/main" id="{548AFBAE-B315-D85A-CAA7-9AA437651F06}"/>
                 </a:ext>
               </a:extLst>
             </p:cNvPr>
@@ -15774,7 +15927,7 @@
             <p:cNvPr id="23" name="TextBox 22">
               <a:extLst>
                 <a:ext uri="{FF2B5EF4-FFF2-40B4-BE49-F238E27FC236}">
-                  <a16:creationId xmlns:a16="http://schemas.microsoft.com/office/drawing/2014/main" id="{B8D3DB90-543D-100B-71F5-C3E23F229977}"/>
+                  <a16:creationId xmlns:a16="http://schemas.microsoft.com/office/drawing/2014/main" id="{A3FEB84C-D884-490C-FB28-DE62968D7DFE}"/>
                 </a:ext>
               </a:extLst>
             </p:cNvPr>
@@ -15836,7 +15989,7 @@
           <p:cNvPr id="25" name="!!Anchor_Source_Footer!!">
             <a:extLst>
               <a:ext uri="{FF2B5EF4-FFF2-40B4-BE49-F238E27FC236}">
-                <a16:creationId xmlns:a16="http://schemas.microsoft.com/office/drawing/2014/main" id="{1C2270CB-A0C7-BB3C-5A79-3F9C515FCCC8}"/>
+                <a16:creationId xmlns:a16="http://schemas.microsoft.com/office/drawing/2014/main" id="{55622B35-B56C-9F1C-2ABC-79B272FCE3CD}"/>
               </a:ext>
             </a:extLst>
           </p:cNvPr>
@@ -15874,7 +16027,7 @@
     </p:spTree>
     <p:extLst>
       <p:ext uri="{BB962C8B-B14F-4D97-AF65-F5344CB8AC3E}">
-        <p14:creationId xmlns:p14="http://schemas.microsoft.com/office/powerpoint/2010/main" val="3443815486"/>
+        <p14:creationId xmlns:p14="http://schemas.microsoft.com/office/powerpoint/2010/main" val="3164050301"/>
       </p:ext>
     </p:extLst>
   </p:cSld>
@@ -15905,9 +16058,6 @@
                     <p:cTn id="3" fill="hold">
                       <p:stCondLst>
                         <p:cond delay="indefinite"/>
-                        <p:cond evt="onBegin" delay="0">
-                          <p:tn val="2"/>
-                        </p:cond>
                       </p:stCondLst>
                       <p:childTnLst>
                         <p:par>
@@ -15917,9 +16067,9 @@
                             </p:stCondLst>
                             <p:childTnLst>
                               <p:par>
-                                <p:cTn id="5" presetID="2" presetClass="entr" presetSubtype="1" accel="50000" decel="50000" fill="hold" nodeType="withEffect">
+                                <p:cTn id="5" presetID="2" presetClass="entr" presetSubtype="1" accel="50000" decel="50000" fill="hold" nodeType="clickEffect">
                                   <p:stCondLst>
-                                    <p:cond delay="120"/>
+                                    <p:cond delay="0"/>
                                   </p:stCondLst>
                                   <p:childTnLst>
                                     <p:set>
@@ -15989,15 +16139,33 @@
                                   </p:childTnLst>
                                 </p:cTn>
                               </p:par>
+                            </p:childTnLst>
+                          </p:cTn>
+                        </p:par>
+                      </p:childTnLst>
+                    </p:cTn>
+                  </p:par>
+                  <p:par>
+                    <p:cTn id="9" fill="hold">
+                      <p:stCondLst>
+                        <p:cond delay="indefinite"/>
+                      </p:stCondLst>
+                      <p:childTnLst>
+                        <p:par>
+                          <p:cTn id="10" fill="hold">
+                            <p:stCondLst>
+                              <p:cond delay="0"/>
+                            </p:stCondLst>
+                            <p:childTnLst>
                               <p:par>
-                                <p:cTn id="9" presetID="2" presetClass="entr" presetSubtype="1" accel="50000" decel="50000" fill="hold" nodeType="withEffect">
+                                <p:cTn id="11" presetID="2" presetClass="entr" presetSubtype="1" accel="50000" decel="50000" fill="hold" nodeType="clickEffect">
                                   <p:stCondLst>
-                                    <p:cond delay="240"/>
+                                    <p:cond delay="0"/>
                                   </p:stCondLst>
                                   <p:childTnLst>
                                     <p:set>
                                       <p:cBhvr>
-                                        <p:cTn id="10" dur="1" fill="hold">
+                                        <p:cTn id="12" dur="1" fill="hold">
                                           <p:stCondLst>
                                             <p:cond delay="0"/>
                                           </p:stCondLst>
@@ -16015,7 +16183,7 @@
                                     </p:set>
                                     <p:anim calcmode="lin" valueType="num">
                                       <p:cBhvr additive="base">
-                                        <p:cTn id="11" dur="500" fill="hold"/>
+                                        <p:cTn id="13" dur="500" fill="hold"/>
                                         <p:tgtEl>
                                           <p:spTgt spid="18"/>
                                         </p:tgtEl>
@@ -16038,7 +16206,7 @@
                                     </p:anim>
                                     <p:anim calcmode="lin" valueType="num">
                                       <p:cBhvr additive="base">
-                                        <p:cTn id="12" dur="500" fill="hold"/>
+                                        <p:cTn id="14" dur="500" fill="hold"/>
                                         <p:tgtEl>
                                           <p:spTgt spid="18"/>
                                         </p:tgtEl>
@@ -16062,15 +16230,33 @@
                                   </p:childTnLst>
                                 </p:cTn>
                               </p:par>
+                            </p:childTnLst>
+                          </p:cTn>
+                        </p:par>
+                      </p:childTnLst>
+                    </p:cTn>
+                  </p:par>
+                  <p:par>
+                    <p:cTn id="15" fill="hold">
+                      <p:stCondLst>
+                        <p:cond delay="indefinite"/>
+                      </p:stCondLst>
+                      <p:childTnLst>
+                        <p:par>
+                          <p:cTn id="16" fill="hold">
+                            <p:stCondLst>
+                              <p:cond delay="0"/>
+                            </p:stCondLst>
+                            <p:childTnLst>
                               <p:par>
-                                <p:cTn id="13" presetID="2" presetClass="entr" presetSubtype="1" accel="50000" decel="50000" fill="hold" nodeType="withEffect">
+                                <p:cTn id="17" presetID="2" presetClass="entr" presetSubtype="1" accel="50000" decel="50000" fill="hold" nodeType="clickEffect">
                                   <p:stCondLst>
-                                    <p:cond delay="360"/>
+                                    <p:cond delay="0"/>
                                   </p:stCondLst>
                                   <p:childTnLst>
                                     <p:set>
                                       <p:cBhvr>
-                                        <p:cTn id="14" dur="1" fill="hold">
+                                        <p:cTn id="18" dur="1" fill="hold">
                                           <p:stCondLst>
                                             <p:cond delay="0"/>
                                           </p:stCondLst>
@@ -16088,7 +16274,7 @@
                                     </p:set>
                                     <p:anim calcmode="lin" valueType="num">
                                       <p:cBhvr additive="base">
-                                        <p:cTn id="15" dur="500" fill="hold"/>
+                                        <p:cTn id="19" dur="500" fill="hold"/>
                                         <p:tgtEl>
                                           <p:spTgt spid="24"/>
                                         </p:tgtEl>
@@ -16111,7 +16297,7 @@
                                     </p:anim>
                                     <p:anim calcmode="lin" valueType="num">
                                       <p:cBhvr additive="base">
-                                        <p:cTn id="16" dur="500" fill="hold"/>
+                                        <p:cTn id="20" dur="500" fill="hold"/>
                                         <p:tgtEl>
                                           <p:spTgt spid="24"/>
                                         </p:tgtEl>
@@ -16196,7 +16382,7 @@
           <p:cNvPr id="2" name="!!Anchor_Kicker_Rail!!">
             <a:extLst>
               <a:ext uri="{FF2B5EF4-FFF2-40B4-BE49-F238E27FC236}">
-                <a16:creationId xmlns:a16="http://schemas.microsoft.com/office/drawing/2014/main" id="{04E60277-74EE-87CA-0B26-C56287AB3668}"/>
+                <a16:creationId xmlns:a16="http://schemas.microsoft.com/office/drawing/2014/main" id="{5BA8BCE0-43EF-AF31-E481-A7F899F85A74}"/>
               </a:ext>
             </a:extLst>
           </p:cNvPr>
@@ -16236,7 +16422,7 @@
           <p:cNvPr id="3" name="!!Anchor_Slide_Tracker!!">
             <a:extLst>
               <a:ext uri="{FF2B5EF4-FFF2-40B4-BE49-F238E27FC236}">
-                <a16:creationId xmlns:a16="http://schemas.microsoft.com/office/drawing/2014/main" id="{2A6EFE28-6F76-4CE5-C775-3636ACF3BBAF}"/>
+                <a16:creationId xmlns:a16="http://schemas.microsoft.com/office/drawing/2014/main" id="{B77E8EFD-FD4F-14EC-6644-38B01A97C362}"/>
               </a:ext>
             </a:extLst>
           </p:cNvPr>
@@ -16277,7 +16463,7 @@
           <p:cNvPr id="4" name="!!Anchor_Assertion_Title!!">
             <a:extLst>
               <a:ext uri="{FF2B5EF4-FFF2-40B4-BE49-F238E27FC236}">
-                <a16:creationId xmlns:a16="http://schemas.microsoft.com/office/drawing/2014/main" id="{BFA450C8-1B32-3BFB-312F-7BCF851D5972}"/>
+                <a16:creationId xmlns:a16="http://schemas.microsoft.com/office/drawing/2014/main" id="{97248DB1-BD25-EDF8-DD22-0A1F0C0B36CC}"/>
               </a:ext>
             </a:extLst>
           </p:cNvPr>
@@ -16317,7 +16503,7 @@
           <p:cNvPr id="11" name="!!Stage_Hero_Container!!">
             <a:extLst>
               <a:ext uri="{FF2B5EF4-FFF2-40B4-BE49-F238E27FC236}">
-                <a16:creationId xmlns:a16="http://schemas.microsoft.com/office/drawing/2014/main" id="{9B57AACC-EA46-BB61-583F-E4781AB79524}"/>
+                <a16:creationId xmlns:a16="http://schemas.microsoft.com/office/drawing/2014/main" id="{E8D5E44D-1C96-93EE-FA6B-69DF5F4A86C0}"/>
               </a:ext>
             </a:extLst>
           </p:cNvPr>
@@ -16337,7 +16523,7 @@
             <p:cNvPr id="5" name="Rectangle: Rounded Corners 4">
               <a:extLst>
                 <a:ext uri="{FF2B5EF4-FFF2-40B4-BE49-F238E27FC236}">
-                  <a16:creationId xmlns:a16="http://schemas.microsoft.com/office/drawing/2014/main" id="{86C664EB-FD45-F11D-5346-598025582F2D}"/>
+                  <a16:creationId xmlns:a16="http://schemas.microsoft.com/office/drawing/2014/main" id="{E089A3A1-BD31-35CE-31FC-4E558685AE7B}"/>
                 </a:ext>
               </a:extLst>
             </p:cNvPr>
@@ -16391,7 +16577,7 @@
             <p:cNvPr id="6" name="Rectangle: Rounded Corners 5">
               <a:extLst>
                 <a:ext uri="{FF2B5EF4-FFF2-40B4-BE49-F238E27FC236}">
-                  <a16:creationId xmlns:a16="http://schemas.microsoft.com/office/drawing/2014/main" id="{069C4300-3457-0D70-681B-C1B506573C41}"/>
+                  <a16:creationId xmlns:a16="http://schemas.microsoft.com/office/drawing/2014/main" id="{C3394C32-3B8C-2599-13B2-7B8B09E33112}"/>
                 </a:ext>
               </a:extLst>
             </p:cNvPr>
@@ -16467,7 +16653,7 @@
             <p:cNvPr id="7" name="Oval 6">
               <a:extLst>
                 <a:ext uri="{FF2B5EF4-FFF2-40B4-BE49-F238E27FC236}">
-                  <a16:creationId xmlns:a16="http://schemas.microsoft.com/office/drawing/2014/main" id="{6C3D5E60-1034-EA3E-4C97-56A23172EEBA}"/>
+                  <a16:creationId xmlns:a16="http://schemas.microsoft.com/office/drawing/2014/main" id="{91CC1AC3-DBD8-DA31-5243-B89E338EC716}"/>
                 </a:ext>
               </a:extLst>
             </p:cNvPr>
@@ -16535,7 +16721,7 @@
             <p:cNvPr id="9" name="Graphic 8">
               <a:extLst>
                 <a:ext uri="{FF2B5EF4-FFF2-40B4-BE49-F238E27FC236}">
-                  <a16:creationId xmlns:a16="http://schemas.microsoft.com/office/drawing/2014/main" id="{187AE87F-1ABD-27E3-3992-B941F3FE1C7D}"/>
+                  <a16:creationId xmlns:a16="http://schemas.microsoft.com/office/drawing/2014/main" id="{1B5AB9D9-E5EF-08FA-1BB8-EE877203138B}"/>
                 </a:ext>
               </a:extLst>
             </p:cNvPr>
@@ -16571,7 +16757,7 @@
             <p:cNvPr id="10" name="TextBox 9">
               <a:extLst>
                 <a:ext uri="{FF2B5EF4-FFF2-40B4-BE49-F238E27FC236}">
-                  <a16:creationId xmlns:a16="http://schemas.microsoft.com/office/drawing/2014/main" id="{4A23CE07-1F21-E78D-7614-43D0FBA69D9B}"/>
+                  <a16:creationId xmlns:a16="http://schemas.microsoft.com/office/drawing/2014/main" id="{808EF9F1-1E34-D18E-7AE0-F813ABB65F04}"/>
                 </a:ext>
               </a:extLst>
             </p:cNvPr>
@@ -16636,7 +16822,7 @@
           <p:cNvPr id="18" name="!!Stage_Sub_Card_1!!">
             <a:extLst>
               <a:ext uri="{FF2B5EF4-FFF2-40B4-BE49-F238E27FC236}">
-                <a16:creationId xmlns:a16="http://schemas.microsoft.com/office/drawing/2014/main" id="{E7FCDD8F-98CE-8D1F-07BD-A821A61033AD}"/>
+                <a16:creationId xmlns:a16="http://schemas.microsoft.com/office/drawing/2014/main" id="{33D58559-5D35-3918-9524-B78BA764AD08}"/>
               </a:ext>
             </a:extLst>
           </p:cNvPr>
@@ -16656,7 +16842,7 @@
             <p:cNvPr id="12" name="Rectangle: Rounded Corners 11">
               <a:extLst>
                 <a:ext uri="{FF2B5EF4-FFF2-40B4-BE49-F238E27FC236}">
-                  <a16:creationId xmlns:a16="http://schemas.microsoft.com/office/drawing/2014/main" id="{D30169B9-0999-5AFC-67BF-61E9D591681C}"/>
+                  <a16:creationId xmlns:a16="http://schemas.microsoft.com/office/drawing/2014/main" id="{2F479C52-0CD5-DD45-367C-9A0B6A8ED57A}"/>
                 </a:ext>
               </a:extLst>
             </p:cNvPr>
@@ -16710,7 +16896,7 @@
             <p:cNvPr id="13" name="Rectangle: Rounded Corners 12">
               <a:extLst>
                 <a:ext uri="{FF2B5EF4-FFF2-40B4-BE49-F238E27FC236}">
-                  <a16:creationId xmlns:a16="http://schemas.microsoft.com/office/drawing/2014/main" id="{DCE5CAE7-BA34-3301-99E5-A894C7037C28}"/>
+                  <a16:creationId xmlns:a16="http://schemas.microsoft.com/office/drawing/2014/main" id="{79DACC87-1F57-3695-7DCA-089ED3552AF8}"/>
                 </a:ext>
               </a:extLst>
             </p:cNvPr>
@@ -16792,7 +16978,7 @@
             <p:cNvPr id="14" name="Oval 13">
               <a:extLst>
                 <a:ext uri="{FF2B5EF4-FFF2-40B4-BE49-F238E27FC236}">
-                  <a16:creationId xmlns:a16="http://schemas.microsoft.com/office/drawing/2014/main" id="{6040C02F-916E-4C29-E316-B831A88C572A}"/>
+                  <a16:creationId xmlns:a16="http://schemas.microsoft.com/office/drawing/2014/main" id="{679CEED4-16FC-EDAB-5AE0-F22593B2BC73}"/>
                 </a:ext>
               </a:extLst>
             </p:cNvPr>
@@ -16860,7 +17046,7 @@
             <p:cNvPr id="16" name="Graphic 15">
               <a:extLst>
                 <a:ext uri="{FF2B5EF4-FFF2-40B4-BE49-F238E27FC236}">
-                  <a16:creationId xmlns:a16="http://schemas.microsoft.com/office/drawing/2014/main" id="{E5954A40-75E2-F923-1638-0CCE07EDE82C}"/>
+                  <a16:creationId xmlns:a16="http://schemas.microsoft.com/office/drawing/2014/main" id="{4663E668-BB53-FB6D-0258-6BB34A01FF05}"/>
                 </a:ext>
               </a:extLst>
             </p:cNvPr>
@@ -16896,7 +17082,7 @@
             <p:cNvPr id="17" name="TextBox 16">
               <a:extLst>
                 <a:ext uri="{FF2B5EF4-FFF2-40B4-BE49-F238E27FC236}">
-                  <a16:creationId xmlns:a16="http://schemas.microsoft.com/office/drawing/2014/main" id="{79DF4B28-E78F-E85F-99D0-30AB566E3931}"/>
+                  <a16:creationId xmlns:a16="http://schemas.microsoft.com/office/drawing/2014/main" id="{A5186A28-FC00-3B11-D818-ED82A27FEB19}"/>
                 </a:ext>
               </a:extLst>
             </p:cNvPr>
@@ -16961,7 +17147,7 @@
           <p:cNvPr id="19" name="!!Anchor_Source_Footer!!">
             <a:extLst>
               <a:ext uri="{FF2B5EF4-FFF2-40B4-BE49-F238E27FC236}">
-                <a16:creationId xmlns:a16="http://schemas.microsoft.com/office/drawing/2014/main" id="{77010DB4-4740-B8E5-CDC8-83AEB52A26AF}"/>
+                <a16:creationId xmlns:a16="http://schemas.microsoft.com/office/drawing/2014/main" id="{53993501-706A-22CB-B9E5-9E33755D601A}"/>
               </a:ext>
             </a:extLst>
           </p:cNvPr>
@@ -17005,7 +17191,7 @@
     </p:spTree>
     <p:extLst>
       <p:ext uri="{BB962C8B-B14F-4D97-AF65-F5344CB8AC3E}">
-        <p14:creationId xmlns:p14="http://schemas.microsoft.com/office/powerpoint/2010/main" val="2865064137"/>
+        <p14:creationId xmlns:p14="http://schemas.microsoft.com/office/powerpoint/2010/main" val="1879664390"/>
       </p:ext>
     </p:extLst>
   </p:cSld>
@@ -17036,9 +17222,6 @@
                     <p:cTn id="3" fill="hold">
                       <p:stCondLst>
                         <p:cond delay="indefinite"/>
-                        <p:cond evt="onBegin" delay="0">
-                          <p:tn val="2"/>
-                        </p:cond>
                       </p:stCondLst>
                       <p:childTnLst>
                         <p:par>
@@ -17048,9 +17231,9 @@
                             </p:stCondLst>
                             <p:childTnLst>
                               <p:par>
-                                <p:cTn id="5" presetID="2" presetClass="entr" presetSubtype="1" accel="50000" decel="50000" fill="hold" nodeType="withEffect">
+                                <p:cTn id="5" presetID="2" presetClass="entr" presetSubtype="1" accel="50000" decel="50000" fill="hold" nodeType="clickEffect">
                                   <p:stCondLst>
-                                    <p:cond delay="180"/>
+                                    <p:cond delay="0"/>
                                   </p:stCondLst>
                                   <p:childTnLst>
                                     <p:set>
@@ -17181,7 +17364,7 @@
           <p:cNvPr id="2" name="!!Anchor_Kicker_Rail!!">
             <a:extLst>
               <a:ext uri="{FF2B5EF4-FFF2-40B4-BE49-F238E27FC236}">
-                <a16:creationId xmlns:a16="http://schemas.microsoft.com/office/drawing/2014/main" id="{19C7C947-AB8F-B608-F992-0604F7116E1F}"/>
+                <a16:creationId xmlns:a16="http://schemas.microsoft.com/office/drawing/2014/main" id="{018D6788-1F60-D91C-4466-F5398C3341BC}"/>
               </a:ext>
             </a:extLst>
           </p:cNvPr>
@@ -17221,7 +17404,7 @@
           <p:cNvPr id="3" name="!!Anchor_Slide_Tracker!!">
             <a:extLst>
               <a:ext uri="{FF2B5EF4-FFF2-40B4-BE49-F238E27FC236}">
-                <a16:creationId xmlns:a16="http://schemas.microsoft.com/office/drawing/2014/main" id="{A00CD1C3-6ACA-7B52-B1BF-D1A58BAC3946}"/>
+                <a16:creationId xmlns:a16="http://schemas.microsoft.com/office/drawing/2014/main" id="{0366ADE0-72DE-95B4-D479-CBD9697CBD90}"/>
               </a:ext>
             </a:extLst>
           </p:cNvPr>
@@ -17262,7 +17445,7 @@
           <p:cNvPr id="4" name="!!Anchor_Assertion_Title!!">
             <a:extLst>
               <a:ext uri="{FF2B5EF4-FFF2-40B4-BE49-F238E27FC236}">
-                <a16:creationId xmlns:a16="http://schemas.microsoft.com/office/drawing/2014/main" id="{33AEB206-4952-A2CF-AAAF-EA40CB62DC3A}"/>
+                <a16:creationId xmlns:a16="http://schemas.microsoft.com/office/drawing/2014/main" id="{882D4F56-9B43-058B-A15B-1093A4920547}"/>
               </a:ext>
             </a:extLst>
           </p:cNvPr>
@@ -17302,7 +17485,7 @@
           <p:cNvPr id="12" name="!!Stage_Hero_Container!!">
             <a:extLst>
               <a:ext uri="{FF2B5EF4-FFF2-40B4-BE49-F238E27FC236}">
-                <a16:creationId xmlns:a16="http://schemas.microsoft.com/office/drawing/2014/main" id="{5B0F7169-E6BF-A30D-F535-4C04DF28CB25}"/>
+                <a16:creationId xmlns:a16="http://schemas.microsoft.com/office/drawing/2014/main" id="{5F48A027-8C77-0126-41E8-41A1486900C0}"/>
               </a:ext>
             </a:extLst>
           </p:cNvPr>
@@ -17322,7 +17505,7 @@
             <p:cNvPr id="6" name="Picture 5">
               <a:extLst>
                 <a:ext uri="{FF2B5EF4-FFF2-40B4-BE49-F238E27FC236}">
-                  <a16:creationId xmlns:a16="http://schemas.microsoft.com/office/drawing/2014/main" id="{13C00E5C-7CEE-73D9-27EF-A6ADD5ED3F69}"/>
+                  <a16:creationId xmlns:a16="http://schemas.microsoft.com/office/drawing/2014/main" id="{BC6B79D0-C686-DEBA-8D8F-9F0A4A018585}"/>
                 </a:ext>
               </a:extLst>
             </p:cNvPr>
@@ -17363,7 +17546,7 @@
             <p:cNvPr id="7" name="Rectangle: Rounded Corners 6">
               <a:extLst>
                 <a:ext uri="{FF2B5EF4-FFF2-40B4-BE49-F238E27FC236}">
-                  <a16:creationId xmlns:a16="http://schemas.microsoft.com/office/drawing/2014/main" id="{8AE8D4C5-C17A-FF6E-D869-16A46CA37FF3}"/>
+                  <a16:creationId xmlns:a16="http://schemas.microsoft.com/office/drawing/2014/main" id="{216780EF-46D7-FC33-7A73-2613B8BF16C9}"/>
                 </a:ext>
               </a:extLst>
             </p:cNvPr>
@@ -17417,7 +17600,7 @@
             <p:cNvPr id="8" name="Oval 7">
               <a:extLst>
                 <a:ext uri="{FF2B5EF4-FFF2-40B4-BE49-F238E27FC236}">
-                  <a16:creationId xmlns:a16="http://schemas.microsoft.com/office/drawing/2014/main" id="{AFB4E245-838F-2B7E-9408-9D0DB094B90A}"/>
+                  <a16:creationId xmlns:a16="http://schemas.microsoft.com/office/drawing/2014/main" id="{058A3984-C3B8-68B7-D3BD-2010D52B9872}"/>
                 </a:ext>
               </a:extLst>
             </p:cNvPr>
@@ -17485,7 +17668,7 @@
             <p:cNvPr id="10" name="Graphic 9">
               <a:extLst>
                 <a:ext uri="{FF2B5EF4-FFF2-40B4-BE49-F238E27FC236}">
-                  <a16:creationId xmlns:a16="http://schemas.microsoft.com/office/drawing/2014/main" id="{628B6A73-0BDF-A667-DDAB-56EE93407298}"/>
+                  <a16:creationId xmlns:a16="http://schemas.microsoft.com/office/drawing/2014/main" id="{1E9B0B46-D795-62B9-8547-F7E08531BCA5}"/>
                 </a:ext>
               </a:extLst>
             </p:cNvPr>
@@ -17521,7 +17704,7 @@
             <p:cNvPr id="11" name="TextBox 10">
               <a:extLst>
                 <a:ext uri="{FF2B5EF4-FFF2-40B4-BE49-F238E27FC236}">
-                  <a16:creationId xmlns:a16="http://schemas.microsoft.com/office/drawing/2014/main" id="{21D2F06A-DA62-0EAE-F3AF-D316E1D3E06A}"/>
+                  <a16:creationId xmlns:a16="http://schemas.microsoft.com/office/drawing/2014/main" id="{AD79434B-25F8-DA60-E834-185E057B637D}"/>
                 </a:ext>
               </a:extLst>
             </p:cNvPr>
@@ -17580,7 +17763,7 @@
           <p:cNvPr id="18" name="!!Stage_Sub_Card_1!!">
             <a:extLst>
               <a:ext uri="{FF2B5EF4-FFF2-40B4-BE49-F238E27FC236}">
-                <a16:creationId xmlns:a16="http://schemas.microsoft.com/office/drawing/2014/main" id="{D1B554A6-9C66-B4CF-12E9-741230CE9208}"/>
+                <a16:creationId xmlns:a16="http://schemas.microsoft.com/office/drawing/2014/main" id="{35598611-41EA-CE2B-547F-2CDE8B5226AB}"/>
               </a:ext>
             </a:extLst>
           </p:cNvPr>
@@ -17600,7 +17783,7 @@
             <p:cNvPr id="13" name="Rectangle: Rounded Corners 12">
               <a:extLst>
                 <a:ext uri="{FF2B5EF4-FFF2-40B4-BE49-F238E27FC236}">
-                  <a16:creationId xmlns:a16="http://schemas.microsoft.com/office/drawing/2014/main" id="{82A2CD51-DEF0-D6B5-B020-49321E5355EA}"/>
+                  <a16:creationId xmlns:a16="http://schemas.microsoft.com/office/drawing/2014/main" id="{A2D12FD5-FA3F-4303-BF86-903749006B3F}"/>
                 </a:ext>
               </a:extLst>
             </p:cNvPr>
@@ -17654,7 +17837,7 @@
             <p:cNvPr id="14" name="Oval 13">
               <a:extLst>
                 <a:ext uri="{FF2B5EF4-FFF2-40B4-BE49-F238E27FC236}">
-                  <a16:creationId xmlns:a16="http://schemas.microsoft.com/office/drawing/2014/main" id="{9262A391-BEDE-3BFB-1E0B-1471726213C8}"/>
+                  <a16:creationId xmlns:a16="http://schemas.microsoft.com/office/drawing/2014/main" id="{B8072E03-A9E0-EC97-D092-9AECF83F4C9A}"/>
                 </a:ext>
               </a:extLst>
             </p:cNvPr>
@@ -17722,7 +17905,7 @@
             <p:cNvPr id="16" name="Graphic 15">
               <a:extLst>
                 <a:ext uri="{FF2B5EF4-FFF2-40B4-BE49-F238E27FC236}">
-                  <a16:creationId xmlns:a16="http://schemas.microsoft.com/office/drawing/2014/main" id="{6CA6CA04-2AFA-B8F1-1F42-79D588C236EE}"/>
+                  <a16:creationId xmlns:a16="http://schemas.microsoft.com/office/drawing/2014/main" id="{E21B1FFD-183E-B4D8-9D85-8D1A334334E6}"/>
                 </a:ext>
               </a:extLst>
             </p:cNvPr>
@@ -17758,7 +17941,7 @@
             <p:cNvPr id="17" name="TextBox 16">
               <a:extLst>
                 <a:ext uri="{FF2B5EF4-FFF2-40B4-BE49-F238E27FC236}">
-                  <a16:creationId xmlns:a16="http://schemas.microsoft.com/office/drawing/2014/main" id="{5F85F714-2D95-0ADC-870F-64221EA7076E}"/>
+                  <a16:creationId xmlns:a16="http://schemas.microsoft.com/office/drawing/2014/main" id="{1DCCA95C-3973-DE1B-2CA6-9F8C93A7B237}"/>
                 </a:ext>
               </a:extLst>
             </p:cNvPr>
@@ -17820,7 +18003,7 @@
           <p:cNvPr id="24" name="!!Stage_Sub_Card_2!!">
             <a:extLst>
               <a:ext uri="{FF2B5EF4-FFF2-40B4-BE49-F238E27FC236}">
-                <a16:creationId xmlns:a16="http://schemas.microsoft.com/office/drawing/2014/main" id="{74F09A31-85CC-932B-BFAE-77D5BCA4DF57}"/>
+                <a16:creationId xmlns:a16="http://schemas.microsoft.com/office/drawing/2014/main" id="{B0950C67-EEEA-1321-D12C-4EC6B76DEEFF}"/>
               </a:ext>
             </a:extLst>
           </p:cNvPr>
@@ -17840,7 +18023,7 @@
             <p:cNvPr id="19" name="Rectangle: Rounded Corners 18">
               <a:extLst>
                 <a:ext uri="{FF2B5EF4-FFF2-40B4-BE49-F238E27FC236}">
-                  <a16:creationId xmlns:a16="http://schemas.microsoft.com/office/drawing/2014/main" id="{8F5A3640-DC11-EE02-BCD6-5271F31C85C4}"/>
+                  <a16:creationId xmlns:a16="http://schemas.microsoft.com/office/drawing/2014/main" id="{715A8443-1CA2-D7B0-9C63-47975F2CAB1A}"/>
                 </a:ext>
               </a:extLst>
             </p:cNvPr>
@@ -17894,7 +18077,7 @@
             <p:cNvPr id="20" name="Oval 19">
               <a:extLst>
                 <a:ext uri="{FF2B5EF4-FFF2-40B4-BE49-F238E27FC236}">
-                  <a16:creationId xmlns:a16="http://schemas.microsoft.com/office/drawing/2014/main" id="{4B27A81A-D61C-688F-0899-D2DB9BB1C4D9}"/>
+                  <a16:creationId xmlns:a16="http://schemas.microsoft.com/office/drawing/2014/main" id="{78CCD28F-DF31-BBD4-A1F8-A558BB6BACB9}"/>
                 </a:ext>
               </a:extLst>
             </p:cNvPr>
@@ -17962,7 +18145,7 @@
             <p:cNvPr id="22" name="Graphic 21">
               <a:extLst>
                 <a:ext uri="{FF2B5EF4-FFF2-40B4-BE49-F238E27FC236}">
-                  <a16:creationId xmlns:a16="http://schemas.microsoft.com/office/drawing/2014/main" id="{5B12E4F8-6981-5077-AC57-F241FA782C14}"/>
+                  <a16:creationId xmlns:a16="http://schemas.microsoft.com/office/drawing/2014/main" id="{8F55EFC9-E7FF-9F2B-D26D-B72F57526AE9}"/>
                 </a:ext>
               </a:extLst>
             </p:cNvPr>
@@ -17998,7 +18181,7 @@
             <p:cNvPr id="23" name="TextBox 22">
               <a:extLst>
                 <a:ext uri="{FF2B5EF4-FFF2-40B4-BE49-F238E27FC236}">
-                  <a16:creationId xmlns:a16="http://schemas.microsoft.com/office/drawing/2014/main" id="{80BACB7A-7643-48B8-8AFF-1CFB7C09F75B}"/>
+                  <a16:creationId xmlns:a16="http://schemas.microsoft.com/office/drawing/2014/main" id="{532565A6-2695-49F6-DAAF-E68D255AD62E}"/>
                 </a:ext>
               </a:extLst>
             </p:cNvPr>
@@ -18060,7 +18243,7 @@
           <p:cNvPr id="30" name="!!Stage_Sub_Card_3!!">
             <a:extLst>
               <a:ext uri="{FF2B5EF4-FFF2-40B4-BE49-F238E27FC236}">
-                <a16:creationId xmlns:a16="http://schemas.microsoft.com/office/drawing/2014/main" id="{A68A8F4E-8D82-CA4F-662B-5C37E8544A28}"/>
+                <a16:creationId xmlns:a16="http://schemas.microsoft.com/office/drawing/2014/main" id="{250EBC56-4D7A-C67E-CB1A-D646153D1D61}"/>
               </a:ext>
             </a:extLst>
           </p:cNvPr>
@@ -18080,7 +18263,7 @@
             <p:cNvPr id="25" name="Rectangle: Rounded Corners 24">
               <a:extLst>
                 <a:ext uri="{FF2B5EF4-FFF2-40B4-BE49-F238E27FC236}">
-                  <a16:creationId xmlns:a16="http://schemas.microsoft.com/office/drawing/2014/main" id="{E1E3D012-4BBF-6CE2-2F22-41E243F09FB3}"/>
+                  <a16:creationId xmlns:a16="http://schemas.microsoft.com/office/drawing/2014/main" id="{40BEF2E5-EE2A-3444-147F-41D72422B264}"/>
                 </a:ext>
               </a:extLst>
             </p:cNvPr>
@@ -18134,7 +18317,7 @@
             <p:cNvPr id="26" name="Oval 25">
               <a:extLst>
                 <a:ext uri="{FF2B5EF4-FFF2-40B4-BE49-F238E27FC236}">
-                  <a16:creationId xmlns:a16="http://schemas.microsoft.com/office/drawing/2014/main" id="{320AB6CA-F8E6-34B1-7605-1ACC566FEEB5}"/>
+                  <a16:creationId xmlns:a16="http://schemas.microsoft.com/office/drawing/2014/main" id="{72BF6DA7-955B-994B-2604-F2BD976A3064}"/>
                 </a:ext>
               </a:extLst>
             </p:cNvPr>
@@ -18202,7 +18385,7 @@
             <p:cNvPr id="28" name="Graphic 27">
               <a:extLst>
                 <a:ext uri="{FF2B5EF4-FFF2-40B4-BE49-F238E27FC236}">
-                  <a16:creationId xmlns:a16="http://schemas.microsoft.com/office/drawing/2014/main" id="{F00415BF-CD11-1EC0-8977-E39C7B632421}"/>
+                  <a16:creationId xmlns:a16="http://schemas.microsoft.com/office/drawing/2014/main" id="{4A9B2EEB-C5D3-0176-9ED9-6B02D76346E4}"/>
                 </a:ext>
               </a:extLst>
             </p:cNvPr>
@@ -18238,7 +18421,7 @@
             <p:cNvPr id="29" name="TextBox 28">
               <a:extLst>
                 <a:ext uri="{FF2B5EF4-FFF2-40B4-BE49-F238E27FC236}">
-                  <a16:creationId xmlns:a16="http://schemas.microsoft.com/office/drawing/2014/main" id="{353D1168-1F6F-FAC6-DF30-5EDF88E094AD}"/>
+                  <a16:creationId xmlns:a16="http://schemas.microsoft.com/office/drawing/2014/main" id="{0EB825F3-22DE-26D7-A9EA-55F99489A593}"/>
                 </a:ext>
               </a:extLst>
             </p:cNvPr>
@@ -18294,7 +18477,7 @@
           <p:cNvPr id="31" name="!!Anchor_Source_Footer!!">
             <a:extLst>
               <a:ext uri="{FF2B5EF4-FFF2-40B4-BE49-F238E27FC236}">
-                <a16:creationId xmlns:a16="http://schemas.microsoft.com/office/drawing/2014/main" id="{1BA3E7FB-9047-1657-7CA2-281DF735D423}"/>
+                <a16:creationId xmlns:a16="http://schemas.microsoft.com/office/drawing/2014/main" id="{F6C2A6C9-455F-E3FE-AE67-6E27D081B41F}"/>
               </a:ext>
             </a:extLst>
           </p:cNvPr>
@@ -18338,7 +18521,7 @@
     </p:spTree>
     <p:extLst>
       <p:ext uri="{BB962C8B-B14F-4D97-AF65-F5344CB8AC3E}">
-        <p14:creationId xmlns:p14="http://schemas.microsoft.com/office/powerpoint/2010/main" val="2600501841"/>
+        <p14:creationId xmlns:p14="http://schemas.microsoft.com/office/powerpoint/2010/main" val="1012954970"/>
       </p:ext>
     </p:extLst>
   </p:cSld>
@@ -18369,9 +18552,6 @@
                     <p:cTn id="3" fill="hold">
                       <p:stCondLst>
                         <p:cond delay="indefinite"/>
-                        <p:cond evt="onBegin" delay="0">
-                          <p:tn val="2"/>
-                        </p:cond>
                       </p:stCondLst>
                       <p:childTnLst>
                         <p:par>
@@ -18381,9 +18561,9 @@
                             </p:stCondLst>
                             <p:childTnLst>
                               <p:par>
-                                <p:cTn id="5" presetID="2" presetClass="entr" presetSubtype="1" accel="50000" decel="50000" fill="hold" nodeType="withEffect">
+                                <p:cTn id="5" presetID="2" presetClass="entr" presetSubtype="1" accel="50000" decel="50000" fill="hold" nodeType="clickEffect">
                                   <p:stCondLst>
-                                    <p:cond delay="120"/>
+                                    <p:cond delay="0"/>
                                   </p:stCondLst>
                                   <p:childTnLst>
                                     <p:set>
@@ -18453,15 +18633,33 @@
                                   </p:childTnLst>
                                 </p:cTn>
                               </p:par>
+                            </p:childTnLst>
+                          </p:cTn>
+                        </p:par>
+                      </p:childTnLst>
+                    </p:cTn>
+                  </p:par>
+                  <p:par>
+                    <p:cTn id="9" fill="hold">
+                      <p:stCondLst>
+                        <p:cond delay="indefinite"/>
+                      </p:stCondLst>
+                      <p:childTnLst>
+                        <p:par>
+                          <p:cTn id="10" fill="hold">
+                            <p:stCondLst>
+                              <p:cond delay="0"/>
+                            </p:stCondLst>
+                            <p:childTnLst>
                               <p:par>
-                                <p:cTn id="9" presetID="2" presetClass="entr" presetSubtype="1" accel="50000" decel="50000" fill="hold" nodeType="withEffect">
+                                <p:cTn id="11" presetID="2" presetClass="entr" presetSubtype="1" accel="50000" decel="50000" fill="hold" nodeType="clickEffect">
                                   <p:stCondLst>
-                                    <p:cond delay="240"/>
+                                    <p:cond delay="0"/>
                                   </p:stCondLst>
                                   <p:childTnLst>
                                     <p:set>
                                       <p:cBhvr>
-                                        <p:cTn id="10" dur="1" fill="hold">
+                                        <p:cTn id="12" dur="1" fill="hold">
                                           <p:stCondLst>
                                             <p:cond delay="0"/>
                                           </p:stCondLst>
@@ -18479,7 +18677,7 @@
                                     </p:set>
                                     <p:anim calcmode="lin" valueType="num">
                                       <p:cBhvr additive="base">
-                                        <p:cTn id="11" dur="500" fill="hold"/>
+                                        <p:cTn id="13" dur="500" fill="hold"/>
                                         <p:tgtEl>
                                           <p:spTgt spid="24"/>
                                         </p:tgtEl>
@@ -18502,7 +18700,7 @@
                                     </p:anim>
                                     <p:anim calcmode="lin" valueType="num">
                                       <p:cBhvr additive="base">
-                                        <p:cTn id="12" dur="500" fill="hold"/>
+                                        <p:cTn id="14" dur="500" fill="hold"/>
                                         <p:tgtEl>
                                           <p:spTgt spid="24"/>
                                         </p:tgtEl>
@@ -18526,15 +18724,33 @@
                                   </p:childTnLst>
                                 </p:cTn>
                               </p:par>
+                            </p:childTnLst>
+                          </p:cTn>
+                        </p:par>
+                      </p:childTnLst>
+                    </p:cTn>
+                  </p:par>
+                  <p:par>
+                    <p:cTn id="15" fill="hold">
+                      <p:stCondLst>
+                        <p:cond delay="indefinite"/>
+                      </p:stCondLst>
+                      <p:childTnLst>
+                        <p:par>
+                          <p:cTn id="16" fill="hold">
+                            <p:stCondLst>
+                              <p:cond delay="0"/>
+                            </p:stCondLst>
+                            <p:childTnLst>
                               <p:par>
-                                <p:cTn id="13" presetID="2" presetClass="entr" presetSubtype="1" accel="50000" decel="50000" fill="hold" nodeType="withEffect">
+                                <p:cTn id="17" presetID="2" presetClass="entr" presetSubtype="1" accel="50000" decel="50000" fill="hold" nodeType="clickEffect">
                                   <p:stCondLst>
-                                    <p:cond delay="360"/>
+                                    <p:cond delay="0"/>
                                   </p:stCondLst>
                                   <p:childTnLst>
                                     <p:set>
                                       <p:cBhvr>
-                                        <p:cTn id="14" dur="1" fill="hold">
+                                        <p:cTn id="18" dur="1" fill="hold">
                                           <p:stCondLst>
                                             <p:cond delay="0"/>
                                           </p:stCondLst>
@@ -18552,7 +18768,7 @@
                                     </p:set>
                                     <p:anim calcmode="lin" valueType="num">
                                       <p:cBhvr additive="base">
-                                        <p:cTn id="15" dur="500" fill="hold"/>
+                                        <p:cTn id="19" dur="500" fill="hold"/>
                                         <p:tgtEl>
                                           <p:spTgt spid="30"/>
                                         </p:tgtEl>
@@ -18575,7 +18791,7 @@
                                     </p:anim>
                                     <p:anim calcmode="lin" valueType="num">
                                       <p:cBhvr additive="base">
-                                        <p:cTn id="16" dur="500" fill="hold"/>
+                                        <p:cTn id="20" dur="500" fill="hold"/>
                                         <p:tgtEl>
                                           <p:spTgt spid="30"/>
                                         </p:tgtEl>
@@ -18660,7 +18876,7 @@
           <p:cNvPr id="2" name="!!Anchor_Kicker_Rail!!">
             <a:extLst>
               <a:ext uri="{FF2B5EF4-FFF2-40B4-BE49-F238E27FC236}">
-                <a16:creationId xmlns:a16="http://schemas.microsoft.com/office/drawing/2014/main" id="{B8222CFE-D05F-B6DE-7AEA-4FB8D694DCD3}"/>
+                <a16:creationId xmlns:a16="http://schemas.microsoft.com/office/drawing/2014/main" id="{59E5C9C7-337D-658B-066E-373EC2C03D96}"/>
               </a:ext>
             </a:extLst>
           </p:cNvPr>
@@ -18706,7 +18922,7 @@
           <p:cNvPr id="3" name="!!Anchor_Slide_Tracker!!">
             <a:extLst>
               <a:ext uri="{FF2B5EF4-FFF2-40B4-BE49-F238E27FC236}">
-                <a16:creationId xmlns:a16="http://schemas.microsoft.com/office/drawing/2014/main" id="{B82DA969-49ED-B15C-8397-72515138F13B}"/>
+                <a16:creationId xmlns:a16="http://schemas.microsoft.com/office/drawing/2014/main" id="{B329A58B-27BB-07AB-4475-4AF850387BC1}"/>
               </a:ext>
             </a:extLst>
           </p:cNvPr>
@@ -18747,7 +18963,7 @@
           <p:cNvPr id="4" name="!!Anchor_Assertion_Title!!">
             <a:extLst>
               <a:ext uri="{FF2B5EF4-FFF2-40B4-BE49-F238E27FC236}">
-                <a16:creationId xmlns:a16="http://schemas.microsoft.com/office/drawing/2014/main" id="{9DA6EBF0-7B53-48C6-B05C-F3E2648A14BD}"/>
+                <a16:creationId xmlns:a16="http://schemas.microsoft.com/office/drawing/2014/main" id="{FE6CB9C8-7700-B12E-C770-AA115C65F1C9}"/>
               </a:ext>
             </a:extLst>
           </p:cNvPr>
@@ -18793,7 +19009,7 @@
           <p:cNvPr id="10" name="!!Stage_Hero_Container!!">
             <a:extLst>
               <a:ext uri="{FF2B5EF4-FFF2-40B4-BE49-F238E27FC236}">
-                <a16:creationId xmlns:a16="http://schemas.microsoft.com/office/drawing/2014/main" id="{42B90316-4ED7-8ACF-BA74-179C08DBE8CB}"/>
+                <a16:creationId xmlns:a16="http://schemas.microsoft.com/office/drawing/2014/main" id="{745EF08C-33CB-D728-8A85-5646DFFFE7B0}"/>
               </a:ext>
             </a:extLst>
           </p:cNvPr>
@@ -18813,7 +19029,7 @@
             <p:cNvPr id="5" name="Rectangle: Rounded Corners 4">
               <a:extLst>
                 <a:ext uri="{FF2B5EF4-FFF2-40B4-BE49-F238E27FC236}">
-                  <a16:creationId xmlns:a16="http://schemas.microsoft.com/office/drawing/2014/main" id="{817C558D-DFE3-74BB-88F9-604F8BE1270D}"/>
+                  <a16:creationId xmlns:a16="http://schemas.microsoft.com/office/drawing/2014/main" id="{5ADC9286-C6C7-A9DC-2DC9-2C3FEDAB43AB}"/>
                 </a:ext>
               </a:extLst>
             </p:cNvPr>
@@ -18867,7 +19083,7 @@
             <p:cNvPr id="6" name="Rectangle 5">
               <a:extLst>
                 <a:ext uri="{FF2B5EF4-FFF2-40B4-BE49-F238E27FC236}">
-                  <a16:creationId xmlns:a16="http://schemas.microsoft.com/office/drawing/2014/main" id="{D0F611FF-8CA3-03BE-1934-5EC37014F43A}"/>
+                  <a16:creationId xmlns:a16="http://schemas.microsoft.com/office/drawing/2014/main" id="{CD6E775D-8E07-FA10-6D1C-AEF05FBF7758}"/>
                 </a:ext>
               </a:extLst>
             </p:cNvPr>
@@ -18943,7 +19159,7 @@
             <p:cNvPr id="8" name="Graphic 7">
               <a:extLst>
                 <a:ext uri="{FF2B5EF4-FFF2-40B4-BE49-F238E27FC236}">
-                  <a16:creationId xmlns:a16="http://schemas.microsoft.com/office/drawing/2014/main" id="{54FF3844-8AB2-CD73-4344-FBC13B0C97A0}"/>
+                  <a16:creationId xmlns:a16="http://schemas.microsoft.com/office/drawing/2014/main" id="{2609C5A4-1719-D064-F7EF-2E4F058C6A12}"/>
                 </a:ext>
               </a:extLst>
             </p:cNvPr>
@@ -18979,7 +19195,7 @@
             <p:cNvPr id="9" name="TextBox 8">
               <a:extLst>
                 <a:ext uri="{FF2B5EF4-FFF2-40B4-BE49-F238E27FC236}">
-                  <a16:creationId xmlns:a16="http://schemas.microsoft.com/office/drawing/2014/main" id="{1A77A8CB-D2A9-CF7D-B03C-4094FB2133CC}"/>
+                  <a16:creationId xmlns:a16="http://schemas.microsoft.com/office/drawing/2014/main" id="{0292644B-FC82-C021-170A-7E9C292EC03B}"/>
                 </a:ext>
               </a:extLst>
             </p:cNvPr>
@@ -19035,7 +19251,7 @@
           <p:cNvPr id="16" name="!!Stage_Sub_Card_1!!">
             <a:extLst>
               <a:ext uri="{FF2B5EF4-FFF2-40B4-BE49-F238E27FC236}">
-                <a16:creationId xmlns:a16="http://schemas.microsoft.com/office/drawing/2014/main" id="{85045AB6-D768-5EDF-4114-747195AD56D1}"/>
+                <a16:creationId xmlns:a16="http://schemas.microsoft.com/office/drawing/2014/main" id="{F06D7737-A980-463C-D062-37D4FB760B19}"/>
               </a:ext>
             </a:extLst>
           </p:cNvPr>
@@ -19055,7 +19271,7 @@
             <p:cNvPr id="11" name="Rectangle: Rounded Corners 10">
               <a:extLst>
                 <a:ext uri="{FF2B5EF4-FFF2-40B4-BE49-F238E27FC236}">
-                  <a16:creationId xmlns:a16="http://schemas.microsoft.com/office/drawing/2014/main" id="{D8FD7CB1-5138-2257-AFA6-794B17EA4955}"/>
+                  <a16:creationId xmlns:a16="http://schemas.microsoft.com/office/drawing/2014/main" id="{7AB890BE-1819-BB84-7179-57F4544ABAB3}"/>
                 </a:ext>
               </a:extLst>
             </p:cNvPr>
@@ -19109,7 +19325,7 @@
             <p:cNvPr id="12" name="Rectangle 11">
               <a:extLst>
                 <a:ext uri="{FF2B5EF4-FFF2-40B4-BE49-F238E27FC236}">
-                  <a16:creationId xmlns:a16="http://schemas.microsoft.com/office/drawing/2014/main" id="{23355080-C30C-A744-267C-F096D0626FA8}"/>
+                  <a16:creationId xmlns:a16="http://schemas.microsoft.com/office/drawing/2014/main" id="{1973830E-3CD1-ECCA-68BE-43C9A42C54D5}"/>
                 </a:ext>
               </a:extLst>
             </p:cNvPr>
@@ -19185,7 +19401,7 @@
             <p:cNvPr id="14" name="Graphic 13">
               <a:extLst>
                 <a:ext uri="{FF2B5EF4-FFF2-40B4-BE49-F238E27FC236}">
-                  <a16:creationId xmlns:a16="http://schemas.microsoft.com/office/drawing/2014/main" id="{653EFC79-3E5A-1CE5-207A-0CDD752B26F5}"/>
+                  <a16:creationId xmlns:a16="http://schemas.microsoft.com/office/drawing/2014/main" id="{E8F00102-42B1-1D01-0EAD-F691F86EAB52}"/>
                 </a:ext>
               </a:extLst>
             </p:cNvPr>
@@ -19221,7 +19437,7 @@
             <p:cNvPr id="15" name="TextBox 14">
               <a:extLst>
                 <a:ext uri="{FF2B5EF4-FFF2-40B4-BE49-F238E27FC236}">
-                  <a16:creationId xmlns:a16="http://schemas.microsoft.com/office/drawing/2014/main" id="{73884DE7-9552-06A4-D1B0-437F23164EC1}"/>
+                  <a16:creationId xmlns:a16="http://schemas.microsoft.com/office/drawing/2014/main" id="{54844965-D2D8-2B99-3C01-B36C38BCFEE3}"/>
                 </a:ext>
               </a:extLst>
             </p:cNvPr>
@@ -19283,7 +19499,7 @@
           <p:cNvPr id="22" name="!!Stage_Sub_Card_2!!">
             <a:extLst>
               <a:ext uri="{FF2B5EF4-FFF2-40B4-BE49-F238E27FC236}">
-                <a16:creationId xmlns:a16="http://schemas.microsoft.com/office/drawing/2014/main" id="{A067E3BB-F6BE-9802-7694-21808C23F9B3}"/>
+                <a16:creationId xmlns:a16="http://schemas.microsoft.com/office/drawing/2014/main" id="{A119965D-0519-4D6F-D875-4280465196F1}"/>
               </a:ext>
             </a:extLst>
           </p:cNvPr>
@@ -19303,7 +19519,7 @@
             <p:cNvPr id="17" name="Rectangle: Rounded Corners 16">
               <a:extLst>
                 <a:ext uri="{FF2B5EF4-FFF2-40B4-BE49-F238E27FC236}">
-                  <a16:creationId xmlns:a16="http://schemas.microsoft.com/office/drawing/2014/main" id="{6384908B-F1FA-8C01-1A62-B4603F65F509}"/>
+                  <a16:creationId xmlns:a16="http://schemas.microsoft.com/office/drawing/2014/main" id="{E1F648F3-6DD6-D2E4-EA24-A67B5E725EDC}"/>
                 </a:ext>
               </a:extLst>
             </p:cNvPr>
@@ -19357,7 +19573,7 @@
             <p:cNvPr id="18" name="Rectangle 17">
               <a:extLst>
                 <a:ext uri="{FF2B5EF4-FFF2-40B4-BE49-F238E27FC236}">
-                  <a16:creationId xmlns:a16="http://schemas.microsoft.com/office/drawing/2014/main" id="{B12F1B58-B75E-5588-66B6-91588E652911}"/>
+                  <a16:creationId xmlns:a16="http://schemas.microsoft.com/office/drawing/2014/main" id="{3FFA315E-F1A2-5054-99D2-DF467AC94FA1}"/>
                 </a:ext>
               </a:extLst>
             </p:cNvPr>
@@ -19433,7 +19649,7 @@
             <p:cNvPr id="20" name="Graphic 19">
               <a:extLst>
                 <a:ext uri="{FF2B5EF4-FFF2-40B4-BE49-F238E27FC236}">
-                  <a16:creationId xmlns:a16="http://schemas.microsoft.com/office/drawing/2014/main" id="{FAABC718-B75B-2F0A-E638-6DD0C2AE5EBE}"/>
+                  <a16:creationId xmlns:a16="http://schemas.microsoft.com/office/drawing/2014/main" id="{618B9178-38DA-5703-AFA6-7824FD67BC2E}"/>
                 </a:ext>
               </a:extLst>
             </p:cNvPr>
@@ -19469,7 +19685,7 @@
             <p:cNvPr id="21" name="TextBox 20">
               <a:extLst>
                 <a:ext uri="{FF2B5EF4-FFF2-40B4-BE49-F238E27FC236}">
-                  <a16:creationId xmlns:a16="http://schemas.microsoft.com/office/drawing/2014/main" id="{40478829-AFF0-0AF2-F3BE-AAC4574450A2}"/>
+                  <a16:creationId xmlns:a16="http://schemas.microsoft.com/office/drawing/2014/main" id="{10E6EFFB-1787-BA5B-2AD8-5E86FCC37CB0}"/>
                 </a:ext>
               </a:extLst>
             </p:cNvPr>
@@ -19531,7 +19747,7 @@
           <p:cNvPr id="28" name="!!Stage_Sub_Card_3!!">
             <a:extLst>
               <a:ext uri="{FF2B5EF4-FFF2-40B4-BE49-F238E27FC236}">
-                <a16:creationId xmlns:a16="http://schemas.microsoft.com/office/drawing/2014/main" id="{9A2E8C54-2018-23D9-1B8A-9DFBE3D25773}"/>
+                <a16:creationId xmlns:a16="http://schemas.microsoft.com/office/drawing/2014/main" id="{2791C861-18DE-1128-DA4C-2C8B00B3C8DF}"/>
               </a:ext>
             </a:extLst>
           </p:cNvPr>
@@ -19551,7 +19767,7 @@
             <p:cNvPr id="23" name="Rectangle: Rounded Corners 22">
               <a:extLst>
                 <a:ext uri="{FF2B5EF4-FFF2-40B4-BE49-F238E27FC236}">
-                  <a16:creationId xmlns:a16="http://schemas.microsoft.com/office/drawing/2014/main" id="{1F92805B-AD8E-9DCE-FE4E-05767D9BEA27}"/>
+                  <a16:creationId xmlns:a16="http://schemas.microsoft.com/office/drawing/2014/main" id="{8C4A662F-E6DB-2D4F-92FA-BF851683E44D}"/>
                 </a:ext>
               </a:extLst>
             </p:cNvPr>
@@ -19605,7 +19821,7 @@
             <p:cNvPr id="24" name="Rectangle 23">
               <a:extLst>
                 <a:ext uri="{FF2B5EF4-FFF2-40B4-BE49-F238E27FC236}">
-                  <a16:creationId xmlns:a16="http://schemas.microsoft.com/office/drawing/2014/main" id="{AC6A77CC-9149-4176-0305-3705DC2C24C9}"/>
+                  <a16:creationId xmlns:a16="http://schemas.microsoft.com/office/drawing/2014/main" id="{E47771F6-A4B9-D420-B527-5AE4CCACFE39}"/>
                 </a:ext>
               </a:extLst>
             </p:cNvPr>
@@ -19681,7 +19897,7 @@
             <p:cNvPr id="26" name="Graphic 25">
               <a:extLst>
                 <a:ext uri="{FF2B5EF4-FFF2-40B4-BE49-F238E27FC236}">
-                  <a16:creationId xmlns:a16="http://schemas.microsoft.com/office/drawing/2014/main" id="{D60B2E49-1911-63FA-F6AF-9FCDE8E357BD}"/>
+                  <a16:creationId xmlns:a16="http://schemas.microsoft.com/office/drawing/2014/main" id="{A84162CF-AC13-F2EC-BEDB-F3FB628674F2}"/>
                 </a:ext>
               </a:extLst>
             </p:cNvPr>
@@ -19717,7 +19933,7 @@
             <p:cNvPr id="27" name="TextBox 26">
               <a:extLst>
                 <a:ext uri="{FF2B5EF4-FFF2-40B4-BE49-F238E27FC236}">
-                  <a16:creationId xmlns:a16="http://schemas.microsoft.com/office/drawing/2014/main" id="{8DCCB896-9149-A173-24F5-AECD08688EEE}"/>
+                  <a16:creationId xmlns:a16="http://schemas.microsoft.com/office/drawing/2014/main" id="{E7083F81-B618-FA6A-240E-BC4EFE1C7EDC}"/>
                 </a:ext>
               </a:extLst>
             </p:cNvPr>
@@ -19779,7 +19995,7 @@
           <p:cNvPr id="29" name="!!Anchor_Source_Footer!!">
             <a:extLst>
               <a:ext uri="{FF2B5EF4-FFF2-40B4-BE49-F238E27FC236}">
-                <a16:creationId xmlns:a16="http://schemas.microsoft.com/office/drawing/2014/main" id="{223A4509-87D9-E3C0-91D8-A22890E6F943}"/>
+                <a16:creationId xmlns:a16="http://schemas.microsoft.com/office/drawing/2014/main" id="{36FB3EB9-FF7A-BD28-822B-CD97339B268F}"/>
               </a:ext>
             </a:extLst>
           </p:cNvPr>
@@ -19823,7 +20039,7 @@
     </p:spTree>
     <p:extLst>
       <p:ext uri="{BB962C8B-B14F-4D97-AF65-F5344CB8AC3E}">
-        <p14:creationId xmlns:p14="http://schemas.microsoft.com/office/powerpoint/2010/main" val="321785778"/>
+        <p14:creationId xmlns:p14="http://schemas.microsoft.com/office/powerpoint/2010/main" val="1750035194"/>
       </p:ext>
     </p:extLst>
   </p:cSld>
@@ -19854,9 +20070,6 @@
                     <p:cTn id="3" fill="hold">
                       <p:stCondLst>
                         <p:cond delay="indefinite"/>
-                        <p:cond evt="onBegin" delay="0">
-                          <p:tn val="2"/>
-                        </p:cond>
                       </p:stCondLst>
                       <p:childTnLst>
                         <p:par>
@@ -19866,9 +20079,9 @@
                             </p:stCondLst>
                             <p:childTnLst>
                               <p:par>
-                                <p:cTn id="5" presetID="2" presetClass="entr" presetSubtype="1" accel="50000" decel="50000" fill="hold" nodeType="withEffect">
+                                <p:cTn id="5" presetID="2" presetClass="entr" presetSubtype="1" accel="50000" decel="50000" fill="hold" nodeType="clickEffect">
                                   <p:stCondLst>
-                                    <p:cond delay="120"/>
+                                    <p:cond delay="0"/>
                                   </p:stCondLst>
                                   <p:childTnLst>
                                     <p:set>
@@ -19938,15 +20151,33 @@
                                   </p:childTnLst>
                                 </p:cTn>
                               </p:par>
+                            </p:childTnLst>
+                          </p:cTn>
+                        </p:par>
+                      </p:childTnLst>
+                    </p:cTn>
+                  </p:par>
+                  <p:par>
+                    <p:cTn id="9" fill="hold">
+                      <p:stCondLst>
+                        <p:cond delay="indefinite"/>
+                      </p:stCondLst>
+                      <p:childTnLst>
+                        <p:par>
+                          <p:cTn id="10" fill="hold">
+                            <p:stCondLst>
+                              <p:cond delay="0"/>
+                            </p:stCondLst>
+                            <p:childTnLst>
                               <p:par>
-                                <p:cTn id="9" presetID="2" presetClass="entr" presetSubtype="1" accel="50000" decel="50000" fill="hold" nodeType="withEffect">
+                                <p:cTn id="11" presetID="2" presetClass="entr" presetSubtype="1" accel="50000" decel="50000" fill="hold" nodeType="clickEffect">
                                   <p:stCondLst>
-                                    <p:cond delay="240"/>
+                                    <p:cond delay="0"/>
                                   </p:stCondLst>
                                   <p:childTnLst>
                                     <p:set>
                                       <p:cBhvr>
-                                        <p:cTn id="10" dur="1" fill="hold">
+                                        <p:cTn id="12" dur="1" fill="hold">
                                           <p:stCondLst>
                                             <p:cond delay="0"/>
                                           </p:stCondLst>
@@ -19964,7 +20195,7 @@
                                     </p:set>
                                     <p:anim calcmode="lin" valueType="num">
                                       <p:cBhvr additive="base">
-                                        <p:cTn id="11" dur="500" fill="hold"/>
+                                        <p:cTn id="13" dur="500" fill="hold"/>
                                         <p:tgtEl>
                                           <p:spTgt spid="22"/>
                                         </p:tgtEl>
@@ -19987,7 +20218,7 @@
                                     </p:anim>
                                     <p:anim calcmode="lin" valueType="num">
                                       <p:cBhvr additive="base">
-                                        <p:cTn id="12" dur="500" fill="hold"/>
+                                        <p:cTn id="14" dur="500" fill="hold"/>
                                         <p:tgtEl>
                                           <p:spTgt spid="22"/>
                                         </p:tgtEl>
@@ -20011,15 +20242,33 @@
                                   </p:childTnLst>
                                 </p:cTn>
                               </p:par>
+                            </p:childTnLst>
+                          </p:cTn>
+                        </p:par>
+                      </p:childTnLst>
+                    </p:cTn>
+                  </p:par>
+                  <p:par>
+                    <p:cTn id="15" fill="hold">
+                      <p:stCondLst>
+                        <p:cond delay="indefinite"/>
+                      </p:stCondLst>
+                      <p:childTnLst>
+                        <p:par>
+                          <p:cTn id="16" fill="hold">
+                            <p:stCondLst>
+                              <p:cond delay="0"/>
+                            </p:stCondLst>
+                            <p:childTnLst>
                               <p:par>
-                                <p:cTn id="13" presetID="2" presetClass="entr" presetSubtype="1" accel="50000" decel="50000" fill="hold" nodeType="withEffect">
+                                <p:cTn id="17" presetID="2" presetClass="entr" presetSubtype="1" accel="50000" decel="50000" fill="hold" nodeType="clickEffect">
                                   <p:stCondLst>
-                                    <p:cond delay="360"/>
+                                    <p:cond delay="0"/>
                                   </p:stCondLst>
                                   <p:childTnLst>
                                     <p:set>
                                       <p:cBhvr>
-                                        <p:cTn id="14" dur="1" fill="hold">
+                                        <p:cTn id="18" dur="1" fill="hold">
                                           <p:stCondLst>
                                             <p:cond delay="0"/>
                                           </p:stCondLst>
@@ -20037,7 +20286,7 @@
                                     </p:set>
                                     <p:anim calcmode="lin" valueType="num">
                                       <p:cBhvr additive="base">
-                                        <p:cTn id="15" dur="500" fill="hold"/>
+                                        <p:cTn id="19" dur="500" fill="hold"/>
                                         <p:tgtEl>
                                           <p:spTgt spid="28"/>
                                         </p:tgtEl>
@@ -20060,7 +20309,7 @@
                                     </p:anim>
                                     <p:anim calcmode="lin" valueType="num">
                                       <p:cBhvr additive="base">
-                                        <p:cTn id="16" dur="500" fill="hold"/>
+                                        <p:cTn id="20" dur="500" fill="hold"/>
                                         <p:tgtEl>
                                           <p:spTgt spid="28"/>
                                         </p:tgtEl>

</xml_diff>